<commit_message>
Board summary: split deposit-only customers in holding chart
Co-Authored-By: Claude Opus 5.5 <noreply@anthropic.com>
Claude-Session: https://claude.ai/code/session_01PMn7aLX79upLSj9P26uPyP
</commit_message>
<xml_diff>
--- a/clicx_insights/CLICX_Board_Summary.pptx
+++ b/clicx_insights/CLICX_Board_Summary.pptx
@@ -108,7 +108,7 @@
   <p:extLst>
     <p:ext uri="{521415D9-36F7-43E2-AB2F-B90AF26B5E84}">
       <p14:sectionLst xmlns:p14="http://schemas.microsoft.com/office/powerpoint/2010/main">
-        <p14:section name="Board summary" id="{84c0f023-3225-cd71-c2ea-e15fa48a9885}">
+        <p14:section name="Board summary" id="{463ce379-09d9-9941-5a66-fe3f11893ccb}">
           <p14:sldIdLst>
             <p14:sldId id="256"/>
             <p14:sldId id="257"/>
@@ -226,7 +226,7 @@
             <c:bubble3D val="0"/>
             <c:spPr>
               <a:solidFill>
-                <a:srgbClr val="051C2C"/>
+                <a:srgbClr val="00A9F4"/>
               </a:solidFill>
               <a:effectLst/>
             </c:spPr>
@@ -237,7 +237,7 @@
             <c:bubble3D val="0"/>
             <c:spPr>
               <a:solidFill>
-                <a:srgbClr val="051C2C"/>
+                <a:srgbClr val="00A9F4"/>
               </a:solidFill>
               <a:effectLst/>
             </c:spPr>
@@ -248,7 +248,7 @@
             <c:bubble3D val="0"/>
             <c:spPr>
               <a:solidFill>
-                <a:srgbClr val="2251FF"/>
+                <a:srgbClr val="051C2C"/>
               </a:solidFill>
               <a:effectLst/>
             </c:spPr>
@@ -270,6 +270,28 @@
             <c:bubble3D val="0"/>
             <c:spPr>
               <a:solidFill>
+                <a:srgbClr val="2251FF"/>
+              </a:solidFill>
+              <a:effectLst/>
+            </c:spPr>
+          </c:dPt>
+          <c:dPt>
+            <c:idx val="6"/>
+            <c:invertIfNegative val="0"/>
+            <c:bubble3D val="0"/>
+            <c:spPr>
+              <a:solidFill>
+                <a:srgbClr val="051C2C"/>
+              </a:solidFill>
+              <a:effectLst/>
+            </c:spPr>
+          </c:dPt>
+          <c:dPt>
+            <c:idx val="7"/>
+            <c:invertIfNegative val="0"/>
+            <c:bubble3D val="0"/>
+            <c:spPr>
+              <a:solidFill>
                 <a:srgbClr val="051C2C"/>
               </a:solidFill>
               <a:effectLst/>
@@ -277,26 +299,32 @@
           </c:dPt>
           <c:cat>
             <c:multiLvlStrRef>
-              <c:f>Sheet1!$A$2:$A$7</c:f>
+              <c:f>Sheet1!$A$2:$A$9</c:f>
               <c:multiLvlStrCache>
-                <c:ptCount val="6"/>
+                <c:ptCount val="8"/>
                 <c:lvl>
                   <c:pt idx="0">
-                    <c:v>Uses nothing yet</c:v>
+                    <c:v>Zero balance, no use</c:v>
                   </c:pt>
                   <c:pt idx="1">
+                    <c:v>Money only, under 1K</c:v>
+                  </c:pt>
+                  <c:pt idx="2">
+                    <c:v>Money only, 1K–20K</c:v>
+                  </c:pt>
+                  <c:pt idx="3">
                     <c:v>Borrows only</c:v>
                   </c:pt>
-                  <c:pt idx="2">
+                  <c:pt idx="4">
                     <c:v>Pays only</c:v>
                   </c:pt>
-                  <c:pt idx="3">
+                  <c:pt idx="5">
                     <c:v>Borrows and pays</c:v>
                   </c:pt>
-                  <c:pt idx="4">
+                  <c:pt idx="6">
                     <c:v>Saves only (20K+)</c:v>
                   </c:pt>
-                  <c:pt idx="5">
+                  <c:pt idx="7">
                     <c:v>Saves and more</c:v>
                   </c:pt>
                 </c:lvl>
@@ -305,26 +333,32 @@
           </c:cat>
           <c:val>
             <c:numRef>
-              <c:f>Sheet1!$B$2:$B$7</c:f>
+              <c:f>Sheet1!$B$2:$B$9</c:f>
               <c:numCache>
                 <c:formatCode>General</c:formatCode>
-                <c:ptCount val="6"/>
+                <c:ptCount val="8"/>
                 <c:pt idx="0">
-                  <c:v>1248</c:v>
+                  <c:v>1058</c:v>
                 </c:pt>
                 <c:pt idx="1">
+                  <c:v>166</c:v>
+                </c:pt>
+                <c:pt idx="2">
+                  <c:v>20</c:v>
+                </c:pt>
+                <c:pt idx="3">
                   <c:v>117</c:v>
                 </c:pt>
-                <c:pt idx="2">
+                <c:pt idx="4">
                   <c:v>66</c:v>
                 </c:pt>
-                <c:pt idx="3">
+                <c:pt idx="5">
                   <c:v>47</c:v>
                 </c:pt>
-                <c:pt idx="4">
-                  <c:v>19</c:v>
+                <c:pt idx="6">
+                  <c:v>22</c:v>
                 </c:pt>
-                <c:pt idx="5">
+                <c:pt idx="7">
                   <c:v>5</c:v>
                 </c:pt>
               </c:numCache>
@@ -355,7 +389,7 @@
           <c:showBubbleSize val="0"/>
           <c:showLeaderLines val="0"/>
         </c:dLbls>
-        <c:gapWidth val="40"/>
+        <c:gapWidth val="35"/>
         <c:overlap val="0"/>
         <c:axId val="2094734554"/>
         <c:axId val="2094734552"/>
@@ -406,7 +440,7 @@
         <c:axId val="2094734552"/>
         <c:scaling>
           <c:orientation val="minMax"/>
-          <c:max val="1600"/>
+          <c:max val="1400"/>
         </c:scaling>
         <c:delete val="1"/>
         <c:axPos val="b"/>

</xml_diff>

<commit_message>
Board summary: add slide on how money in, loans and payments connect
Co-Authored-By: Claude Opus 5.5 <noreply@anthropic.com>
Claude-Session: https://claude.ai/code/session_01PMn7aLX79upLSj9P26uPyP
</commit_message>
<xml_diff>
--- a/clicx_insights/CLICX_Board_Summary.pptx
+++ b/clicx_insights/CLICX_Board_Summary.pptx
@@ -7,9 +7,10 @@
   <p:sldIdLst>
     <p:sldId id="256" r:id="rId2"/>
     <p:sldId id="257" r:id="rId3"/>
+    <p:sldId id="258" r:id="rId4"/>
   </p:sldIdLst>
   <p:notesMasterIdLst>
-    <p:notesMasterId r:id="rId4"/>
+    <p:notesMasterId r:id="rId5"/>
   </p:notesMasterIdLst>
   <p:sldSz cx="12192000" cy="6858000"/>
   <p:notesSz cx="6858000" cy="12192000"/>
@@ -108,10 +109,11 @@
   <p:extLst>
     <p:ext uri="{521415D9-36F7-43E2-AB2F-B90AF26B5E84}">
       <p14:sectionLst xmlns:p14="http://schemas.microsoft.com/office/powerpoint/2010/main">
-        <p14:section name="Board summary" id="{463ce379-09d9-9941-5a66-fe3f11893ccb}">
+        <p14:section name="Board summary" id="{3784c5e3-906a-1d39-0ce8-7d7949f8a356}">
           <p14:sldIdLst>
             <p14:sldId id="256"/>
             <p14:sldId id="257"/>
+            <p14:sldId id="258"/>
           </p14:sldIdLst>
         </p14:section>
       </p14:sectionLst>
@@ -1535,6 +1537,94 @@
             <a:fld id="{F7021451-1387-4CA6-816F-3879F97B5CBC}" type="slidenum">
               <a:rPr lang="en-US"/>
               <a:t>2</a:t>
+            </a:fld>
+            <a:endParaRPr lang="en-US"/>
+          </a:p>
+        </p:txBody>
+      </p:sp>
+    </p:spTree>
+    <p:extLst>
+      <p:ext uri="{BB962C8B-B14F-4D97-AF65-F5344CB8AC3E}">
+        <p14:creationId xmlns:p14="http://schemas.microsoft.com/office/powerpoint/2010/main" val="1024086991"/>
+      </p:ext>
+    </p:extLst>
+  </p:cSld>
+  <p:clrMapOvr>
+    <a:masterClrMapping/>
+  </p:clrMapOvr>
+</p:notes>
+</file>
+
+<file path=ppt/notesSlides/notesSlide3.xml><?xml version="1.0" encoding="utf-8"?>
+<p:notes xmlns:a="http://schemas.openxmlformats.org/drawingml/2006/main" xmlns:r="http://schemas.openxmlformats.org/officeDocument/2006/relationships" xmlns:p="http://schemas.openxmlformats.org/presentationml/2006/main">
+  <p:cSld>
+    <p:spTree>
+      <p:nvGrpSpPr>
+        <p:cNvPr id="1" name=""/>
+        <p:cNvGrpSpPr/>
+        <p:nvPr/>
+      </p:nvGrpSpPr>
+      <p:grpSpPr>
+        <a:xfrm>
+          <a:off x="0" y="0"/>
+          <a:ext cx="0" cy="0"/>
+          <a:chOff x="0" y="0"/>
+          <a:chExt cx="0" cy="0"/>
+        </a:xfrm>
+      </p:grpSpPr>
+      <p:sp>
+        <p:nvSpPr>
+          <p:cNvPr id="2" name="Slide Image Placeholder 1"/>
+          <p:cNvSpPr>
+            <a:spLocks noGrp="1" noRot="1" noChangeAspect="1"/>
+          </p:cNvSpPr>
+          <p:nvPr>
+            <p:ph type="sldImg"/>
+          </p:nvPr>
+        </p:nvSpPr>
+        <p:spPr/>
+      </p:sp>
+      <p:sp>
+        <p:nvSpPr>
+          <p:cNvPr id="3" name="Notes Placeholder 2"/>
+          <p:cNvSpPr>
+            <a:spLocks noGrp="1"/>
+          </p:cNvSpPr>
+          <p:nvPr>
+            <p:ph type="body" idx="1"/>
+          </p:nvPr>
+        </p:nvSpPr>
+        <p:spPr/>
+        <p:txBody>
+          <a:bodyPr/>
+          <a:lstStyle/>
+          <a:p>
+            <a:r>
+              <a:rPr lang="en-US" dirty="0"/>
+              <a:t/>
+            </a:r>
+            <a:endParaRPr lang="en-US" dirty="0"/>
+          </a:p>
+        </p:txBody>
+      </p:sp>
+      <p:sp>
+        <p:nvSpPr>
+          <p:cNvPr id="4" name="Slide Number Placeholder 3"/>
+          <p:cNvSpPr>
+            <a:spLocks noGrp="1"/>
+          </p:cNvSpPr>
+          <p:nvPr>
+            <p:ph type="sldNum" sz="quarter" idx="10"/>
+          </p:nvPr>
+        </p:nvSpPr>
+        <p:spPr/>
+        <p:txBody>
+          <a:bodyPr/>
+          <a:lstStyle/>
+          <a:p>
+            <a:fld id="{F7021451-1387-4CA6-816F-3879F97B5CBC}" type="slidenum">
+              <a:rPr lang="en-US"/>
+              <a:t>3</a:t>
             </a:fld>
             <a:endParaRPr lang="en-US"/>
           </a:p>
@@ -2425,7 +2515,7 @@
                   <a:schemeClr val="accent1"/>
                 </a:solidFill>
               </a:rPr>
-              <a:t>BOARD SUMMARY  (1/2)  |  WHAT EXISTING CUSTOMERS DO</a:t>
+              <a:t>BOARD SUMMARY  (1/3)  |  WHAT EXISTING CUSTOMERS DO</a:t>
             </a:r>
             <a:endParaRPr lang="en-US" sz="1100" dirty="0"/>
           </a:p>
@@ -3249,7 +3339,2801 @@
                   <a:schemeClr val="accent1"/>
                 </a:solidFill>
               </a:rPr>
-              <a:t>BOARD SUMMARY  (2/2)  |  WHAT WE WILL DO</a:t>
+              <a:t>BOARD SUMMARY  (2/3)  |  HOW PRODUCTS CONNECT</a:t>
+            </a:r>
+            <a:endParaRPr lang="en-US" sz="1100" dirty="0"/>
+          </a:p>
+        </p:txBody>
+      </p:sp>
+      <p:sp>
+        <p:nvSpPr>
+          <p:cNvPr id="3" name="Text 0"/>
+          <p:cNvSpPr/>
+          <p:nvPr>
+            <p:ph idx="101" type="title" hasCustomPrompt="1"/>
+          </p:nvPr>
+        </p:nvSpPr>
+        <p:spPr>
+          <a:xfrm>
+            <a:off x="457200" y="566928"/>
+            <a:ext cx="11274552" cy="822960"/>
+          </a:xfrm>
+          <a:prstGeom prst="rect">
+            <a:avLst/>
+          </a:prstGeom>
+          <a:noFill/>
+          <a:ln/>
+        </p:spPr>
+        <p:txBody>
+          <a:bodyPr wrap="square" lIns="0" tIns="0" rIns="0" bIns="0" rtlCol="0" anchor="t"/>
+          <a:lstStyle/>
+          <a:p>
+            <a:pPr algn="l" indent="0" marL="0">
+              <a:buNone/>
+            </a:pPr>
+            <a:r>
+              <a:rPr lang="en-US" sz="2400" b="1" dirty="0">
+                <a:solidFill>
+                  <a:schemeClr val="tx2"/>
+                </a:solidFill>
+              </a:rPr>
+              <a:t>How are money in, loans and payments connected?</a:t>
+            </a:r>
+            <a:endParaRPr lang="en-US" sz="2400" dirty="0"/>
+          </a:p>
+        </p:txBody>
+      </p:sp>
+      <p:sp>
+        <p:nvSpPr>
+          <p:cNvPr id="4" name="Text 0"/>
+          <p:cNvSpPr/>
+          <p:nvPr>
+            <p:ph idx="102" type="body" hasCustomPrompt="1"/>
+          </p:nvPr>
+        </p:nvSpPr>
+        <p:spPr>
+          <a:xfrm>
+            <a:off x="457200" y="1481328"/>
+            <a:ext cx="11274552" cy="594360"/>
+          </a:xfrm>
+          <a:prstGeom prst="rect">
+            <a:avLst/>
+          </a:prstGeom>
+          <a:noFill/>
+          <a:ln/>
+        </p:spPr>
+        <p:txBody>
+          <a:bodyPr wrap="square" lIns="0" tIns="0" rIns="0" bIns="0" rtlCol="0" anchor="t"/>
+          <a:lstStyle/>
+          <a:p>
+            <a:pPr indent="0" marL="0">
+              <a:buNone/>
+            </a:pPr>
+            <a:r>
+              <a:rPr lang="en-US" sz="1600" dirty="0">
+                <a:solidFill>
+                  <a:schemeClr val="tx1"/>
+                </a:solidFill>
+              </a:rPr>
+              <a:t>Tightly: a customer who has any one of them is 2.5–3.7x more likely to have the other two. But only 35% of accounts ever get money in, so most customers never start the chain</a:t>
+            </a:r>
+            <a:endParaRPr lang="en-US" sz="1600" dirty="0"/>
+          </a:p>
+        </p:txBody>
+      </p:sp>
+      <p:sp>
+        <p:nvSpPr>
+          <p:cNvPr id="5" name="Text 0"/>
+          <p:cNvSpPr/>
+          <p:nvPr>
+            <p:ph idx="103" type="body" hasCustomPrompt="1"/>
+          </p:nvPr>
+        </p:nvSpPr>
+        <p:spPr>
+          <a:xfrm>
+            <a:off x="457200" y="6327648"/>
+            <a:ext cx="10241280" cy="274320"/>
+          </a:xfrm>
+          <a:prstGeom prst="rect">
+            <a:avLst/>
+          </a:prstGeom>
+          <a:noFill/>
+          <a:ln/>
+        </p:spPr>
+        <p:txBody>
+          <a:bodyPr wrap="square" lIns="0" tIns="0" rIns="0" bIns="0" rtlCol="0" anchor="t"/>
+          <a:lstStyle/>
+          <a:p>
+            <a:pPr indent="0" marL="0">
+              <a:buNone/>
+            </a:pPr>
+            <a:r>
+              <a:rPr lang="en-US" sz="1000" dirty="0">
+                <a:solidFill>
+                  <a:srgbClr val="6E7C87"/>
+                </a:solidFill>
+              </a:rPr>
+              <a:t>x = times more likely than the average customer. Ladder % = share of the step before. Source: CLICX product and payment segments, 1 Oct 2026 (1.50M accounts); registration funnel from CLICX 5-Year Business Plan</a:t>
+            </a:r>
+            <a:endParaRPr lang="en-US" sz="1000" dirty="0"/>
+          </a:p>
+        </p:txBody>
+      </p:sp>
+      <p:sp>
+        <p:nvSpPr>
+          <p:cNvPr id="6" name="Matrix title"/>
+          <p:cNvSpPr txBox="1"/>
+          <p:nvPr/>
+        </p:nvSpPr>
+        <p:spPr>
+          <a:xfrm>
+            <a:off x="457200" y="2194560"/>
+            <a:ext cx="4114800" cy="292608"/>
+          </a:xfrm>
+          <a:prstGeom prst="rect">
+            <a:avLst/>
+          </a:prstGeom>
+          <a:noFill/>
+          <a:ln/>
+        </p:spPr>
+        <p:txBody>
+          <a:bodyPr wrap="square" lIns="0" tIns="0" rIns="0" bIns="0" rtlCol="0" anchor="ctr"/>
+          <a:lstStyle/>
+          <a:p>
+            <a:pPr indent="0" marL="0">
+              <a:buNone/>
+            </a:pPr>
+            <a:r>
+              <a:rPr lang="en-US" sz="1300" b="1" dirty="0">
+                <a:solidFill>
+                  <a:schemeClr val="tx2"/>
+                </a:solidFill>
+              </a:rPr>
+              <a:t>Has one product: how likely are the others?</a:t>
+            </a:r>
+            <a:endParaRPr lang="en-US" sz="1300" dirty="0"/>
+          </a:p>
+        </p:txBody>
+      </p:sp>
+      <p:graphicFrame>
+        <p:nvGraphicFramePr>
+          <p:cNvPr id="3" name="Connection matrix"/>
+          <p:cNvGraphicFramePr>
+            <a:graphicFrameLocks noGrp="1"/>
+          </p:cNvGraphicFramePr>
+          <p:nvPr>
+            <p:extLst>
+              <p:ext uri="{D42A27DB-BD31-4B8C-83A1-F6EECF244321}">
+                <p14:modId xmlns:p14="http://schemas.microsoft.com/office/powerpoint/2010/main" val="1579011935"/>
+              </p:ext>
+            </p:extLst>
+          </p:nvPr>
+        </p:nvGraphicFramePr>
+        <p:xfrm>
+          <a:off x="457200" y="2560320"/>
+          <a:ext cx="4114800" cy="914400"/>
+        </p:xfrm>
+        <a:graphic>
+          <a:graphicData uri="http://schemas.openxmlformats.org/drawingml/2006/table">
+            <a:tbl>
+              <a:tblPr/>
+              <a:tblGrid>
+                <a:gridCol w="1234440"/>
+                <a:gridCol w="960120"/>
+                <a:gridCol w="960120"/>
+                <a:gridCol w="960120"/>
+              </a:tblGrid>
+              <a:tr h="457200">
+                <a:tc>
+                  <a:txBody>
+                    <a:bodyPr/>
+                    <a:lstStyle/>
+                    <a:p>
+                      <a:pPr algn="ctr" indent="0" marL="0">
+                        <a:buNone/>
+                      </a:pPr>
+                      <a:r>
+                        <a:rPr lang="en-US" sz="1050" b="1" dirty="0">
+                          <a:solidFill>
+                            <a:srgbClr val="FFFFFF"/>
+                          </a:solidFill>
+                          <a:latin typeface="Arial" pitchFamily="34" charset="0"/>
+                          <a:ea typeface="Arial" pitchFamily="34" charset="-122"/>
+                          <a:cs typeface="Arial" pitchFamily="34" charset="-120"/>
+                        </a:rPr>
+                        <a:t>If the customer…</a:t>
+                      </a:r>
+                      <a:endParaRPr lang="en-US" sz="1050" dirty="0">
+                        <a:latin typeface="Arial" charset="0"/>
+                        <a:ea typeface="Arial" charset="0"/>
+                        <a:cs typeface="Arial" charset="0"/>
+                      </a:endParaRPr>
+                    </a:p>
+                  </a:txBody>
+                  <a:tcPr marL="54864" marR="54864" marT="36576" marB="36576" anchor="ctr">
+                    <a:lnL w="19050" cap="flat" cmpd="sng" algn="ctr">
+                      <a:solidFill>
+                        <a:srgbClr val="FFFFFF"/>
+                      </a:solidFill>
+                      <a:prstDash val="solid"/>
+                      <a:round/>
+                      <a:headEnd type="none" w="med" len="med"/>
+                      <a:tailEnd type="none" w="med" len="med"/>
+                    </a:lnL>
+                    <a:lnR w="19050" cap="flat" cmpd="sng" algn="ctr">
+                      <a:solidFill>
+                        <a:srgbClr val="FFFFFF"/>
+                      </a:solidFill>
+                      <a:prstDash val="solid"/>
+                      <a:round/>
+                      <a:headEnd type="none" w="med" len="med"/>
+                      <a:tailEnd type="none" w="med" len="med"/>
+                    </a:lnR>
+                    <a:lnT w="19050" cap="flat" cmpd="sng" algn="ctr">
+                      <a:solidFill>
+                        <a:srgbClr val="FFFFFF"/>
+                      </a:solidFill>
+                      <a:prstDash val="solid"/>
+                      <a:round/>
+                      <a:headEnd type="none" w="med" len="med"/>
+                      <a:tailEnd type="none" w="med" len="med"/>
+                    </a:lnT>
+                    <a:lnB w="19050" cap="flat" cmpd="sng" algn="ctr">
+                      <a:solidFill>
+                        <a:srgbClr val="FFFFFF"/>
+                      </a:solidFill>
+                      <a:prstDash val="solid"/>
+                      <a:round/>
+                      <a:headEnd type="none" w="med" len="med"/>
+                      <a:tailEnd type="none" w="med" len="med"/>
+                    </a:lnB>
+                    <a:solidFill>
+                      <a:srgbClr val="051C2C"/>
+                    </a:solidFill>
+                  </a:tcPr>
+                </a:tc>
+                <a:tc>
+                  <a:txBody>
+                    <a:bodyPr/>
+                    <a:lstStyle/>
+                    <a:p>
+                      <a:pPr algn="ctr" indent="0" marL="0">
+                        <a:buNone/>
+                      </a:pPr>
+                      <a:r>
+                        <a:rPr lang="en-US" sz="1050" b="1" dirty="0">
+                          <a:solidFill>
+                            <a:srgbClr val="FFFFFF"/>
+                          </a:solidFill>
+                          <a:latin typeface="Arial" pitchFamily="34" charset="0"/>
+                          <a:ea typeface="Arial" pitchFamily="34" charset="-122"/>
+                          <a:cs typeface="Arial" pitchFamily="34" charset="-120"/>
+                        </a:rPr>
+                        <a:t>…% who put money in</a:t>
+                      </a:r>
+                      <a:endParaRPr lang="en-US" sz="1050" dirty="0">
+                        <a:latin typeface="Arial" charset="0"/>
+                        <a:ea typeface="Arial" charset="0"/>
+                        <a:cs typeface="Arial" charset="0"/>
+                      </a:endParaRPr>
+                    </a:p>
+                  </a:txBody>
+                  <a:tcPr marL="54864" marR="54864" marT="36576" marB="36576" anchor="ctr">
+                    <a:lnL w="19050" cap="flat" cmpd="sng" algn="ctr">
+                      <a:solidFill>
+                        <a:srgbClr val="FFFFFF"/>
+                      </a:solidFill>
+                      <a:prstDash val="solid"/>
+                      <a:round/>
+                      <a:headEnd type="none" w="med" len="med"/>
+                      <a:tailEnd type="none" w="med" len="med"/>
+                    </a:lnL>
+                    <a:lnR w="19050" cap="flat" cmpd="sng" algn="ctr">
+                      <a:solidFill>
+                        <a:srgbClr val="FFFFFF"/>
+                      </a:solidFill>
+                      <a:prstDash val="solid"/>
+                      <a:round/>
+                      <a:headEnd type="none" w="med" len="med"/>
+                      <a:tailEnd type="none" w="med" len="med"/>
+                    </a:lnR>
+                    <a:lnT w="19050" cap="flat" cmpd="sng" algn="ctr">
+                      <a:solidFill>
+                        <a:srgbClr val="FFFFFF"/>
+                      </a:solidFill>
+                      <a:prstDash val="solid"/>
+                      <a:round/>
+                      <a:headEnd type="none" w="med" len="med"/>
+                      <a:tailEnd type="none" w="med" len="med"/>
+                    </a:lnT>
+                    <a:lnB w="19050" cap="flat" cmpd="sng" algn="ctr">
+                      <a:solidFill>
+                        <a:srgbClr val="FFFFFF"/>
+                      </a:solidFill>
+                      <a:prstDash val="solid"/>
+                      <a:round/>
+                      <a:headEnd type="none" w="med" len="med"/>
+                      <a:tailEnd type="none" w="med" len="med"/>
+                    </a:lnB>
+                    <a:solidFill>
+                      <a:srgbClr val="051C2C"/>
+                    </a:solidFill>
+                  </a:tcPr>
+                </a:tc>
+                <a:tc>
+                  <a:txBody>
+                    <a:bodyPr/>
+                    <a:lstStyle/>
+                    <a:p>
+                      <a:pPr algn="ctr" indent="0" marL="0">
+                        <a:buNone/>
+                      </a:pPr>
+                      <a:r>
+                        <a:rPr lang="en-US" sz="1050" b="1" dirty="0">
+                          <a:solidFill>
+                            <a:srgbClr val="FFFFFF"/>
+                          </a:solidFill>
+                          <a:latin typeface="Arial" pitchFamily="34" charset="0"/>
+                          <a:ea typeface="Arial" pitchFamily="34" charset="-122"/>
+                          <a:cs typeface="Arial" pitchFamily="34" charset="-120"/>
+                        </a:rPr>
+                        <a:t>…% with a loan</a:t>
+                      </a:r>
+                      <a:endParaRPr lang="en-US" sz="1050" dirty="0">
+                        <a:latin typeface="Arial" charset="0"/>
+                        <a:ea typeface="Arial" charset="0"/>
+                        <a:cs typeface="Arial" charset="0"/>
+                      </a:endParaRPr>
+                    </a:p>
+                  </a:txBody>
+                  <a:tcPr marL="54864" marR="54864" marT="36576" marB="36576" anchor="ctr">
+                    <a:lnL w="19050" cap="flat" cmpd="sng" algn="ctr">
+                      <a:solidFill>
+                        <a:srgbClr val="FFFFFF"/>
+                      </a:solidFill>
+                      <a:prstDash val="solid"/>
+                      <a:round/>
+                      <a:headEnd type="none" w="med" len="med"/>
+                      <a:tailEnd type="none" w="med" len="med"/>
+                    </a:lnL>
+                    <a:lnR w="19050" cap="flat" cmpd="sng" algn="ctr">
+                      <a:solidFill>
+                        <a:srgbClr val="FFFFFF"/>
+                      </a:solidFill>
+                      <a:prstDash val="solid"/>
+                      <a:round/>
+                      <a:headEnd type="none" w="med" len="med"/>
+                      <a:tailEnd type="none" w="med" len="med"/>
+                    </a:lnR>
+                    <a:lnT w="19050" cap="flat" cmpd="sng" algn="ctr">
+                      <a:solidFill>
+                        <a:srgbClr val="FFFFFF"/>
+                      </a:solidFill>
+                      <a:prstDash val="solid"/>
+                      <a:round/>
+                      <a:headEnd type="none" w="med" len="med"/>
+                      <a:tailEnd type="none" w="med" len="med"/>
+                    </a:lnT>
+                    <a:lnB w="19050" cap="flat" cmpd="sng" algn="ctr">
+                      <a:solidFill>
+                        <a:srgbClr val="FFFFFF"/>
+                      </a:solidFill>
+                      <a:prstDash val="solid"/>
+                      <a:round/>
+                      <a:headEnd type="none" w="med" len="med"/>
+                      <a:tailEnd type="none" w="med" len="med"/>
+                    </a:lnB>
+                    <a:solidFill>
+                      <a:srgbClr val="051C2C"/>
+                    </a:solidFill>
+                  </a:tcPr>
+                </a:tc>
+                <a:tc>
+                  <a:txBody>
+                    <a:bodyPr/>
+                    <a:lstStyle/>
+                    <a:p>
+                      <a:pPr algn="ctr" indent="0" marL="0">
+                        <a:buNone/>
+                      </a:pPr>
+                      <a:r>
+                        <a:rPr lang="en-US" sz="1050" b="1" dirty="0">
+                          <a:solidFill>
+                            <a:srgbClr val="FFFFFF"/>
+                          </a:solidFill>
+                          <a:latin typeface="Arial" pitchFamily="34" charset="0"/>
+                          <a:ea typeface="Arial" pitchFamily="34" charset="-122"/>
+                          <a:cs typeface="Arial" pitchFamily="34" charset="-120"/>
+                        </a:rPr>
+                        <a:t>…% who paid in Oct</a:t>
+                      </a:r>
+                      <a:endParaRPr lang="en-US" sz="1050" dirty="0">
+                        <a:latin typeface="Arial" charset="0"/>
+                        <a:ea typeface="Arial" charset="0"/>
+                        <a:cs typeface="Arial" charset="0"/>
+                      </a:endParaRPr>
+                    </a:p>
+                  </a:txBody>
+                  <a:tcPr marL="54864" marR="54864" marT="36576" marB="36576" anchor="ctr">
+                    <a:lnL w="19050" cap="flat" cmpd="sng" algn="ctr">
+                      <a:solidFill>
+                        <a:srgbClr val="FFFFFF"/>
+                      </a:solidFill>
+                      <a:prstDash val="solid"/>
+                      <a:round/>
+                      <a:headEnd type="none" w="med" len="med"/>
+                      <a:tailEnd type="none" w="med" len="med"/>
+                    </a:lnL>
+                    <a:lnR w="19050" cap="flat" cmpd="sng" algn="ctr">
+                      <a:solidFill>
+                        <a:srgbClr val="FFFFFF"/>
+                      </a:solidFill>
+                      <a:prstDash val="solid"/>
+                      <a:round/>
+                      <a:headEnd type="none" w="med" len="med"/>
+                      <a:tailEnd type="none" w="med" len="med"/>
+                    </a:lnR>
+                    <a:lnT w="19050" cap="flat" cmpd="sng" algn="ctr">
+                      <a:solidFill>
+                        <a:srgbClr val="FFFFFF"/>
+                      </a:solidFill>
+                      <a:prstDash val="solid"/>
+                      <a:round/>
+                      <a:headEnd type="none" w="med" len="med"/>
+                      <a:tailEnd type="none" w="med" len="med"/>
+                    </a:lnT>
+                    <a:lnB w="19050" cap="flat" cmpd="sng" algn="ctr">
+                      <a:solidFill>
+                        <a:srgbClr val="FFFFFF"/>
+                      </a:solidFill>
+                      <a:prstDash val="solid"/>
+                      <a:round/>
+                      <a:headEnd type="none" w="med" len="med"/>
+                      <a:tailEnd type="none" w="med" len="med"/>
+                    </a:lnB>
+                    <a:solidFill>
+                      <a:srgbClr val="051C2C"/>
+                    </a:solidFill>
+                  </a:tcPr>
+                </a:tc>
+              </a:tr>
+              <a:tr h="457200">
+                <a:tc>
+                  <a:txBody>
+                    <a:bodyPr/>
+                    <a:lstStyle/>
+                    <a:p>
+                      <a:pPr indent="0" marL="0">
+                        <a:buNone/>
+                      </a:pPr>
+                      <a:r>
+                        <a:rPr lang="en-US" sz="1100" b="1" dirty="0">
+                          <a:solidFill>
+                            <a:srgbClr val="051C2C"/>
+                          </a:solidFill>
+                          <a:latin typeface="Arial" pitchFamily="34" charset="0"/>
+                          <a:ea typeface="Arial" pitchFamily="34" charset="-122"/>
+                          <a:cs typeface="Arial" pitchFamily="34" charset="-120"/>
+                        </a:rPr>
+                        <a:t>All customers (average)</a:t>
+                      </a:r>
+                      <a:endParaRPr lang="en-US" sz="1100" dirty="0">
+                        <a:latin typeface="Arial" charset="0"/>
+                        <a:ea typeface="Arial" charset="0"/>
+                        <a:cs typeface="Arial" charset="0"/>
+                      </a:endParaRPr>
+                    </a:p>
+                  </a:txBody>
+                  <a:tcPr marL="54864" marR="54864" marT="36576" marB="36576" anchor="ctr">
+                    <a:lnL w="19050" cap="flat" cmpd="sng" algn="ctr">
+                      <a:solidFill>
+                        <a:srgbClr val="FFFFFF"/>
+                      </a:solidFill>
+                      <a:prstDash val="solid"/>
+                      <a:round/>
+                      <a:headEnd type="none" w="med" len="med"/>
+                      <a:tailEnd type="none" w="med" len="med"/>
+                    </a:lnL>
+                    <a:lnR w="19050" cap="flat" cmpd="sng" algn="ctr">
+                      <a:solidFill>
+                        <a:srgbClr val="FFFFFF"/>
+                      </a:solidFill>
+                      <a:prstDash val="solid"/>
+                      <a:round/>
+                      <a:headEnd type="none" w="med" len="med"/>
+                      <a:tailEnd type="none" w="med" len="med"/>
+                    </a:lnR>
+                    <a:lnT w="19050" cap="flat" cmpd="sng" algn="ctr">
+                      <a:solidFill>
+                        <a:srgbClr val="FFFFFF"/>
+                      </a:solidFill>
+                      <a:prstDash val="solid"/>
+                      <a:round/>
+                      <a:headEnd type="none" w="med" len="med"/>
+                      <a:tailEnd type="none" w="med" len="med"/>
+                    </a:lnT>
+                    <a:lnB w="19050" cap="flat" cmpd="sng" algn="ctr">
+                      <a:solidFill>
+                        <a:srgbClr val="FFFFFF"/>
+                      </a:solidFill>
+                      <a:prstDash val="solid"/>
+                      <a:round/>
+                      <a:headEnd type="none" w="med" len="med"/>
+                      <a:tailEnd type="none" w="med" len="med"/>
+                    </a:lnB>
+                  </a:tcPr>
+                </a:tc>
+                <a:tc>
+                  <a:txBody>
+                    <a:bodyPr/>
+                    <a:lstStyle/>
+                    <a:p>
+                      <a:pPr algn="ctr" indent="0" marL="0">
+                        <a:buNone/>
+                      </a:pPr>
+                      <a:r>
+                        <a:rPr lang="en-US" sz="1200" b="1" dirty="0">
+                          <a:solidFill>
+                            <a:srgbClr val="1A1A1A"/>
+                          </a:solidFill>
+                          <a:latin typeface="Arial" pitchFamily="34" charset="0"/>
+                          <a:ea typeface="Arial" pitchFamily="34" charset="-122"/>
+                          <a:cs typeface="Arial" pitchFamily="34" charset="-120"/>
+                        </a:rPr>
+                        <a:t>35%</a:t>
+                      </a:r>
+                      <a:endParaRPr lang="en-US" sz="1200" dirty="0">
+                        <a:latin typeface="Arial" charset="0"/>
+                        <a:ea typeface="Arial" charset="0"/>
+                        <a:cs typeface="Arial" charset="0"/>
+                      </a:endParaRPr>
+                    </a:p>
+                  </a:txBody>
+                  <a:tcPr marL="54864" marR="54864" marT="36576" marB="36576" anchor="ctr">
+                    <a:lnL w="19050" cap="flat" cmpd="sng" algn="ctr">
+                      <a:solidFill>
+                        <a:srgbClr val="FFFFFF"/>
+                      </a:solidFill>
+                      <a:prstDash val="solid"/>
+                      <a:round/>
+                      <a:headEnd type="none" w="med" len="med"/>
+                      <a:tailEnd type="none" w="med" len="med"/>
+                    </a:lnL>
+                    <a:lnR w="19050" cap="flat" cmpd="sng" algn="ctr">
+                      <a:solidFill>
+                        <a:srgbClr val="FFFFFF"/>
+                      </a:solidFill>
+                      <a:prstDash val="solid"/>
+                      <a:round/>
+                      <a:headEnd type="none" w="med" len="med"/>
+                      <a:tailEnd type="none" w="med" len="med"/>
+                    </a:lnR>
+                    <a:lnT w="19050" cap="flat" cmpd="sng" algn="ctr">
+                      <a:solidFill>
+                        <a:srgbClr val="FFFFFF"/>
+                      </a:solidFill>
+                      <a:prstDash val="solid"/>
+                      <a:round/>
+                      <a:headEnd type="none" w="med" len="med"/>
+                      <a:tailEnd type="none" w="med" len="med"/>
+                    </a:lnT>
+                    <a:lnB w="19050" cap="flat" cmpd="sng" algn="ctr">
+                      <a:solidFill>
+                        <a:srgbClr val="FFFFFF"/>
+                      </a:solidFill>
+                      <a:prstDash val="solid"/>
+                      <a:round/>
+                      <a:headEnd type="none" w="med" len="med"/>
+                      <a:tailEnd type="none" w="med" len="med"/>
+                    </a:lnB>
+                    <a:solidFill>
+                      <a:srgbClr val="F2F4F7"/>
+                    </a:solidFill>
+                  </a:tcPr>
+                </a:tc>
+                <a:tc>
+                  <a:txBody>
+                    <a:bodyPr/>
+                    <a:lstStyle/>
+                    <a:p>
+                      <a:pPr algn="ctr" indent="0" marL="0">
+                        <a:buNone/>
+                      </a:pPr>
+                      <a:r>
+                        <a:rPr lang="en-US" sz="1200" b="1" dirty="0">
+                          <a:solidFill>
+                            <a:srgbClr val="1A1A1A"/>
+                          </a:solidFill>
+                          <a:latin typeface="Arial" pitchFamily="34" charset="0"/>
+                          <a:ea typeface="Arial" pitchFamily="34" charset="-122"/>
+                          <a:cs typeface="Arial" pitchFamily="34" charset="-120"/>
+                        </a:rPr>
+                        <a:t>11%</a:t>
+                      </a:r>
+                      <a:endParaRPr lang="en-US" sz="1200" dirty="0">
+                        <a:latin typeface="Arial" charset="0"/>
+                        <a:ea typeface="Arial" charset="0"/>
+                        <a:cs typeface="Arial" charset="0"/>
+                      </a:endParaRPr>
+                    </a:p>
+                  </a:txBody>
+                  <a:tcPr marL="54864" marR="54864" marT="36576" marB="36576" anchor="ctr">
+                    <a:lnL w="19050" cap="flat" cmpd="sng" algn="ctr">
+                      <a:solidFill>
+                        <a:srgbClr val="FFFFFF"/>
+                      </a:solidFill>
+                      <a:prstDash val="solid"/>
+                      <a:round/>
+                      <a:headEnd type="none" w="med" len="med"/>
+                      <a:tailEnd type="none" w="med" len="med"/>
+                    </a:lnL>
+                    <a:lnR w="19050" cap="flat" cmpd="sng" algn="ctr">
+                      <a:solidFill>
+                        <a:srgbClr val="FFFFFF"/>
+                      </a:solidFill>
+                      <a:prstDash val="solid"/>
+                      <a:round/>
+                      <a:headEnd type="none" w="med" len="med"/>
+                      <a:tailEnd type="none" w="med" len="med"/>
+                    </a:lnR>
+                    <a:lnT w="19050" cap="flat" cmpd="sng" algn="ctr">
+                      <a:solidFill>
+                        <a:srgbClr val="FFFFFF"/>
+                      </a:solidFill>
+                      <a:prstDash val="solid"/>
+                      <a:round/>
+                      <a:headEnd type="none" w="med" len="med"/>
+                      <a:tailEnd type="none" w="med" len="med"/>
+                    </a:lnT>
+                    <a:lnB w="19050" cap="flat" cmpd="sng" algn="ctr">
+                      <a:solidFill>
+                        <a:srgbClr val="FFFFFF"/>
+                      </a:solidFill>
+                      <a:prstDash val="solid"/>
+                      <a:round/>
+                      <a:headEnd type="none" w="med" len="med"/>
+                      <a:tailEnd type="none" w="med" len="med"/>
+                    </a:lnB>
+                    <a:solidFill>
+                      <a:srgbClr val="F2F4F7"/>
+                    </a:solidFill>
+                  </a:tcPr>
+                </a:tc>
+                <a:tc>
+                  <a:txBody>
+                    <a:bodyPr/>
+                    <a:lstStyle/>
+                    <a:p>
+                      <a:pPr algn="ctr" indent="0" marL="0">
+                        <a:buNone/>
+                      </a:pPr>
+                      <a:r>
+                        <a:rPr lang="en-US" sz="1200" b="1" dirty="0">
+                          <a:solidFill>
+                            <a:srgbClr val="1A1A1A"/>
+                          </a:solidFill>
+                          <a:latin typeface="Arial" pitchFamily="34" charset="0"/>
+                          <a:ea typeface="Arial" pitchFamily="34" charset="-122"/>
+                          <a:cs typeface="Arial" pitchFamily="34" charset="-120"/>
+                        </a:rPr>
+                        <a:t>7.8%</a:t>
+                      </a:r>
+                      <a:endParaRPr lang="en-US" sz="1200" dirty="0">
+                        <a:latin typeface="Arial" charset="0"/>
+                        <a:ea typeface="Arial" charset="0"/>
+                        <a:cs typeface="Arial" charset="0"/>
+                      </a:endParaRPr>
+                    </a:p>
+                  </a:txBody>
+                  <a:tcPr marL="54864" marR="54864" marT="36576" marB="36576" anchor="ctr">
+                    <a:lnL w="19050" cap="flat" cmpd="sng" algn="ctr">
+                      <a:solidFill>
+                        <a:srgbClr val="FFFFFF"/>
+                      </a:solidFill>
+                      <a:prstDash val="solid"/>
+                      <a:round/>
+                      <a:headEnd type="none" w="med" len="med"/>
+                      <a:tailEnd type="none" w="med" len="med"/>
+                    </a:lnL>
+                    <a:lnR w="19050" cap="flat" cmpd="sng" algn="ctr">
+                      <a:solidFill>
+                        <a:srgbClr val="FFFFFF"/>
+                      </a:solidFill>
+                      <a:prstDash val="solid"/>
+                      <a:round/>
+                      <a:headEnd type="none" w="med" len="med"/>
+                      <a:tailEnd type="none" w="med" len="med"/>
+                    </a:lnR>
+                    <a:lnT w="19050" cap="flat" cmpd="sng" algn="ctr">
+                      <a:solidFill>
+                        <a:srgbClr val="FFFFFF"/>
+                      </a:solidFill>
+                      <a:prstDash val="solid"/>
+                      <a:round/>
+                      <a:headEnd type="none" w="med" len="med"/>
+                      <a:tailEnd type="none" w="med" len="med"/>
+                    </a:lnT>
+                    <a:lnB w="19050" cap="flat" cmpd="sng" algn="ctr">
+                      <a:solidFill>
+                        <a:srgbClr val="FFFFFF"/>
+                      </a:solidFill>
+                      <a:prstDash val="solid"/>
+                      <a:round/>
+                      <a:headEnd type="none" w="med" len="med"/>
+                      <a:tailEnd type="none" w="med" len="med"/>
+                    </a:lnB>
+                    <a:solidFill>
+                      <a:srgbClr val="F2F4F7"/>
+                    </a:solidFill>
+                  </a:tcPr>
+                </a:tc>
+              </a:tr>
+              <a:tr h="777240">
+                <a:tc>
+                  <a:txBody>
+                    <a:bodyPr/>
+                    <a:lstStyle/>
+                    <a:p>
+                      <a:pPr indent="0" marL="0">
+                        <a:buNone/>
+                      </a:pPr>
+                      <a:r>
+                        <a:rPr lang="en-US" sz="1100" b="1" dirty="0">
+                          <a:solidFill>
+                            <a:srgbClr val="051C2C"/>
+                          </a:solidFill>
+                          <a:latin typeface="Arial" pitchFamily="34" charset="0"/>
+                          <a:ea typeface="Arial" pitchFamily="34" charset="-122"/>
+                          <a:cs typeface="Arial" pitchFamily="34" charset="-120"/>
+                        </a:rPr>
+                        <a:t>Has put money in (525K)</a:t>
+                      </a:r>
+                      <a:endParaRPr lang="en-US" sz="1100" dirty="0">
+                        <a:latin typeface="Arial" charset="0"/>
+                        <a:ea typeface="Arial" charset="0"/>
+                        <a:cs typeface="Arial" charset="0"/>
+                      </a:endParaRPr>
+                    </a:p>
+                  </a:txBody>
+                  <a:tcPr marL="54864" marR="54864" marT="36576" marB="36576" anchor="ctr">
+                    <a:lnL w="19050" cap="flat" cmpd="sng" algn="ctr">
+                      <a:solidFill>
+                        <a:srgbClr val="FFFFFF"/>
+                      </a:solidFill>
+                      <a:prstDash val="solid"/>
+                      <a:round/>
+                      <a:headEnd type="none" w="med" len="med"/>
+                      <a:tailEnd type="none" w="med" len="med"/>
+                    </a:lnL>
+                    <a:lnR w="19050" cap="flat" cmpd="sng" algn="ctr">
+                      <a:solidFill>
+                        <a:srgbClr val="FFFFFF"/>
+                      </a:solidFill>
+                      <a:prstDash val="solid"/>
+                      <a:round/>
+                      <a:headEnd type="none" w="med" len="med"/>
+                      <a:tailEnd type="none" w="med" len="med"/>
+                    </a:lnR>
+                    <a:lnT w="19050" cap="flat" cmpd="sng" algn="ctr">
+                      <a:solidFill>
+                        <a:srgbClr val="FFFFFF"/>
+                      </a:solidFill>
+                      <a:prstDash val="solid"/>
+                      <a:round/>
+                      <a:headEnd type="none" w="med" len="med"/>
+                      <a:tailEnd type="none" w="med" len="med"/>
+                    </a:lnT>
+                    <a:lnB w="19050" cap="flat" cmpd="sng" algn="ctr">
+                      <a:solidFill>
+                        <a:srgbClr val="FFFFFF"/>
+                      </a:solidFill>
+                      <a:prstDash val="solid"/>
+                      <a:round/>
+                      <a:headEnd type="none" w="med" len="med"/>
+                      <a:tailEnd type="none" w="med" len="med"/>
+                    </a:lnB>
+                  </a:tcPr>
+                </a:tc>
+                <a:tc>
+                  <a:txBody>
+                    <a:bodyPr/>
+                    <a:lstStyle/>
+                    <a:p>
+                      <a:pPr algn="ctr" indent="0" marL="0">
+                        <a:buNone/>
+                      </a:pPr>
+                      <a:r>
+                        <a:rPr lang="en-US" sz="1200" dirty="0">
+                          <a:solidFill>
+                            <a:srgbClr val="5F6B76"/>
+                          </a:solidFill>
+                          <a:latin typeface="Arial" pitchFamily="34" charset="0"/>
+                          <a:ea typeface="Arial" pitchFamily="34" charset="-122"/>
+                          <a:cs typeface="Arial" pitchFamily="34" charset="-120"/>
+                        </a:rPr>
+                        <a:t>–</a:t>
+                      </a:r>
+                      <a:endParaRPr lang="en-US" sz="1200" dirty="0">
+                        <a:latin typeface="Arial" charset="0"/>
+                        <a:ea typeface="Arial" charset="0"/>
+                        <a:cs typeface="Arial" charset="0"/>
+                      </a:endParaRPr>
+                    </a:p>
+                  </a:txBody>
+                  <a:tcPr marL="54864" marR="54864" marT="36576" marB="36576" anchor="ctr">
+                    <a:lnL w="19050" cap="flat" cmpd="sng" algn="ctr">
+                      <a:solidFill>
+                        <a:srgbClr val="FFFFFF"/>
+                      </a:solidFill>
+                      <a:prstDash val="solid"/>
+                      <a:round/>
+                      <a:headEnd type="none" w="med" len="med"/>
+                      <a:tailEnd type="none" w="med" len="med"/>
+                    </a:lnL>
+                    <a:lnR w="19050" cap="flat" cmpd="sng" algn="ctr">
+                      <a:solidFill>
+                        <a:srgbClr val="FFFFFF"/>
+                      </a:solidFill>
+                      <a:prstDash val="solid"/>
+                      <a:round/>
+                      <a:headEnd type="none" w="med" len="med"/>
+                      <a:tailEnd type="none" w="med" len="med"/>
+                    </a:lnR>
+                    <a:lnT w="19050" cap="flat" cmpd="sng" algn="ctr">
+                      <a:solidFill>
+                        <a:srgbClr val="FFFFFF"/>
+                      </a:solidFill>
+                      <a:prstDash val="solid"/>
+                      <a:round/>
+                      <a:headEnd type="none" w="med" len="med"/>
+                      <a:tailEnd type="none" w="med" len="med"/>
+                    </a:lnT>
+                    <a:lnB w="19050" cap="flat" cmpd="sng" algn="ctr">
+                      <a:solidFill>
+                        <a:srgbClr val="FFFFFF"/>
+                      </a:solidFill>
+                      <a:prstDash val="solid"/>
+                      <a:round/>
+                      <a:headEnd type="none" w="med" len="med"/>
+                      <a:tailEnd type="none" w="med" len="med"/>
+                    </a:lnB>
+                  </a:tcPr>
+                </a:tc>
+                <a:tc>
+                  <a:txBody>
+                    <a:bodyPr/>
+                    <a:lstStyle/>
+                    <a:p>
+                      <a:pPr algn="ctr" indent="0" marL="0">
+                        <a:buNone/>
+                      </a:pPr>
+                      <a:r>
+                        <a:rPr lang="en-US" sz="1500" b="1" dirty="0">
+                          <a:solidFill>
+                            <a:srgbClr val="FFFFFF"/>
+                          </a:solidFill>
+                          <a:latin typeface="Arial" pitchFamily="34" charset="0"/>
+                          <a:ea typeface="Arial" pitchFamily="34" charset="-122"/>
+                          <a:cs typeface="Arial" pitchFamily="34" charset="-120"/>
+                        </a:rPr>
+                        <a:t>27%</a:t>
+                      </a:r>
+                      <a:endParaRPr lang="en-US" sz="1200" dirty="0">
+                        <a:latin typeface="Arial" charset="0"/>
+                        <a:ea typeface="Arial" charset="0"/>
+                        <a:cs typeface="Arial" charset="0"/>
+                      </a:endParaRPr>
+                    </a:p>
+                    <a:p>
+                      <a:pPr algn="ctr" indent="0" marL="0">
+                        <a:buNone/>
+                      </a:pPr>
+                      <a:r>
+                        <a:rPr lang="en-US" sz="950" dirty="0">
+                          <a:solidFill>
+                            <a:srgbClr val="FFFFFF"/>
+                          </a:solidFill>
+                          <a:latin typeface="Arial" pitchFamily="34" charset="0"/>
+                          <a:ea typeface="Arial" pitchFamily="34" charset="-122"/>
+                          <a:cs typeface="Arial" pitchFamily="34" charset="-120"/>
+                        </a:rPr>
+                        <a:t>2.5x more likely</a:t>
+                      </a:r>
+                      <a:endParaRPr lang="en-US" sz="1200" dirty="0">
+                        <a:latin typeface="Arial" charset="0"/>
+                        <a:ea typeface="Arial" charset="0"/>
+                        <a:cs typeface="Arial" charset="0"/>
+                      </a:endParaRPr>
+                    </a:p>
+                  </a:txBody>
+                  <a:tcPr marL="54864" marR="54864" marT="36576" marB="36576" anchor="ctr">
+                    <a:lnL w="19050" cap="flat" cmpd="sng" algn="ctr">
+                      <a:solidFill>
+                        <a:srgbClr val="FFFFFF"/>
+                      </a:solidFill>
+                      <a:prstDash val="solid"/>
+                      <a:round/>
+                      <a:headEnd type="none" w="med" len="med"/>
+                      <a:tailEnd type="none" w="med" len="med"/>
+                    </a:lnL>
+                    <a:lnR w="19050" cap="flat" cmpd="sng" algn="ctr">
+                      <a:solidFill>
+                        <a:srgbClr val="FFFFFF"/>
+                      </a:solidFill>
+                      <a:prstDash val="solid"/>
+                      <a:round/>
+                      <a:headEnd type="none" w="med" len="med"/>
+                      <a:tailEnd type="none" w="med" len="med"/>
+                    </a:lnR>
+                    <a:lnT w="19050" cap="flat" cmpd="sng" algn="ctr">
+                      <a:solidFill>
+                        <a:srgbClr val="FFFFFF"/>
+                      </a:solidFill>
+                      <a:prstDash val="solid"/>
+                      <a:round/>
+                      <a:headEnd type="none" w="med" len="med"/>
+                      <a:tailEnd type="none" w="med" len="med"/>
+                    </a:lnT>
+                    <a:lnB w="19050" cap="flat" cmpd="sng" algn="ctr">
+                      <a:solidFill>
+                        <a:srgbClr val="FFFFFF"/>
+                      </a:solidFill>
+                      <a:prstDash val="solid"/>
+                      <a:round/>
+                      <a:headEnd type="none" w="med" len="med"/>
+                      <a:tailEnd type="none" w="med" len="med"/>
+                    </a:lnB>
+                    <a:solidFill>
+                      <a:srgbClr val="2251FF"/>
+                    </a:solidFill>
+                  </a:tcPr>
+                </a:tc>
+                <a:tc>
+                  <a:txBody>
+                    <a:bodyPr/>
+                    <a:lstStyle/>
+                    <a:p>
+                      <a:pPr algn="ctr" indent="0" marL="0">
+                        <a:buNone/>
+                      </a:pPr>
+                      <a:r>
+                        <a:rPr lang="en-US" sz="1500" b="1" dirty="0">
+                          <a:solidFill>
+                            <a:srgbClr val="FFFFFF"/>
+                          </a:solidFill>
+                          <a:latin typeface="Arial" pitchFamily="34" charset="0"/>
+                          <a:ea typeface="Arial" pitchFamily="34" charset="-122"/>
+                          <a:cs typeface="Arial" pitchFamily="34" charset="-120"/>
+                        </a:rPr>
+                        <a:t>22%</a:t>
+                      </a:r>
+                      <a:endParaRPr lang="en-US" sz="1200" dirty="0">
+                        <a:latin typeface="Arial" charset="0"/>
+                        <a:ea typeface="Arial" charset="0"/>
+                        <a:cs typeface="Arial" charset="0"/>
+                      </a:endParaRPr>
+                    </a:p>
+                    <a:p>
+                      <a:pPr algn="ctr" indent="0" marL="0">
+                        <a:buNone/>
+                      </a:pPr>
+                      <a:r>
+                        <a:rPr lang="en-US" sz="950" dirty="0">
+                          <a:solidFill>
+                            <a:srgbClr val="FFFFFF"/>
+                          </a:solidFill>
+                          <a:latin typeface="Arial" pitchFamily="34" charset="0"/>
+                          <a:ea typeface="Arial" pitchFamily="34" charset="-122"/>
+                          <a:cs typeface="Arial" pitchFamily="34" charset="-120"/>
+                        </a:rPr>
+                        <a:t>2.8x more likely</a:t>
+                      </a:r>
+                      <a:endParaRPr lang="en-US" sz="1200" dirty="0">
+                        <a:latin typeface="Arial" charset="0"/>
+                        <a:ea typeface="Arial" charset="0"/>
+                        <a:cs typeface="Arial" charset="0"/>
+                      </a:endParaRPr>
+                    </a:p>
+                  </a:txBody>
+                  <a:tcPr marL="54864" marR="54864" marT="36576" marB="36576" anchor="ctr">
+                    <a:lnL w="19050" cap="flat" cmpd="sng" algn="ctr">
+                      <a:solidFill>
+                        <a:srgbClr val="FFFFFF"/>
+                      </a:solidFill>
+                      <a:prstDash val="solid"/>
+                      <a:round/>
+                      <a:headEnd type="none" w="med" len="med"/>
+                      <a:tailEnd type="none" w="med" len="med"/>
+                    </a:lnL>
+                    <a:lnR w="19050" cap="flat" cmpd="sng" algn="ctr">
+                      <a:solidFill>
+                        <a:srgbClr val="FFFFFF"/>
+                      </a:solidFill>
+                      <a:prstDash val="solid"/>
+                      <a:round/>
+                      <a:headEnd type="none" w="med" len="med"/>
+                      <a:tailEnd type="none" w="med" len="med"/>
+                    </a:lnR>
+                    <a:lnT w="19050" cap="flat" cmpd="sng" algn="ctr">
+                      <a:solidFill>
+                        <a:srgbClr val="FFFFFF"/>
+                      </a:solidFill>
+                      <a:prstDash val="solid"/>
+                      <a:round/>
+                      <a:headEnd type="none" w="med" len="med"/>
+                      <a:tailEnd type="none" w="med" len="med"/>
+                    </a:lnT>
+                    <a:lnB w="19050" cap="flat" cmpd="sng" algn="ctr">
+                      <a:solidFill>
+                        <a:srgbClr val="FFFFFF"/>
+                      </a:solidFill>
+                      <a:prstDash val="solid"/>
+                      <a:round/>
+                      <a:headEnd type="none" w="med" len="med"/>
+                      <a:tailEnd type="none" w="med" len="med"/>
+                    </a:lnB>
+                    <a:solidFill>
+                      <a:srgbClr val="2251FF"/>
+                    </a:solidFill>
+                  </a:tcPr>
+                </a:tc>
+              </a:tr>
+              <a:tr h="777240">
+                <a:tc>
+                  <a:txBody>
+                    <a:bodyPr/>
+                    <a:lstStyle/>
+                    <a:p>
+                      <a:pPr indent="0" marL="0">
+                        <a:buNone/>
+                      </a:pPr>
+                      <a:r>
+                        <a:rPr lang="en-US" sz="1100" b="1" dirty="0">
+                          <a:solidFill>
+                            <a:srgbClr val="051C2C"/>
+                          </a:solidFill>
+                          <a:latin typeface="Arial" pitchFamily="34" charset="0"/>
+                          <a:ea typeface="Arial" pitchFamily="34" charset="-122"/>
+                          <a:cs typeface="Arial" pitchFamily="34" charset="-120"/>
+                        </a:rPr>
+                        <a:t>Has a loan (164K)</a:t>
+                      </a:r>
+                      <a:endParaRPr lang="en-US" sz="1100" dirty="0">
+                        <a:latin typeface="Arial" charset="0"/>
+                        <a:ea typeface="Arial" charset="0"/>
+                        <a:cs typeface="Arial" charset="0"/>
+                      </a:endParaRPr>
+                    </a:p>
+                  </a:txBody>
+                  <a:tcPr marL="54864" marR="54864" marT="36576" marB="36576" anchor="ctr">
+                    <a:lnL w="19050" cap="flat" cmpd="sng" algn="ctr">
+                      <a:solidFill>
+                        <a:srgbClr val="FFFFFF"/>
+                      </a:solidFill>
+                      <a:prstDash val="solid"/>
+                      <a:round/>
+                      <a:headEnd type="none" w="med" len="med"/>
+                      <a:tailEnd type="none" w="med" len="med"/>
+                    </a:lnL>
+                    <a:lnR w="19050" cap="flat" cmpd="sng" algn="ctr">
+                      <a:solidFill>
+                        <a:srgbClr val="FFFFFF"/>
+                      </a:solidFill>
+                      <a:prstDash val="solid"/>
+                      <a:round/>
+                      <a:headEnd type="none" w="med" len="med"/>
+                      <a:tailEnd type="none" w="med" len="med"/>
+                    </a:lnR>
+                    <a:lnT w="19050" cap="flat" cmpd="sng" algn="ctr">
+                      <a:solidFill>
+                        <a:srgbClr val="FFFFFF"/>
+                      </a:solidFill>
+                      <a:prstDash val="solid"/>
+                      <a:round/>
+                      <a:headEnd type="none" w="med" len="med"/>
+                      <a:tailEnd type="none" w="med" len="med"/>
+                    </a:lnT>
+                    <a:lnB w="19050" cap="flat" cmpd="sng" algn="ctr">
+                      <a:solidFill>
+                        <a:srgbClr val="FFFFFF"/>
+                      </a:solidFill>
+                      <a:prstDash val="solid"/>
+                      <a:round/>
+                      <a:headEnd type="none" w="med" len="med"/>
+                      <a:tailEnd type="none" w="med" len="med"/>
+                    </a:lnB>
+                  </a:tcPr>
+                </a:tc>
+                <a:tc>
+                  <a:txBody>
+                    <a:bodyPr/>
+                    <a:lstStyle/>
+                    <a:p>
+                      <a:pPr algn="ctr" indent="0" marL="0">
+                        <a:buNone/>
+                      </a:pPr>
+                      <a:r>
+                        <a:rPr lang="en-US" sz="1500" b="1" dirty="0">
+                          <a:solidFill>
+                            <a:srgbClr val="FFFFFF"/>
+                          </a:solidFill>
+                          <a:latin typeface="Arial" pitchFamily="34" charset="0"/>
+                          <a:ea typeface="Arial" pitchFamily="34" charset="-122"/>
+                          <a:cs typeface="Arial" pitchFamily="34" charset="-120"/>
+                        </a:rPr>
+                        <a:t>87%</a:t>
+                      </a:r>
+                      <a:endParaRPr lang="en-US" sz="1200" dirty="0">
+                        <a:latin typeface="Arial" charset="0"/>
+                        <a:ea typeface="Arial" charset="0"/>
+                        <a:cs typeface="Arial" charset="0"/>
+                      </a:endParaRPr>
+                    </a:p>
+                    <a:p>
+                      <a:pPr algn="ctr" indent="0" marL="0">
+                        <a:buNone/>
+                      </a:pPr>
+                      <a:r>
+                        <a:rPr lang="en-US" sz="950" dirty="0">
+                          <a:solidFill>
+                            <a:srgbClr val="FFFFFF"/>
+                          </a:solidFill>
+                          <a:latin typeface="Arial" pitchFamily="34" charset="0"/>
+                          <a:ea typeface="Arial" pitchFamily="34" charset="-122"/>
+                          <a:cs typeface="Arial" pitchFamily="34" charset="-120"/>
+                        </a:rPr>
+                        <a:t>2.5x more likely</a:t>
+                      </a:r>
+                      <a:endParaRPr lang="en-US" sz="1200" dirty="0">
+                        <a:latin typeface="Arial" charset="0"/>
+                        <a:ea typeface="Arial" charset="0"/>
+                        <a:cs typeface="Arial" charset="0"/>
+                      </a:endParaRPr>
+                    </a:p>
+                  </a:txBody>
+                  <a:tcPr marL="54864" marR="54864" marT="36576" marB="36576" anchor="ctr">
+                    <a:lnL w="19050" cap="flat" cmpd="sng" algn="ctr">
+                      <a:solidFill>
+                        <a:srgbClr val="FFFFFF"/>
+                      </a:solidFill>
+                      <a:prstDash val="solid"/>
+                      <a:round/>
+                      <a:headEnd type="none" w="med" len="med"/>
+                      <a:tailEnd type="none" w="med" len="med"/>
+                    </a:lnL>
+                    <a:lnR w="19050" cap="flat" cmpd="sng" algn="ctr">
+                      <a:solidFill>
+                        <a:srgbClr val="FFFFFF"/>
+                      </a:solidFill>
+                      <a:prstDash val="solid"/>
+                      <a:round/>
+                      <a:headEnd type="none" w="med" len="med"/>
+                      <a:tailEnd type="none" w="med" len="med"/>
+                    </a:lnR>
+                    <a:lnT w="19050" cap="flat" cmpd="sng" algn="ctr">
+                      <a:solidFill>
+                        <a:srgbClr val="FFFFFF"/>
+                      </a:solidFill>
+                      <a:prstDash val="solid"/>
+                      <a:round/>
+                      <a:headEnd type="none" w="med" len="med"/>
+                      <a:tailEnd type="none" w="med" len="med"/>
+                    </a:lnT>
+                    <a:lnB w="19050" cap="flat" cmpd="sng" algn="ctr">
+                      <a:solidFill>
+                        <a:srgbClr val="FFFFFF"/>
+                      </a:solidFill>
+                      <a:prstDash val="solid"/>
+                      <a:round/>
+                      <a:headEnd type="none" w="med" len="med"/>
+                      <a:tailEnd type="none" w="med" len="med"/>
+                    </a:lnB>
+                    <a:solidFill>
+                      <a:srgbClr val="2251FF"/>
+                    </a:solidFill>
+                  </a:tcPr>
+                </a:tc>
+                <a:tc>
+                  <a:txBody>
+                    <a:bodyPr/>
+                    <a:lstStyle/>
+                    <a:p>
+                      <a:pPr algn="ctr" indent="0" marL="0">
+                        <a:buNone/>
+                      </a:pPr>
+                      <a:r>
+                        <a:rPr lang="en-US" sz="1200" dirty="0">
+                          <a:solidFill>
+                            <a:srgbClr val="5F6B76"/>
+                          </a:solidFill>
+                          <a:latin typeface="Arial" pitchFamily="34" charset="0"/>
+                          <a:ea typeface="Arial" pitchFamily="34" charset="-122"/>
+                          <a:cs typeface="Arial" pitchFamily="34" charset="-120"/>
+                        </a:rPr>
+                        <a:t>–</a:t>
+                      </a:r>
+                      <a:endParaRPr lang="en-US" sz="1200" dirty="0">
+                        <a:latin typeface="Arial" charset="0"/>
+                        <a:ea typeface="Arial" charset="0"/>
+                        <a:cs typeface="Arial" charset="0"/>
+                      </a:endParaRPr>
+                    </a:p>
+                  </a:txBody>
+                  <a:tcPr marL="54864" marR="54864" marT="36576" marB="36576" anchor="ctr">
+                    <a:lnL w="19050" cap="flat" cmpd="sng" algn="ctr">
+                      <a:solidFill>
+                        <a:srgbClr val="FFFFFF"/>
+                      </a:solidFill>
+                      <a:prstDash val="solid"/>
+                      <a:round/>
+                      <a:headEnd type="none" w="med" len="med"/>
+                      <a:tailEnd type="none" w="med" len="med"/>
+                    </a:lnL>
+                    <a:lnR w="19050" cap="flat" cmpd="sng" algn="ctr">
+                      <a:solidFill>
+                        <a:srgbClr val="FFFFFF"/>
+                      </a:solidFill>
+                      <a:prstDash val="solid"/>
+                      <a:round/>
+                      <a:headEnd type="none" w="med" len="med"/>
+                      <a:tailEnd type="none" w="med" len="med"/>
+                    </a:lnR>
+                    <a:lnT w="19050" cap="flat" cmpd="sng" algn="ctr">
+                      <a:solidFill>
+                        <a:srgbClr val="FFFFFF"/>
+                      </a:solidFill>
+                      <a:prstDash val="solid"/>
+                      <a:round/>
+                      <a:headEnd type="none" w="med" len="med"/>
+                      <a:tailEnd type="none" w="med" len="med"/>
+                    </a:lnT>
+                    <a:lnB w="19050" cap="flat" cmpd="sng" algn="ctr">
+                      <a:solidFill>
+                        <a:srgbClr val="FFFFFF"/>
+                      </a:solidFill>
+                      <a:prstDash val="solid"/>
+                      <a:round/>
+                      <a:headEnd type="none" w="med" len="med"/>
+                      <a:tailEnd type="none" w="med" len="med"/>
+                    </a:lnB>
+                  </a:tcPr>
+                </a:tc>
+                <a:tc>
+                  <a:txBody>
+                    <a:bodyPr/>
+                    <a:lstStyle/>
+                    <a:p>
+                      <a:pPr algn="ctr" indent="0" marL="0">
+                        <a:buNone/>
+                      </a:pPr>
+                      <a:r>
+                        <a:rPr lang="en-US" sz="1500" b="1" dirty="0">
+                          <a:solidFill>
+                            <a:srgbClr val="FFFFFF"/>
+                          </a:solidFill>
+                          <a:latin typeface="Arial" pitchFamily="34" charset="0"/>
+                          <a:ea typeface="Arial" pitchFamily="34" charset="-122"/>
+                          <a:cs typeface="Arial" pitchFamily="34" charset="-120"/>
+                        </a:rPr>
+                        <a:t>28.5%</a:t>
+                      </a:r>
+                      <a:endParaRPr lang="en-US" sz="1200" dirty="0">
+                        <a:latin typeface="Arial" charset="0"/>
+                        <a:ea typeface="Arial" charset="0"/>
+                        <a:cs typeface="Arial" charset="0"/>
+                      </a:endParaRPr>
+                    </a:p>
+                    <a:p>
+                      <a:pPr algn="ctr" indent="0" marL="0">
+                        <a:buNone/>
+                      </a:pPr>
+                      <a:r>
+                        <a:rPr lang="en-US" sz="950" dirty="0">
+                          <a:solidFill>
+                            <a:srgbClr val="FFFFFF"/>
+                          </a:solidFill>
+                          <a:latin typeface="Arial" pitchFamily="34" charset="0"/>
+                          <a:ea typeface="Arial" pitchFamily="34" charset="-122"/>
+                          <a:cs typeface="Arial" pitchFamily="34" charset="-120"/>
+                        </a:rPr>
+                        <a:t>3.7x more likely</a:t>
+                      </a:r>
+                      <a:endParaRPr lang="en-US" sz="1200" dirty="0">
+                        <a:latin typeface="Arial" charset="0"/>
+                        <a:ea typeface="Arial" charset="0"/>
+                        <a:cs typeface="Arial" charset="0"/>
+                      </a:endParaRPr>
+                    </a:p>
+                  </a:txBody>
+                  <a:tcPr marL="54864" marR="54864" marT="36576" marB="36576" anchor="ctr">
+                    <a:lnL w="19050" cap="flat" cmpd="sng" algn="ctr">
+                      <a:solidFill>
+                        <a:srgbClr val="FFFFFF"/>
+                      </a:solidFill>
+                      <a:prstDash val="solid"/>
+                      <a:round/>
+                      <a:headEnd type="none" w="med" len="med"/>
+                      <a:tailEnd type="none" w="med" len="med"/>
+                    </a:lnL>
+                    <a:lnR w="19050" cap="flat" cmpd="sng" algn="ctr">
+                      <a:solidFill>
+                        <a:srgbClr val="FFFFFF"/>
+                      </a:solidFill>
+                      <a:prstDash val="solid"/>
+                      <a:round/>
+                      <a:headEnd type="none" w="med" len="med"/>
+                      <a:tailEnd type="none" w="med" len="med"/>
+                    </a:lnR>
+                    <a:lnT w="19050" cap="flat" cmpd="sng" algn="ctr">
+                      <a:solidFill>
+                        <a:srgbClr val="FFFFFF"/>
+                      </a:solidFill>
+                      <a:prstDash val="solid"/>
+                      <a:round/>
+                      <a:headEnd type="none" w="med" len="med"/>
+                      <a:tailEnd type="none" w="med" len="med"/>
+                    </a:lnT>
+                    <a:lnB w="19050" cap="flat" cmpd="sng" algn="ctr">
+                      <a:solidFill>
+                        <a:srgbClr val="FFFFFF"/>
+                      </a:solidFill>
+                      <a:prstDash val="solid"/>
+                      <a:round/>
+                      <a:headEnd type="none" w="med" len="med"/>
+                      <a:tailEnd type="none" w="med" len="med"/>
+                    </a:lnB>
+                    <a:solidFill>
+                      <a:srgbClr val="2251FF"/>
+                    </a:solidFill>
+                  </a:tcPr>
+                </a:tc>
+              </a:tr>
+              <a:tr h="777240">
+                <a:tc>
+                  <a:txBody>
+                    <a:bodyPr/>
+                    <a:lstStyle/>
+                    <a:p>
+                      <a:pPr indent="0" marL="0">
+                        <a:buNone/>
+                      </a:pPr>
+                      <a:r>
+                        <a:rPr lang="en-US" sz="1100" b="1" dirty="0">
+                          <a:solidFill>
+                            <a:srgbClr val="051C2C"/>
+                          </a:solidFill>
+                          <a:latin typeface="Arial" pitchFamily="34" charset="0"/>
+                          <a:ea typeface="Arial" pitchFamily="34" charset="-122"/>
+                          <a:cs typeface="Arial" pitchFamily="34" charset="-120"/>
+                        </a:rPr>
+                        <a:t>Paid in Oct (117K)</a:t>
+                      </a:r>
+                      <a:endParaRPr lang="en-US" sz="1100" dirty="0">
+                        <a:latin typeface="Arial" charset="0"/>
+                        <a:ea typeface="Arial" charset="0"/>
+                        <a:cs typeface="Arial" charset="0"/>
+                      </a:endParaRPr>
+                    </a:p>
+                  </a:txBody>
+                  <a:tcPr marL="54864" marR="54864" marT="36576" marB="36576" anchor="ctr">
+                    <a:lnL w="19050" cap="flat" cmpd="sng" algn="ctr">
+                      <a:solidFill>
+                        <a:srgbClr val="FFFFFF"/>
+                      </a:solidFill>
+                      <a:prstDash val="solid"/>
+                      <a:round/>
+                      <a:headEnd type="none" w="med" len="med"/>
+                      <a:tailEnd type="none" w="med" len="med"/>
+                    </a:lnL>
+                    <a:lnR w="19050" cap="flat" cmpd="sng" algn="ctr">
+                      <a:solidFill>
+                        <a:srgbClr val="FFFFFF"/>
+                      </a:solidFill>
+                      <a:prstDash val="solid"/>
+                      <a:round/>
+                      <a:headEnd type="none" w="med" len="med"/>
+                      <a:tailEnd type="none" w="med" len="med"/>
+                    </a:lnR>
+                    <a:lnT w="19050" cap="flat" cmpd="sng" algn="ctr">
+                      <a:solidFill>
+                        <a:srgbClr val="FFFFFF"/>
+                      </a:solidFill>
+                      <a:prstDash val="solid"/>
+                      <a:round/>
+                      <a:headEnd type="none" w="med" len="med"/>
+                      <a:tailEnd type="none" w="med" len="med"/>
+                    </a:lnT>
+                    <a:lnB w="19050" cap="flat" cmpd="sng" algn="ctr">
+                      <a:solidFill>
+                        <a:srgbClr val="FFFFFF"/>
+                      </a:solidFill>
+                      <a:prstDash val="solid"/>
+                      <a:round/>
+                      <a:headEnd type="none" w="med" len="med"/>
+                      <a:tailEnd type="none" w="med" len="med"/>
+                    </a:lnB>
+                  </a:tcPr>
+                </a:tc>
+                <a:tc>
+                  <a:txBody>
+                    <a:bodyPr/>
+                    <a:lstStyle/>
+                    <a:p>
+                      <a:pPr algn="ctr" indent="0" marL="0">
+                        <a:buNone/>
+                      </a:pPr>
+                      <a:r>
+                        <a:rPr lang="en-US" sz="1500" b="1" dirty="0">
+                          <a:solidFill>
+                            <a:srgbClr val="FFFFFF"/>
+                          </a:solidFill>
+                          <a:latin typeface="Arial" pitchFamily="34" charset="0"/>
+                          <a:ea typeface="Arial" pitchFamily="34" charset="-122"/>
+                          <a:cs typeface="Arial" pitchFamily="34" charset="-120"/>
+                        </a:rPr>
+                        <a:t>99%</a:t>
+                      </a:r>
+                      <a:endParaRPr lang="en-US" sz="1200" dirty="0">
+                        <a:latin typeface="Arial" charset="0"/>
+                        <a:ea typeface="Arial" charset="0"/>
+                        <a:cs typeface="Arial" charset="0"/>
+                      </a:endParaRPr>
+                    </a:p>
+                    <a:p>
+                      <a:pPr algn="ctr" indent="0" marL="0">
+                        <a:buNone/>
+                      </a:pPr>
+                      <a:r>
+                        <a:rPr lang="en-US" sz="950" dirty="0">
+                          <a:solidFill>
+                            <a:srgbClr val="FFFFFF"/>
+                          </a:solidFill>
+                          <a:latin typeface="Arial" pitchFamily="34" charset="0"/>
+                          <a:ea typeface="Arial" pitchFamily="34" charset="-122"/>
+                          <a:cs typeface="Arial" pitchFamily="34" charset="-120"/>
+                        </a:rPr>
+                        <a:t>2.8x more likely</a:t>
+                      </a:r>
+                      <a:endParaRPr lang="en-US" sz="1200" dirty="0">
+                        <a:latin typeface="Arial" charset="0"/>
+                        <a:ea typeface="Arial" charset="0"/>
+                        <a:cs typeface="Arial" charset="0"/>
+                      </a:endParaRPr>
+                    </a:p>
+                  </a:txBody>
+                  <a:tcPr marL="54864" marR="54864" marT="36576" marB="36576" anchor="ctr">
+                    <a:lnL w="19050" cap="flat" cmpd="sng" algn="ctr">
+                      <a:solidFill>
+                        <a:srgbClr val="FFFFFF"/>
+                      </a:solidFill>
+                      <a:prstDash val="solid"/>
+                      <a:round/>
+                      <a:headEnd type="none" w="med" len="med"/>
+                      <a:tailEnd type="none" w="med" len="med"/>
+                    </a:lnL>
+                    <a:lnR w="19050" cap="flat" cmpd="sng" algn="ctr">
+                      <a:solidFill>
+                        <a:srgbClr val="FFFFFF"/>
+                      </a:solidFill>
+                      <a:prstDash val="solid"/>
+                      <a:round/>
+                      <a:headEnd type="none" w="med" len="med"/>
+                      <a:tailEnd type="none" w="med" len="med"/>
+                    </a:lnR>
+                    <a:lnT w="19050" cap="flat" cmpd="sng" algn="ctr">
+                      <a:solidFill>
+                        <a:srgbClr val="FFFFFF"/>
+                      </a:solidFill>
+                      <a:prstDash val="solid"/>
+                      <a:round/>
+                      <a:headEnd type="none" w="med" len="med"/>
+                      <a:tailEnd type="none" w="med" len="med"/>
+                    </a:lnT>
+                    <a:lnB w="19050" cap="flat" cmpd="sng" algn="ctr">
+                      <a:solidFill>
+                        <a:srgbClr val="FFFFFF"/>
+                      </a:solidFill>
+                      <a:prstDash val="solid"/>
+                      <a:round/>
+                      <a:headEnd type="none" w="med" len="med"/>
+                      <a:tailEnd type="none" w="med" len="med"/>
+                    </a:lnB>
+                    <a:solidFill>
+                      <a:srgbClr val="2251FF"/>
+                    </a:solidFill>
+                  </a:tcPr>
+                </a:tc>
+                <a:tc>
+                  <a:txBody>
+                    <a:bodyPr/>
+                    <a:lstStyle/>
+                    <a:p>
+                      <a:pPr algn="ctr" indent="0" marL="0">
+                        <a:buNone/>
+                      </a:pPr>
+                      <a:r>
+                        <a:rPr lang="en-US" sz="1500" b="1" dirty="0">
+                          <a:solidFill>
+                            <a:srgbClr val="FFFFFF"/>
+                          </a:solidFill>
+                          <a:latin typeface="Arial" pitchFamily="34" charset="0"/>
+                          <a:ea typeface="Arial" pitchFamily="34" charset="-122"/>
+                          <a:cs typeface="Arial" pitchFamily="34" charset="-120"/>
+                        </a:rPr>
+                        <a:t>40%</a:t>
+                      </a:r>
+                      <a:endParaRPr lang="en-US" sz="1200" dirty="0">
+                        <a:latin typeface="Arial" charset="0"/>
+                        <a:ea typeface="Arial" charset="0"/>
+                        <a:cs typeface="Arial" charset="0"/>
+                      </a:endParaRPr>
+                    </a:p>
+                    <a:p>
+                      <a:pPr algn="ctr" indent="0" marL="0">
+                        <a:buNone/>
+                      </a:pPr>
+                      <a:r>
+                        <a:rPr lang="en-US" sz="950" dirty="0">
+                          <a:solidFill>
+                            <a:srgbClr val="FFFFFF"/>
+                          </a:solidFill>
+                          <a:latin typeface="Arial" pitchFamily="34" charset="0"/>
+                          <a:ea typeface="Arial" pitchFamily="34" charset="-122"/>
+                          <a:cs typeface="Arial" pitchFamily="34" charset="-120"/>
+                        </a:rPr>
+                        <a:t>3.6x more likely</a:t>
+                      </a:r>
+                      <a:endParaRPr lang="en-US" sz="1200" dirty="0">
+                        <a:latin typeface="Arial" charset="0"/>
+                        <a:ea typeface="Arial" charset="0"/>
+                        <a:cs typeface="Arial" charset="0"/>
+                      </a:endParaRPr>
+                    </a:p>
+                  </a:txBody>
+                  <a:tcPr marL="54864" marR="54864" marT="36576" marB="36576" anchor="ctr">
+                    <a:lnL w="19050" cap="flat" cmpd="sng" algn="ctr">
+                      <a:solidFill>
+                        <a:srgbClr val="FFFFFF"/>
+                      </a:solidFill>
+                      <a:prstDash val="solid"/>
+                      <a:round/>
+                      <a:headEnd type="none" w="med" len="med"/>
+                      <a:tailEnd type="none" w="med" len="med"/>
+                    </a:lnL>
+                    <a:lnR w="19050" cap="flat" cmpd="sng" algn="ctr">
+                      <a:solidFill>
+                        <a:srgbClr val="FFFFFF"/>
+                      </a:solidFill>
+                      <a:prstDash val="solid"/>
+                      <a:round/>
+                      <a:headEnd type="none" w="med" len="med"/>
+                      <a:tailEnd type="none" w="med" len="med"/>
+                    </a:lnR>
+                    <a:lnT w="19050" cap="flat" cmpd="sng" algn="ctr">
+                      <a:solidFill>
+                        <a:srgbClr val="FFFFFF"/>
+                      </a:solidFill>
+                      <a:prstDash val="solid"/>
+                      <a:round/>
+                      <a:headEnd type="none" w="med" len="med"/>
+                      <a:tailEnd type="none" w="med" len="med"/>
+                    </a:lnT>
+                    <a:lnB w="19050" cap="flat" cmpd="sng" algn="ctr">
+                      <a:solidFill>
+                        <a:srgbClr val="FFFFFF"/>
+                      </a:solidFill>
+                      <a:prstDash val="solid"/>
+                      <a:round/>
+                      <a:headEnd type="none" w="med" len="med"/>
+                      <a:tailEnd type="none" w="med" len="med"/>
+                    </a:lnB>
+                    <a:solidFill>
+                      <a:srgbClr val="2251FF"/>
+                    </a:solidFill>
+                  </a:tcPr>
+                </a:tc>
+                <a:tc>
+                  <a:txBody>
+                    <a:bodyPr/>
+                    <a:lstStyle/>
+                    <a:p>
+                      <a:pPr algn="ctr" indent="0" marL="0">
+                        <a:buNone/>
+                      </a:pPr>
+                      <a:r>
+                        <a:rPr lang="en-US" sz="1200" dirty="0">
+                          <a:solidFill>
+                            <a:srgbClr val="5F6B76"/>
+                          </a:solidFill>
+                          <a:latin typeface="Arial" pitchFamily="34" charset="0"/>
+                          <a:ea typeface="Arial" pitchFamily="34" charset="-122"/>
+                          <a:cs typeface="Arial" pitchFamily="34" charset="-120"/>
+                        </a:rPr>
+                        <a:t>–</a:t>
+                      </a:r>
+                      <a:endParaRPr lang="en-US" sz="1200" dirty="0">
+                        <a:latin typeface="Arial" charset="0"/>
+                        <a:ea typeface="Arial" charset="0"/>
+                        <a:cs typeface="Arial" charset="0"/>
+                      </a:endParaRPr>
+                    </a:p>
+                  </a:txBody>
+                  <a:tcPr marL="54864" marR="54864" marT="36576" marB="36576" anchor="ctr">
+                    <a:lnL w="19050" cap="flat" cmpd="sng" algn="ctr">
+                      <a:solidFill>
+                        <a:srgbClr val="FFFFFF"/>
+                      </a:solidFill>
+                      <a:prstDash val="solid"/>
+                      <a:round/>
+                      <a:headEnd type="none" w="med" len="med"/>
+                      <a:tailEnd type="none" w="med" len="med"/>
+                    </a:lnL>
+                    <a:lnR w="19050" cap="flat" cmpd="sng" algn="ctr">
+                      <a:solidFill>
+                        <a:srgbClr val="FFFFFF"/>
+                      </a:solidFill>
+                      <a:prstDash val="solid"/>
+                      <a:round/>
+                      <a:headEnd type="none" w="med" len="med"/>
+                      <a:tailEnd type="none" w="med" len="med"/>
+                    </a:lnR>
+                    <a:lnT w="19050" cap="flat" cmpd="sng" algn="ctr">
+                      <a:solidFill>
+                        <a:srgbClr val="FFFFFF"/>
+                      </a:solidFill>
+                      <a:prstDash val="solid"/>
+                      <a:round/>
+                      <a:headEnd type="none" w="med" len="med"/>
+                      <a:tailEnd type="none" w="med" len="med"/>
+                    </a:lnT>
+                    <a:lnB w="19050" cap="flat" cmpd="sng" algn="ctr">
+                      <a:solidFill>
+                        <a:srgbClr val="FFFFFF"/>
+                      </a:solidFill>
+                      <a:prstDash val="solid"/>
+                      <a:round/>
+                      <a:headEnd type="none" w="med" len="med"/>
+                      <a:tailEnd type="none" w="med" len="med"/>
+                    </a:lnB>
+                  </a:tcPr>
+                </a:tc>
+              </a:tr>
+            </a:tbl>
+          </a:graphicData>
+        </a:graphic>
+      </p:graphicFrame>
+      <p:sp>
+        <p:nvSpPr>
+          <p:cNvPr id="8" name="Ladder title"/>
+          <p:cNvSpPr txBox="1"/>
+          <p:nvPr/>
+        </p:nvSpPr>
+        <p:spPr>
+          <a:xfrm>
+            <a:off x="4800600" y="2194560"/>
+            <a:ext cx="3337560" cy="292608"/>
+          </a:xfrm>
+          <a:prstGeom prst="rect">
+            <a:avLst/>
+          </a:prstGeom>
+          <a:noFill/>
+          <a:ln/>
+        </p:spPr>
+        <p:txBody>
+          <a:bodyPr wrap="square" lIns="0" tIns="0" rIns="0" bIns="0" rtlCol="0" anchor="ctr"/>
+          <a:lstStyle/>
+          <a:p>
+            <a:pPr indent="0" marL="0">
+              <a:buNone/>
+            </a:pPr>
+            <a:r>
+              <a:rPr lang="en-US" sz="1300" b="1" dirty="0">
+                <a:solidFill>
+                  <a:schemeClr val="tx2"/>
+                </a:solidFill>
+              </a:rPr>
+              <a:t>How far customers climb, thousand</a:t>
+            </a:r>
+            <a:endParaRPr lang="en-US" sz="1300" dirty="0"/>
+          </a:p>
+        </p:txBody>
+      </p:sp>
+      <p:sp>
+        <p:nvSpPr>
+          <p:cNvPr id="9" name="Ladder label 0"/>
+          <p:cNvSpPr txBox="1"/>
+          <p:nvPr/>
+        </p:nvSpPr>
+        <p:spPr>
+          <a:xfrm>
+            <a:off x="4800600" y="2606040"/>
+            <a:ext cx="1051560" cy="411480"/>
+          </a:xfrm>
+          <a:prstGeom prst="rect">
+            <a:avLst/>
+          </a:prstGeom>
+          <a:noFill/>
+          <a:ln/>
+        </p:spPr>
+        <p:txBody>
+          <a:bodyPr wrap="square" lIns="0" tIns="0" rIns="0" bIns="0" rtlCol="0" anchor="ctr"/>
+          <a:lstStyle/>
+          <a:p>
+            <a:pPr algn="r" indent="0" marL="0">
+              <a:buNone/>
+            </a:pPr>
+            <a:r>
+              <a:rPr lang="en-US" sz="1100" dirty="0">
+                <a:solidFill>
+                  <a:schemeClr val="tx1"/>
+                </a:solidFill>
+              </a:rPr>
+              <a:t>Registered</a:t>
+            </a:r>
+            <a:endParaRPr lang="en-US" sz="1100" dirty="0"/>
+          </a:p>
+        </p:txBody>
+      </p:sp>
+      <p:sp>
+        <p:nvSpPr>
+          <p:cNvPr id="10" name="Ladder bar 0"/>
+          <p:cNvSpPr/>
+          <p:nvPr/>
+        </p:nvSpPr>
+        <p:spPr>
+          <a:xfrm>
+            <a:off x="5943600" y="2651760"/>
+            <a:ext cx="1371600" cy="320040"/>
+          </a:xfrm>
+          <a:prstGeom prst="rect">
+            <a:avLst/>
+          </a:prstGeom>
+          <a:solidFill>
+            <a:schemeClr val="tx2"/>
+          </a:solidFill>
+          <a:ln/>
+        </p:spPr>
+      </p:sp>
+      <p:sp>
+        <p:nvSpPr>
+          <p:cNvPr id="11" name="Ladder value 0"/>
+          <p:cNvSpPr txBox="1"/>
+          <p:nvPr/>
+        </p:nvSpPr>
+        <p:spPr>
+          <a:xfrm>
+            <a:off x="7360920" y="2606040"/>
+            <a:ext cx="777240" cy="411480"/>
+          </a:xfrm>
+          <a:prstGeom prst="rect">
+            <a:avLst/>
+          </a:prstGeom>
+          <a:noFill/>
+          <a:ln/>
+        </p:spPr>
+        <p:txBody>
+          <a:bodyPr wrap="square" lIns="0" tIns="0" rIns="0" bIns="0" rtlCol="0" anchor="ctr"/>
+          <a:lstStyle/>
+          <a:p>
+            <a:pPr indent="0" marL="0">
+              <a:buNone/>
+            </a:pPr>
+            <a:r>
+              <a:rPr lang="en-US" sz="1200" b="1" dirty="0">
+                <a:solidFill>
+                  <a:schemeClr val="tx1"/>
+                </a:solidFill>
+              </a:rPr>
+              <a:t>2,100</a:t>
+            </a:r>
+            <a:endParaRPr lang="en-US" sz="1200" dirty="0"/>
+          </a:p>
+        </p:txBody>
+      </p:sp>
+      <p:sp>
+        <p:nvSpPr>
+          <p:cNvPr id="12" name="Ladder label 1"/>
+          <p:cNvSpPr txBox="1"/>
+          <p:nvPr/>
+        </p:nvSpPr>
+        <p:spPr>
+          <a:xfrm>
+            <a:off x="4800600" y="3172968"/>
+            <a:ext cx="1051560" cy="411480"/>
+          </a:xfrm>
+          <a:prstGeom prst="rect">
+            <a:avLst/>
+          </a:prstGeom>
+          <a:noFill/>
+          <a:ln/>
+        </p:spPr>
+        <p:txBody>
+          <a:bodyPr wrap="square" lIns="0" tIns="0" rIns="0" bIns="0" rtlCol="0" anchor="ctr"/>
+          <a:lstStyle/>
+          <a:p>
+            <a:pPr algn="r" indent="0" marL="0">
+              <a:buNone/>
+            </a:pPr>
+            <a:r>
+              <a:rPr lang="en-US" sz="1100" dirty="0">
+                <a:solidFill>
+                  <a:schemeClr val="tx1"/>
+                </a:solidFill>
+              </a:rPr>
+              <a:t>Account opened</a:t>
+            </a:r>
+            <a:endParaRPr lang="en-US" sz="1100" dirty="0"/>
+          </a:p>
+        </p:txBody>
+      </p:sp>
+      <p:sp>
+        <p:nvSpPr>
+          <p:cNvPr id="13" name="Ladder bar 1"/>
+          <p:cNvSpPr/>
+          <p:nvPr/>
+        </p:nvSpPr>
+        <p:spPr>
+          <a:xfrm>
+            <a:off x="5943600" y="3218688"/>
+            <a:ext cx="979714" cy="320040"/>
+          </a:xfrm>
+          <a:prstGeom prst="rect">
+            <a:avLst/>
+          </a:prstGeom>
+          <a:solidFill>
+            <a:schemeClr val="tx2"/>
+          </a:solidFill>
+          <a:ln/>
+        </p:spPr>
+      </p:sp>
+      <p:sp>
+        <p:nvSpPr>
+          <p:cNvPr id="14" name="Ladder value 1"/>
+          <p:cNvSpPr txBox="1"/>
+          <p:nvPr/>
+        </p:nvSpPr>
+        <p:spPr>
+          <a:xfrm>
+            <a:off x="6969034" y="3172968"/>
+            <a:ext cx="1169126" cy="411480"/>
+          </a:xfrm>
+          <a:prstGeom prst="rect">
+            <a:avLst/>
+          </a:prstGeom>
+          <a:noFill/>
+          <a:ln/>
+        </p:spPr>
+        <p:txBody>
+          <a:bodyPr wrap="square" lIns="0" tIns="0" rIns="0" bIns="0" rtlCol="0" anchor="ctr"/>
+          <a:lstStyle/>
+          <a:p>
+            <a:pPr indent="0" marL="0">
+              <a:buNone/>
+            </a:pPr>
+            <a:r>
+              <a:rPr lang="en-US" sz="1200" b="1" dirty="0">
+                <a:solidFill>
+                  <a:schemeClr val="tx1"/>
+                </a:solidFill>
+              </a:rPr>
+              <a:t>1,500</a:t>
+            </a:r>
+            <a:pPr indent="0" marL="0">
+              <a:buNone/>
+            </a:pPr>
+            <a:r>
+              <a:rPr lang="en-US" sz="1000" dirty="0">
+                <a:solidFill>
+                  <a:srgbClr val="5F6B76"/>
+                </a:solidFill>
+              </a:rPr>
+              <a:t>  71%</a:t>
+            </a:r>
+            <a:endParaRPr lang="en-US" sz="1200" dirty="0"/>
+          </a:p>
+        </p:txBody>
+      </p:sp>
+      <p:sp>
+        <p:nvSpPr>
+          <p:cNvPr id="15" name="Ladder label 2"/>
+          <p:cNvSpPr txBox="1"/>
+          <p:nvPr/>
+        </p:nvSpPr>
+        <p:spPr>
+          <a:xfrm>
+            <a:off x="4800600" y="3739896"/>
+            <a:ext cx="1051560" cy="411480"/>
+          </a:xfrm>
+          <a:prstGeom prst="rect">
+            <a:avLst/>
+          </a:prstGeom>
+          <a:noFill/>
+          <a:ln/>
+        </p:spPr>
+        <p:txBody>
+          <a:bodyPr wrap="square" lIns="0" tIns="0" rIns="0" bIns="0" rtlCol="0" anchor="ctr"/>
+          <a:lstStyle/>
+          <a:p>
+            <a:pPr algn="r" indent="0" marL="0">
+              <a:buNone/>
+            </a:pPr>
+            <a:r>
+              <a:rPr lang="en-US" sz="1100" dirty="0">
+                <a:solidFill>
+                  <a:schemeClr val="tx1"/>
+                </a:solidFill>
+              </a:rPr>
+              <a:t>Money in</a:t>
+            </a:r>
+            <a:endParaRPr lang="en-US" sz="1100" dirty="0"/>
+          </a:p>
+        </p:txBody>
+      </p:sp>
+      <p:sp>
+        <p:nvSpPr>
+          <p:cNvPr id="16" name="Ladder bar 2"/>
+          <p:cNvSpPr/>
+          <p:nvPr/>
+        </p:nvSpPr>
+        <p:spPr>
+          <a:xfrm>
+            <a:off x="5943600" y="3785616"/>
+            <a:ext cx="342900" cy="320040"/>
+          </a:xfrm>
+          <a:prstGeom prst="rect">
+            <a:avLst/>
+          </a:prstGeom>
+          <a:solidFill>
+            <a:schemeClr val="tx2"/>
+          </a:solidFill>
+          <a:ln/>
+        </p:spPr>
+      </p:sp>
+      <p:sp>
+        <p:nvSpPr>
+          <p:cNvPr id="17" name="Ladder value 2"/>
+          <p:cNvSpPr txBox="1"/>
+          <p:nvPr/>
+        </p:nvSpPr>
+        <p:spPr>
+          <a:xfrm>
+            <a:off x="6332220" y="3739896"/>
+            <a:ext cx="1805940" cy="411480"/>
+          </a:xfrm>
+          <a:prstGeom prst="rect">
+            <a:avLst/>
+          </a:prstGeom>
+          <a:noFill/>
+          <a:ln/>
+        </p:spPr>
+        <p:txBody>
+          <a:bodyPr wrap="square" lIns="0" tIns="0" rIns="0" bIns="0" rtlCol="0" anchor="ctr"/>
+          <a:lstStyle/>
+          <a:p>
+            <a:pPr indent="0" marL="0">
+              <a:buNone/>
+            </a:pPr>
+            <a:r>
+              <a:rPr lang="en-US" sz="1200" b="1" dirty="0">
+                <a:solidFill>
+                  <a:schemeClr val="tx1"/>
+                </a:solidFill>
+              </a:rPr>
+              <a:t>525</a:t>
+            </a:r>
+            <a:pPr indent="0" marL="0">
+              <a:buNone/>
+            </a:pPr>
+            <a:r>
+              <a:rPr lang="en-US" sz="1000" dirty="0">
+                <a:solidFill>
+                  <a:srgbClr val="5F6B76"/>
+                </a:solidFill>
+              </a:rPr>
+              <a:t>  35%</a:t>
+            </a:r>
+            <a:endParaRPr lang="en-US" sz="1200" dirty="0"/>
+          </a:p>
+        </p:txBody>
+      </p:sp>
+      <p:sp>
+        <p:nvSpPr>
+          <p:cNvPr id="18" name="Ladder label 3"/>
+          <p:cNvSpPr txBox="1"/>
+          <p:nvPr/>
+        </p:nvSpPr>
+        <p:spPr>
+          <a:xfrm>
+            <a:off x="4800600" y="4306824"/>
+            <a:ext cx="1051560" cy="411480"/>
+          </a:xfrm>
+          <a:prstGeom prst="rect">
+            <a:avLst/>
+          </a:prstGeom>
+          <a:noFill/>
+          <a:ln/>
+        </p:spPr>
+        <p:txBody>
+          <a:bodyPr wrap="square" lIns="0" tIns="0" rIns="0" bIns="0" rtlCol="0" anchor="ctr"/>
+          <a:lstStyle/>
+          <a:p>
+            <a:pPr algn="r" indent="0" marL="0">
+              <a:buNone/>
+            </a:pPr>
+            <a:r>
+              <a:rPr lang="en-US" sz="1100" dirty="0">
+                <a:solidFill>
+                  <a:schemeClr val="tx1"/>
+                </a:solidFill>
+              </a:rPr>
+              <a:t>Paying (Oct)</a:t>
+            </a:r>
+            <a:endParaRPr lang="en-US" sz="1100" dirty="0"/>
+          </a:p>
+        </p:txBody>
+      </p:sp>
+      <p:sp>
+        <p:nvSpPr>
+          <p:cNvPr id="19" name="Ladder bar 3"/>
+          <p:cNvSpPr/>
+          <p:nvPr/>
+        </p:nvSpPr>
+        <p:spPr>
+          <a:xfrm>
+            <a:off x="5943600" y="4352544"/>
+            <a:ext cx="76418" cy="320040"/>
+          </a:xfrm>
+          <a:prstGeom prst="rect">
+            <a:avLst/>
+          </a:prstGeom>
+          <a:solidFill>
+            <a:schemeClr val="accent1"/>
+          </a:solidFill>
+          <a:ln/>
+        </p:spPr>
+      </p:sp>
+      <p:sp>
+        <p:nvSpPr>
+          <p:cNvPr id="20" name="Ladder value 3"/>
+          <p:cNvSpPr txBox="1"/>
+          <p:nvPr/>
+        </p:nvSpPr>
+        <p:spPr>
+          <a:xfrm>
+            <a:off x="6065738" y="4306824"/>
+            <a:ext cx="2072422" cy="411480"/>
+          </a:xfrm>
+          <a:prstGeom prst="rect">
+            <a:avLst/>
+          </a:prstGeom>
+          <a:noFill/>
+          <a:ln/>
+        </p:spPr>
+        <p:txBody>
+          <a:bodyPr wrap="square" lIns="0" tIns="0" rIns="0" bIns="0" rtlCol="0" anchor="ctr"/>
+          <a:lstStyle/>
+          <a:p>
+            <a:pPr indent="0" marL="0">
+              <a:buNone/>
+            </a:pPr>
+            <a:r>
+              <a:rPr lang="en-US" sz="1200" b="1" dirty="0">
+                <a:solidFill>
+                  <a:schemeClr val="tx1"/>
+                </a:solidFill>
+              </a:rPr>
+              <a:t>117</a:t>
+            </a:r>
+            <a:pPr indent="0" marL="0">
+              <a:buNone/>
+            </a:pPr>
+            <a:r>
+              <a:rPr lang="en-US" sz="1000" dirty="0">
+                <a:solidFill>
+                  <a:srgbClr val="5F6B76"/>
+                </a:solidFill>
+              </a:rPr>
+              <a:t>  22%</a:t>
+            </a:r>
+            <a:endParaRPr lang="en-US" sz="1200" dirty="0"/>
+          </a:p>
+        </p:txBody>
+      </p:sp>
+      <p:sp>
+        <p:nvSpPr>
+          <p:cNvPr id="21" name="Ladder label 4"/>
+          <p:cNvSpPr txBox="1"/>
+          <p:nvPr/>
+        </p:nvSpPr>
+        <p:spPr>
+          <a:xfrm>
+            <a:off x="4800600" y="4873752"/>
+            <a:ext cx="1051560" cy="411480"/>
+          </a:xfrm>
+          <a:prstGeom prst="rect">
+            <a:avLst/>
+          </a:prstGeom>
+          <a:noFill/>
+          <a:ln/>
+        </p:spPr>
+        <p:txBody>
+          <a:bodyPr wrap="square" lIns="0" tIns="0" rIns="0" bIns="0" rtlCol="0" anchor="ctr"/>
+          <a:lstStyle/>
+          <a:p>
+            <a:pPr algn="r" indent="0" marL="0">
+              <a:buNone/>
+            </a:pPr>
+            <a:r>
+              <a:rPr lang="en-US" sz="1100" dirty="0">
+                <a:solidFill>
+                  <a:schemeClr val="tx1"/>
+                </a:solidFill>
+              </a:rPr>
+              <a:t>2+ products</a:t>
+            </a:r>
+            <a:endParaRPr lang="en-US" sz="1100" dirty="0"/>
+          </a:p>
+        </p:txBody>
+      </p:sp>
+      <p:sp>
+        <p:nvSpPr>
+          <p:cNvPr id="22" name="Ladder bar 4"/>
+          <p:cNvSpPr/>
+          <p:nvPr/>
+        </p:nvSpPr>
+        <p:spPr>
+          <a:xfrm>
+            <a:off x="5943600" y="4919472"/>
+            <a:ext cx="54864" cy="320040"/>
+          </a:xfrm>
+          <a:prstGeom prst="rect">
+            <a:avLst/>
+          </a:prstGeom>
+          <a:solidFill>
+            <a:schemeClr val="accent1"/>
+          </a:solidFill>
+          <a:ln/>
+        </p:spPr>
+      </p:sp>
+      <p:sp>
+        <p:nvSpPr>
+          <p:cNvPr id="23" name="Ladder value 4"/>
+          <p:cNvSpPr txBox="1"/>
+          <p:nvPr/>
+        </p:nvSpPr>
+        <p:spPr>
+          <a:xfrm>
+            <a:off x="6044184" y="4873752"/>
+            <a:ext cx="2093976" cy="411480"/>
+          </a:xfrm>
+          <a:prstGeom prst="rect">
+            <a:avLst/>
+          </a:prstGeom>
+          <a:noFill/>
+          <a:ln/>
+        </p:spPr>
+        <p:txBody>
+          <a:bodyPr wrap="square" lIns="0" tIns="0" rIns="0" bIns="0" rtlCol="0" anchor="ctr"/>
+          <a:lstStyle/>
+          <a:p>
+            <a:pPr indent="0" marL="0">
+              <a:buNone/>
+            </a:pPr>
+            <a:r>
+              <a:rPr lang="en-US" sz="1200" b="1" dirty="0">
+                <a:solidFill>
+                  <a:schemeClr val="tx1"/>
+                </a:solidFill>
+              </a:rPr>
+              <a:t>51</a:t>
+            </a:r>
+            <a:pPr indent="0" marL="0">
+              <a:buNone/>
+            </a:pPr>
+            <a:r>
+              <a:rPr lang="en-US" sz="1000" dirty="0">
+                <a:solidFill>
+                  <a:srgbClr val="5F6B76"/>
+                </a:solidFill>
+              </a:rPr>
+              <a:t>  44%</a:t>
+            </a:r>
+            <a:endParaRPr lang="en-US" sz="1200" dirty="0"/>
+          </a:p>
+        </p:txBody>
+      </p:sp>
+      <p:sp>
+        <p:nvSpPr>
+          <p:cNvPr id="24" name="Ladder label main"/>
+          <p:cNvSpPr txBox="1"/>
+          <p:nvPr/>
+        </p:nvSpPr>
+        <p:spPr>
+          <a:xfrm>
+            <a:off x="4800600" y="5440680"/>
+            <a:ext cx="1051560" cy="457200"/>
+          </a:xfrm>
+          <a:prstGeom prst="rect">
+            <a:avLst/>
+          </a:prstGeom>
+          <a:noFill/>
+          <a:ln/>
+        </p:spPr>
+        <p:txBody>
+          <a:bodyPr wrap="square" lIns="0" tIns="0" rIns="0" bIns="0" rtlCol="0" anchor="ctr"/>
+          <a:lstStyle/>
+          <a:p>
+            <a:pPr algn="r" indent="0" marL="0">
+              <a:buNone/>
+            </a:pPr>
+            <a:r>
+              <a:rPr lang="en-US" sz="1100" dirty="0">
+                <a:solidFill>
+                  <a:schemeClr val="tx1"/>
+                </a:solidFill>
+              </a:rPr>
+              <a:t>Main bank</a:t>
+            </a:r>
+            <a:endParaRPr lang="en-US" sz="1100" dirty="0"/>
+          </a:p>
+        </p:txBody>
+      </p:sp>
+      <p:sp>
+        <p:nvSpPr>
+          <p:cNvPr id="25" name="Ladder main placeholder"/>
+          <p:cNvSpPr/>
+          <p:nvPr/>
+        </p:nvSpPr>
+        <p:spPr>
+          <a:xfrm>
+            <a:off x="5943600" y="5486400"/>
+            <a:ext cx="2194560" cy="365760"/>
+          </a:xfrm>
+          <a:prstGeom prst="rect">
+            <a:avLst/>
+          </a:prstGeom>
+          <a:solidFill>
+            <a:schemeClr val="bg2"/>
+          </a:solidFill>
+          <a:ln w="12700">
+            <a:solidFill>
+              <a:srgbClr val="A2AAAD"/>
+            </a:solidFill>
+            <a:prstDash val="dash"/>
+          </a:ln>
+        </p:spPr>
+      </p:sp>
+      <p:sp>
+        <p:nvSpPr>
+          <p:cNvPr id="26" name="Ladder main text"/>
+          <p:cNvSpPr txBox="1"/>
+          <p:nvPr/>
+        </p:nvSpPr>
+        <p:spPr>
+          <a:xfrm>
+            <a:off x="5943600" y="5486400"/>
+            <a:ext cx="2194560" cy="365760"/>
+          </a:xfrm>
+          <a:prstGeom prst="rect">
+            <a:avLst/>
+          </a:prstGeom>
+          <a:noFill/>
+          <a:ln/>
+        </p:spPr>
+        <p:txBody>
+          <a:bodyPr wrap="square" lIns="0" tIns="0" rIns="0" bIns="0" rtlCol="0" anchor="ctr"/>
+          <a:lstStyle/>
+          <a:p>
+            <a:pPr algn="ctr" indent="0" marL="0">
+              <a:buNone/>
+            </a:pPr>
+            <a:r>
+              <a:rPr lang="en-US" sz="1000" b="1" dirty="0">
+                <a:solidFill>
+                  <a:schemeClr val="accent5"/>
+                </a:solidFill>
+              </a:rPr>
+              <a:t>Not measured yet</a:t>
+            </a:r>
+            <a:endParaRPr lang="en-US" sz="1000" dirty="0"/>
+          </a:p>
+        </p:txBody>
+      </p:sp>
+      <p:sp>
+        <p:nvSpPr>
+          <p:cNvPr id="27" name="Insight panel"/>
+          <p:cNvSpPr/>
+          <p:nvPr/>
+        </p:nvSpPr>
+        <p:spPr>
+          <a:xfrm>
+            <a:off x="8275320" y="2148840"/>
+            <a:ext cx="3456432" cy="3977640"/>
+          </a:xfrm>
+          <a:prstGeom prst="rect">
+            <a:avLst/>
+          </a:prstGeom>
+          <a:solidFill>
+            <a:schemeClr val="bg2"/>
+          </a:solidFill>
+          <a:ln/>
+        </p:spPr>
+      </p:sp>
+      <p:sp>
+        <p:nvSpPr>
+          <p:cNvPr id="28" name="Insight header"/>
+          <p:cNvSpPr txBox="1"/>
+          <p:nvPr/>
+        </p:nvSpPr>
+        <p:spPr>
+          <a:xfrm>
+            <a:off x="8503920" y="2313432"/>
+            <a:ext cx="2999232" cy="274320"/>
+          </a:xfrm>
+          <a:prstGeom prst="rect">
+            <a:avLst/>
+          </a:prstGeom>
+          <a:noFill/>
+          <a:ln/>
+        </p:spPr>
+        <p:txBody>
+          <a:bodyPr wrap="square" lIns="0" tIns="0" rIns="0" bIns="0" rtlCol="0" anchor="ctr"/>
+          <a:lstStyle/>
+          <a:p>
+            <a:pPr indent="0" marL="0">
+              <a:buNone/>
+            </a:pPr>
+            <a:r>
+              <a:rPr lang="en-US" sz="1100" b="1" spc="100" kern="0" dirty="0">
+                <a:solidFill>
+                  <a:schemeClr val="accent1"/>
+                </a:solidFill>
+              </a:rPr>
+              <a:t>WHAT IT MEANS</a:t>
+            </a:r>
+            <a:endParaRPr lang="en-US" sz="1100" dirty="0"/>
+          </a:p>
+        </p:txBody>
+      </p:sp>
+      <p:sp>
+        <p:nvSpPr>
+          <p:cNvPr id="29" name="Badge 1"/>
+          <p:cNvSpPr/>
+          <p:nvPr/>
+        </p:nvSpPr>
+        <p:spPr>
+          <a:xfrm>
+            <a:off x="8503920" y="2715768"/>
+            <a:ext cx="292608" cy="292608"/>
+          </a:xfrm>
+          <a:prstGeom prst="ellipse">
+            <a:avLst/>
+          </a:prstGeom>
+          <a:solidFill>
+            <a:schemeClr val="tx2"/>
+          </a:solidFill>
+          <a:ln/>
+        </p:spPr>
+      </p:sp>
+      <p:sp>
+        <p:nvSpPr>
+          <p:cNvPr id="30" name="Badge num 1"/>
+          <p:cNvSpPr txBox="1"/>
+          <p:nvPr/>
+        </p:nvSpPr>
+        <p:spPr>
+          <a:xfrm>
+            <a:off x="8503920" y="2715768"/>
+            <a:ext cx="292608" cy="292608"/>
+          </a:xfrm>
+          <a:prstGeom prst="rect">
+            <a:avLst/>
+          </a:prstGeom>
+          <a:noFill/>
+          <a:ln/>
+        </p:spPr>
+        <p:txBody>
+          <a:bodyPr wrap="square" lIns="0" tIns="0" rIns="0" bIns="0" rtlCol="0" anchor="ctr"/>
+          <a:lstStyle/>
+          <a:p>
+            <a:pPr algn="ctr" indent="0" marL="0">
+              <a:buNone/>
+            </a:pPr>
+            <a:r>
+              <a:rPr lang="en-US" sz="1100" b="1" dirty="0">
+                <a:solidFill>
+                  <a:schemeClr val="bg1"/>
+                </a:solidFill>
+              </a:rPr>
+              <a:t>1</a:t>
+            </a:r>
+            <a:endParaRPr lang="en-US" sz="1100" dirty="0"/>
+          </a:p>
+        </p:txBody>
+      </p:sp>
+      <p:sp>
+        <p:nvSpPr>
+          <p:cNvPr id="31" name="Insight 1"/>
+          <p:cNvSpPr txBox="1"/>
+          <p:nvPr/>
+        </p:nvSpPr>
+        <p:spPr>
+          <a:xfrm>
+            <a:off x="8915400" y="2670048"/>
+            <a:ext cx="2633472" cy="1054608"/>
+          </a:xfrm>
+          <a:prstGeom prst="rect">
+            <a:avLst/>
+          </a:prstGeom>
+          <a:noFill/>
+          <a:ln/>
+        </p:spPr>
+        <p:txBody>
+          <a:bodyPr wrap="square" lIns="0" tIns="0" rIns="0" bIns="0" rtlCol="0" anchor="t"/>
+          <a:lstStyle/>
+          <a:p>
+            <a:pPr indent="0" marL="0">
+              <a:spcAft>
+                <a:spcPts val="300"/>
+              </a:spcAft>
+              <a:buNone/>
+            </a:pPr>
+            <a:r>
+              <a:rPr lang="en-US" sz="1400" b="1" dirty="0">
+                <a:solidFill>
+                  <a:schemeClr val="tx2"/>
+                </a:solidFill>
+              </a:rPr>
+              <a:t>Each product pulls in the others</a:t>
+            </a:r>
+            <a:endParaRPr lang="en-US" sz="1400" dirty="0"/>
+          </a:p>
+          <a:p>
+            <a:pPr indent="0" marL="0">
+              <a:spcAft>
+                <a:spcPts val="300"/>
+              </a:spcAft>
+              <a:buNone/>
+            </a:pPr>
+            <a:r>
+              <a:rPr lang="en-US" sz="1200" dirty="0">
+                <a:solidFill>
+                  <a:schemeClr val="tx1"/>
+                </a:solidFill>
+              </a:rPr>
+              <a:t>Holding one makes the other two 2.5–3.7x more likely. Borrowers and payers are the most connected</a:t>
+            </a:r>
+            <a:endParaRPr lang="en-US" sz="1400" dirty="0"/>
+          </a:p>
+        </p:txBody>
+      </p:sp>
+      <p:sp>
+        <p:nvSpPr>
+          <p:cNvPr id="32" name="Badge 2"/>
+          <p:cNvSpPr/>
+          <p:nvPr/>
+        </p:nvSpPr>
+        <p:spPr>
+          <a:xfrm>
+            <a:off x="8503920" y="3843528"/>
+            <a:ext cx="292608" cy="292608"/>
+          </a:xfrm>
+          <a:prstGeom prst="ellipse">
+            <a:avLst/>
+          </a:prstGeom>
+          <a:solidFill>
+            <a:schemeClr val="tx2"/>
+          </a:solidFill>
+          <a:ln/>
+        </p:spPr>
+      </p:sp>
+      <p:sp>
+        <p:nvSpPr>
+          <p:cNvPr id="33" name="Badge num 2"/>
+          <p:cNvSpPr txBox="1"/>
+          <p:nvPr/>
+        </p:nvSpPr>
+        <p:spPr>
+          <a:xfrm>
+            <a:off x="8503920" y="3843528"/>
+            <a:ext cx="292608" cy="292608"/>
+          </a:xfrm>
+          <a:prstGeom prst="rect">
+            <a:avLst/>
+          </a:prstGeom>
+          <a:noFill/>
+          <a:ln/>
+        </p:spPr>
+        <p:txBody>
+          <a:bodyPr wrap="square" lIns="0" tIns="0" rIns="0" bIns="0" rtlCol="0" anchor="ctr"/>
+          <a:lstStyle/>
+          <a:p>
+            <a:pPr algn="ctr" indent="0" marL="0">
+              <a:buNone/>
+            </a:pPr>
+            <a:r>
+              <a:rPr lang="en-US" sz="1100" b="1" dirty="0">
+                <a:solidFill>
+                  <a:schemeClr val="bg1"/>
+                </a:solidFill>
+              </a:rPr>
+              <a:t>2</a:t>
+            </a:r>
+            <a:endParaRPr lang="en-US" sz="1100" dirty="0"/>
+          </a:p>
+        </p:txBody>
+      </p:sp>
+      <p:sp>
+        <p:nvSpPr>
+          <p:cNvPr id="34" name="Insight 2"/>
+          <p:cNvSpPr txBox="1"/>
+          <p:nvPr/>
+        </p:nvSpPr>
+        <p:spPr>
+          <a:xfrm>
+            <a:off x="8915400" y="3797808"/>
+            <a:ext cx="2633472" cy="1054608"/>
+          </a:xfrm>
+          <a:prstGeom prst="rect">
+            <a:avLst/>
+          </a:prstGeom>
+          <a:noFill/>
+          <a:ln/>
+        </p:spPr>
+        <p:txBody>
+          <a:bodyPr wrap="square" lIns="0" tIns="0" rIns="0" bIns="0" rtlCol="0" anchor="t"/>
+          <a:lstStyle/>
+          <a:p>
+            <a:pPr indent="0" marL="0">
+              <a:spcAft>
+                <a:spcPts val="300"/>
+              </a:spcAft>
+              <a:buNone/>
+            </a:pPr>
+            <a:r>
+              <a:rPr lang="en-US" sz="1400" b="1" dirty="0">
+                <a:solidFill>
+                  <a:schemeClr val="tx2"/>
+                </a:solidFill>
+              </a:rPr>
+              <a:t>The chain breaks at step one</a:t>
+            </a:r>
+            <a:endParaRPr lang="en-US" sz="1400" dirty="0"/>
+          </a:p>
+          <a:p>
+            <a:pPr indent="0" marL="0">
+              <a:spcAft>
+                <a:spcPts val="300"/>
+              </a:spcAft>
+              <a:buNone/>
+            </a:pPr>
+            <a:r>
+              <a:rPr lang="en-US" sz="1200" dirty="0">
+                <a:solidFill>
+                  <a:schemeClr val="tx1"/>
+                </a:solidFill>
+              </a:rPr>
+              <a:t>Only 35% of accounts ever get money in, yet 99% of payers have. Money in comes first</a:t>
+            </a:r>
+            <a:endParaRPr lang="en-US" sz="1400" dirty="0"/>
+          </a:p>
+        </p:txBody>
+      </p:sp>
+      <p:sp>
+        <p:nvSpPr>
+          <p:cNvPr id="35" name="Badge 3"/>
+          <p:cNvSpPr/>
+          <p:nvPr/>
+        </p:nvSpPr>
+        <p:spPr>
+          <a:xfrm>
+            <a:off x="8503920" y="4971288"/>
+            <a:ext cx="292608" cy="292608"/>
+          </a:xfrm>
+          <a:prstGeom prst="ellipse">
+            <a:avLst/>
+          </a:prstGeom>
+          <a:solidFill>
+            <a:schemeClr val="tx2"/>
+          </a:solidFill>
+          <a:ln/>
+        </p:spPr>
+      </p:sp>
+      <p:sp>
+        <p:nvSpPr>
+          <p:cNvPr id="36" name="Badge num 3"/>
+          <p:cNvSpPr txBox="1"/>
+          <p:nvPr/>
+        </p:nvSpPr>
+        <p:spPr>
+          <a:xfrm>
+            <a:off x="8503920" y="4971288"/>
+            <a:ext cx="292608" cy="292608"/>
+          </a:xfrm>
+          <a:prstGeom prst="rect">
+            <a:avLst/>
+          </a:prstGeom>
+          <a:noFill/>
+          <a:ln/>
+        </p:spPr>
+        <p:txBody>
+          <a:bodyPr wrap="square" lIns="0" tIns="0" rIns="0" bIns="0" rtlCol="0" anchor="ctr"/>
+          <a:lstStyle/>
+          <a:p>
+            <a:pPr algn="ctr" indent="0" marL="0">
+              <a:buNone/>
+            </a:pPr>
+            <a:r>
+              <a:rPr lang="en-US" sz="1100" b="1" dirty="0">
+                <a:solidFill>
+                  <a:schemeClr val="bg1"/>
+                </a:solidFill>
+              </a:rPr>
+              <a:t>3</a:t>
+            </a:r>
+            <a:endParaRPr lang="en-US" sz="1100" dirty="0"/>
+          </a:p>
+        </p:txBody>
+      </p:sp>
+      <p:sp>
+        <p:nvSpPr>
+          <p:cNvPr id="37" name="Insight 3"/>
+          <p:cNvSpPr txBox="1"/>
+          <p:nvPr/>
+        </p:nvSpPr>
+        <p:spPr>
+          <a:xfrm>
+            <a:off x="8915400" y="4925568"/>
+            <a:ext cx="2633472" cy="1054608"/>
+          </a:xfrm>
+          <a:prstGeom prst="rect">
+            <a:avLst/>
+          </a:prstGeom>
+          <a:noFill/>
+          <a:ln/>
+        </p:spPr>
+        <p:txBody>
+          <a:bodyPr wrap="square" lIns="0" tIns="0" rIns="0" bIns="0" rtlCol="0" anchor="t"/>
+          <a:lstStyle/>
+          <a:p>
+            <a:pPr indent="0" marL="0">
+              <a:spcAft>
+                <a:spcPts val="300"/>
+              </a:spcAft>
+              <a:buNone/>
+            </a:pPr>
+            <a:r>
+              <a:rPr lang="en-US" sz="1400" b="1" dirty="0">
+                <a:solidFill>
+                  <a:schemeClr val="tx2"/>
+                </a:solidFill>
+              </a:rPr>
+              <a:t>Main-bank status isn't tracked</a:t>
+            </a:r>
+            <a:endParaRPr lang="en-US" sz="1400" dirty="0"/>
+          </a:p>
+          <a:p>
+            <a:pPr indent="0" marL="0">
+              <a:spcAft>
+                <a:spcPts val="300"/>
+              </a:spcAft>
+              <a:buNone/>
+            </a:pPr>
+            <a:r>
+              <a:rPr lang="en-US" sz="1200" dirty="0">
+                <a:solidFill>
+                  <a:schemeClr val="tx1"/>
+                </a:solidFill>
+              </a:rPr>
+              <a:t>Main bank = regular income in and regular payments out. Add an income flag to track it</a:t>
+            </a:r>
+            <a:endParaRPr lang="en-US" sz="1400" dirty="0"/>
+          </a:p>
+        </p:txBody>
+      </p:sp>
+      <p:sp>
+        <p:nvSpPr>
+          <p:cNvPr id="25" name="Slide Number Placeholder 0"/>
+          <p:cNvSpPr>
+            <a:spLocks noGrp="1"/>
+          </p:cNvSpPr>
+          <p:nvPr>
+            <p:ph type="sldNum" sz="quarter" idx="4294967295"/>
+          </p:nvPr>
+        </p:nvSpPr>
+        <p:spPr>
+          <a:xfrm>
+            <a:off x="11274552" y="6355080"/>
+            <a:ext cx="457200" cy="274320"/>
+          </a:xfrm>
+          <a:prstGeom prst="rect">
+            <a:avLst/>
+          </a:prstGeom>
+          <a:extLst>
+            <a:ext uri="{C572A759-6A51-4108-AA02-DFA0A04FC94B}">
+              <ma14:wrappingTextBoxFlag xmlns:ma14="http://schemas.microsoft.com/office/mac/drawingml/2011/main" val="0"/>
+            </a:ext>
+          </a:extLst>
+        </p:spPr>
+        <p:txBody>
+          <a:bodyPr/>
+          <a:lstStyle>
+            <a:lvl1pPr>
+              <a:defRPr sz="1000">
+                <a:solidFill>
+                  <a:srgbClr val="6E7C87"/>
+                </a:solidFill>
+              </a:defRPr>
+            </a:lvl1pPr>
+          </a:lstStyle>
+          <a:p>
+            <a:pPr algn="r"/>
+            <a:fld id="{F7021451-1387-4CA6-816F-3879F97B5CBC}" type="slidenum">
+              <a:rPr b="0" lang="en-US"/>
+              <a:t>2</a:t>
+            </a:fld>
+            <a:endParaRPr lang="en-US"/>
+          </a:p>
+        </p:txBody>
+      </p:sp>
+    </p:spTree>
+  </p:cSld>
+  <p:clrMapOvr>
+    <a:masterClrMapping/>
+  </p:clrMapOvr>
+</p:sld>
+</file>
+
+<file path=ppt/slides/slide3.xml><?xml version="1.0" encoding="utf-8"?>
+<p:sld xmlns:a="http://schemas.openxmlformats.org/drawingml/2006/main" xmlns:r="http://schemas.openxmlformats.org/officeDocument/2006/relationships" xmlns:p="http://schemas.openxmlformats.org/presentationml/2006/main">
+  <p:cSld name="Slide 3">
+    <p:spTree>
+      <p:nvGrpSpPr>
+        <p:cNvPr id="1" name=""/>
+        <p:cNvGrpSpPr/>
+        <p:nvPr/>
+      </p:nvGrpSpPr>
+      <p:grpSpPr>
+        <a:xfrm>
+          <a:off x="0" y="0"/>
+          <a:ext cx="0" cy="0"/>
+          <a:chOff x="0" y="0"/>
+          <a:chExt cx="0" cy="0"/>
+        </a:xfrm>
+      </p:grpSpPr>
+      <p:sp>
+        <p:nvSpPr>
+          <p:cNvPr id="2" name="Text 0"/>
+          <p:cNvSpPr/>
+          <p:nvPr>
+            <p:ph idx="100" type="body" hasCustomPrompt="1"/>
+          </p:nvPr>
+        </p:nvSpPr>
+        <p:spPr>
+          <a:xfrm>
+            <a:off x="457200" y="274320"/>
+            <a:ext cx="8229600" cy="274320"/>
+          </a:xfrm>
+          <a:prstGeom prst="rect">
+            <a:avLst/>
+          </a:prstGeom>
+          <a:noFill/>
+          <a:ln/>
+        </p:spPr>
+        <p:txBody>
+          <a:bodyPr wrap="square" lIns="0" tIns="0" rIns="0" bIns="0" rtlCol="0"/>
+          <a:lstStyle/>
+          <a:p>
+            <a:pPr indent="0" marL="0">
+              <a:buNone/>
+            </a:pPr>
+            <a:r>
+              <a:rPr lang="en-US" sz="1100" b="1" spc="100" kern="0" dirty="0">
+                <a:solidFill>
+                  <a:schemeClr val="accent1"/>
+                </a:solidFill>
+              </a:rPr>
+              <a:t>BOARD SUMMARY  (3/3)  |  WHAT WE WILL DO</a:t>
             </a:r>
             <a:endParaRPr lang="en-US" sz="1100" dirty="0"/>
           </a:p>
@@ -3371,7 +6255,7 @@
       </p:sp>
       <p:graphicFrame>
         <p:nvGraphicFramePr>
-          <p:cNvPr id="3" name="Action table"/>
+          <p:cNvPr id="4" name="Action table"/>
           <p:cNvGraphicFramePr>
             <a:graphicFrameLocks noGrp="1"/>
           </p:cNvGraphicFramePr>
@@ -5725,7 +8609,7 @@
             <a:pPr algn="r"/>
             <a:fld id="{F7021451-1387-4CA6-816F-3879F97B5CBC}" type="slidenum">
               <a:rPr b="0" lang="en-US"/>
-              <a:t>2</a:t>
+              <a:t>3</a:t>
             </a:fld>
             <a:endParaRPr lang="en-US"/>
           </a:p>

</xml_diff>

<commit_message>
Board summary: balance sub-groups and balance-vs-use slide
Co-Authored-By: Claude Opus 5.5 <noreply@anthropic.com>
Claude-Session: https://claude.ai/code/session_01PMn7aLX79upLSj9P26uPyP
</commit_message>
<xml_diff>
--- a/clicx_insights/CLICX_Board_Summary.pptx
+++ b/clicx_insights/CLICX_Board_Summary.pptx
@@ -8,9 +8,10 @@
     <p:sldId id="256" r:id="rId2"/>
     <p:sldId id="257" r:id="rId3"/>
     <p:sldId id="258" r:id="rId4"/>
+    <p:sldId id="259" r:id="rId5"/>
   </p:sldIdLst>
   <p:notesMasterIdLst>
-    <p:notesMasterId r:id="rId5"/>
+    <p:notesMasterId r:id="rId6"/>
   </p:notesMasterIdLst>
   <p:sldSz cx="12192000" cy="6858000"/>
   <p:notesSz cx="6858000" cy="12192000"/>
@@ -109,11 +110,12 @@
   <p:extLst>
     <p:ext uri="{521415D9-36F7-43E2-AB2F-B90AF26B5E84}">
       <p14:sectionLst xmlns:p14="http://schemas.microsoft.com/office/powerpoint/2010/main">
-        <p14:section name="Board summary" id="{3784c5e3-906a-1d39-0ce8-7d7949f8a356}">
+        <p14:section name="Board summary" id="{b98f647c-9aaf-f16b-255c-27f0cff642b9}">
           <p14:sldIdLst>
             <p14:sldId id="256"/>
             <p14:sldId id="257"/>
             <p14:sldId id="258"/>
+            <p14:sldId id="259"/>
           </p14:sldIdLst>
         </p14:section>
       </p14:sectionLst>
@@ -1030,6 +1032,689 @@
 </c:chartSpace>
 </file>
 
+<file path=ppt/charts/chart4.xml><?xml version="1.0" encoding="utf-8"?>
+<c:chartSpace xmlns:c="http://schemas.openxmlformats.org/drawingml/2006/chart" xmlns:a="http://schemas.openxmlformats.org/drawingml/2006/main" xmlns:r="http://schemas.openxmlformats.org/officeDocument/2006/relationships">
+  <c:date1904 val="0"/>
+  <c:roundedCorners val="1"/>
+  <c:chart>
+    <c:title>
+      <c:tx>
+        <c:rich>
+          <a:bodyPr/>
+          <a:lstStyle/>
+          <a:p>
+            <a:pPr algn="l">
+              <a:defRPr sz="1300" b="1" i="0" u="none" strike="noStrike">
+                <a:solidFill>
+                  <a:srgbClr val="051C2C"/>
+                </a:solidFill>
+                <a:latin typeface="+mn-lt"/>
+              </a:defRPr>
+            </a:pPr>
+            <a:r>
+              <a:rPr sz="1300" b="1" i="0" u="none" strike="noStrike">
+                <a:solidFill>
+                  <a:srgbClr val="051C2C"/>
+                </a:solidFill>
+                <a:latin typeface="+mn-lt"/>
+              </a:rPr>
+              <a:t>What customers do, by how much they keep with us, %</a:t>
+            </a:r>
+          </a:p>
+        </c:rich>
+      </c:tx>
+      <c:layout/>
+      <c:overlay val="0"/>
+    </c:title>
+    <c:autoTitleDeleted val="0"/>
+    <c:plotArea>
+      <c:layout/>
+      <c:barChart>
+        <c:barDir val="col"/>
+        <c:grouping val="clustered"/>
+        <c:varyColors val="0"/>
+        <c:ser>
+          <c:idx val="0"/>
+          <c:order val="0"/>
+          <c:tx>
+            <c:strRef>
+              <c:f>Sheet1!$B$1</c:f>
+              <c:strCache>
+                <c:ptCount val="1"/>
+                <c:pt idx="0">
+                  <c:v>Has a CLICX loan</c:v>
+                </c:pt>
+              </c:strCache>
+            </c:strRef>
+          </c:tx>
+          <c:spPr>
+            <a:solidFill>
+              <a:srgbClr val="051C2C"/>
+            </a:solidFill>
+            <a:effectLst/>
+          </c:spPr>
+          <c:invertIfNegative val="0"/>
+          <c:dLbls>
+            <c:numFmt formatCode="0%" sourceLinked="0"/>
+            <c:txPr>
+              <a:bodyPr/>
+              <a:lstStyle/>
+              <a:p>
+                <a:pPr>
+                  <a:defRPr b="0" i="0" strike="noStrike" sz="1100" u="none">
+                    <a:solidFill>
+                      <a:srgbClr val="1A1A1A"/>
+                    </a:solidFill>
+                    <a:latin typeface="+mn-lt"/>
+                  </a:defRPr>
+                </a:pPr>
+              </a:p>
+            </c:txPr>
+            <c:showLegendKey val="0"/>
+            <c:showVal val="1"/>
+            <c:showCatName val="0"/>
+            <c:showSerName val="0"/>
+            <c:showPercent val="0"/>
+            <c:showBubbleSize val="0"/>
+            <c:showLeaderLines val="0"/>
+          </c:dLbls>
+          <c:cat>
+            <c:multiLvlStrRef>
+              <c:f>Sheet1!$A$2:$A$5</c:f>
+              <c:multiLvlStrCache>
+                <c:ptCount val="4"/>
+                <c:lvl>
+                  <c:pt idx="0">
+                    <c:v>Zero</c:v>
+                  </c:pt>
+                  <c:pt idx="1">
+                    <c:v>Under 1K</c:v>
+                  </c:pt>
+                  <c:pt idx="2">
+                    <c:v>1K–20K</c:v>
+                  </c:pt>
+                  <c:pt idx="3">
+                    <c:v>20K+</c:v>
+                  </c:pt>
+                </c:lvl>
+              </c:multiLvlStrCache>
+            </c:multiLvlStrRef>
+          </c:cat>
+          <c:val>
+            <c:numRef>
+              <c:f>Sheet1!$B$2:$B$5</c:f>
+              <c:numCache>
+                <c:formatCode>General</c:formatCode>
+                <c:ptCount val="4"/>
+                <c:pt idx="0">
+                  <c:v>0.066</c:v>
+                </c:pt>
+                <c:pt idx="1">
+                  <c:v>0.28</c:v>
+                </c:pt>
+                <c:pt idx="2">
+                  <c:v>0.18</c:v>
+                </c:pt>
+                <c:pt idx="3">
+                  <c:v>0.04</c:v>
+                </c:pt>
+              </c:numCache>
+            </c:numRef>
+          </c:val>
+        </c:ser>
+        <c:ser>
+          <c:idx val="1"/>
+          <c:order val="1"/>
+          <c:tx>
+            <c:strRef>
+              <c:f>Sheet1!$C$1</c:f>
+              <c:strCache>
+                <c:ptCount val="1"/>
+                <c:pt idx="0">
+                  <c:v>Paid with CLICX in Oct</c:v>
+                </c:pt>
+              </c:strCache>
+            </c:strRef>
+          </c:tx>
+          <c:spPr>
+            <a:solidFill>
+              <a:srgbClr val="00A9F4"/>
+            </a:solidFill>
+            <a:effectLst/>
+          </c:spPr>
+          <c:invertIfNegative val="0"/>
+          <c:dLbls>
+            <c:numFmt formatCode="0%" sourceLinked="0"/>
+            <c:txPr>
+              <a:bodyPr/>
+              <a:lstStyle/>
+              <a:p>
+                <a:pPr>
+                  <a:defRPr b="0" i="0" strike="noStrike" sz="1100" u="none">
+                    <a:solidFill>
+                      <a:srgbClr val="1A1A1A"/>
+                    </a:solidFill>
+                    <a:latin typeface="+mn-lt"/>
+                  </a:defRPr>
+                </a:pPr>
+              </a:p>
+            </c:txPr>
+            <c:showLegendKey val="0"/>
+            <c:showVal val="1"/>
+            <c:showCatName val="0"/>
+            <c:showSerName val="0"/>
+            <c:showPercent val="0"/>
+            <c:showBubbleSize val="0"/>
+            <c:showLeaderLines val="0"/>
+          </c:dLbls>
+          <c:cat>
+            <c:multiLvlStrRef>
+              <c:f>Sheet1!$A$2:$A$5</c:f>
+              <c:multiLvlStrCache>
+                <c:ptCount val="4"/>
+                <c:lvl>
+                  <c:pt idx="0">
+                    <c:v>Zero</c:v>
+                  </c:pt>
+                  <c:pt idx="1">
+                    <c:v>Under 1K</c:v>
+                  </c:pt>
+                  <c:pt idx="2">
+                    <c:v>1K–20K</c:v>
+                  </c:pt>
+                  <c:pt idx="3">
+                    <c:v>20K+</c:v>
+                  </c:pt>
+                </c:lvl>
+              </c:multiLvlStrCache>
+            </c:multiLvlStrRef>
+          </c:cat>
+          <c:val>
+            <c:numRef>
+              <c:f>Sheet1!$C$2:$C$5</c:f>
+              <c:numCache>
+                <c:formatCode>General</c:formatCode>
+                <c:ptCount val="4"/>
+                <c:pt idx="0">
+                  <c:v>0.018</c:v>
+                </c:pt>
+                <c:pt idx="1">
+                  <c:v>0.25</c:v>
+                </c:pt>
+                <c:pt idx="2">
+                  <c:v>0.44</c:v>
+                </c:pt>
+                <c:pt idx="3">
+                  <c:v>0.22</c:v>
+                </c:pt>
+              </c:numCache>
+            </c:numRef>
+          </c:val>
+        </c:ser>
+        <c:dLbls>
+          <c:numFmt formatCode="0%" sourceLinked="0"/>
+          <c:txPr>
+            <a:bodyPr/>
+            <a:lstStyle/>
+            <a:p>
+              <a:pPr>
+                <a:defRPr b="0" i="0" strike="noStrike" sz="1100" u="none">
+                  <a:solidFill>
+                    <a:srgbClr val="1A1A1A"/>
+                  </a:solidFill>
+                  <a:latin typeface="+mn-lt"/>
+                </a:defRPr>
+              </a:pPr>
+            </a:p>
+          </c:txPr>
+          <c:showLegendKey val="0"/>
+          <c:showVal val="1"/>
+          <c:showCatName val="0"/>
+          <c:showSerName val="0"/>
+          <c:showPercent val="0"/>
+          <c:showBubbleSize val="0"/>
+          <c:showLeaderLines val="0"/>
+        </c:dLbls>
+        <c:gapWidth val="50"/>
+        <c:overlap val="0"/>
+        <c:axId val="2094734554"/>
+        <c:axId val="2094734552"/>
+        <c:axId val="2094734556"/>
+      </c:barChart>
+      <c:catAx>
+        <c:axId val="2094734554"/>
+        <c:scaling>
+          <c:orientation val="minMax"/>
+        </c:scaling>
+        <c:delete val="0"/>
+        <c:axPos val="b"/>
+        <c:numFmt formatCode="General" sourceLinked="1"/>
+        <c:majorTickMark val="out"/>
+        <c:minorTickMark val="none"/>
+        <c:tickLblPos val="low"/>
+        <c:spPr>
+          <a:ln w="12700" cap="flat">
+            <a:solidFill>
+              <a:srgbClr val="D5DADF"/>
+            </a:solidFill>
+            <a:prstDash val="solid"/>
+            <a:round/>
+          </a:ln>
+        </c:spPr>
+        <c:txPr>
+          <a:bodyPr/>
+          <a:lstStyle/>
+          <a:p>
+            <a:pPr>
+              <a:defRPr sz="1100" b="0" i="0" u="none" strike="noStrike">
+                <a:solidFill>
+                  <a:srgbClr val="5F6B76"/>
+                </a:solidFill>
+                <a:latin typeface="+mn-lt"/>
+              </a:defRPr>
+            </a:pPr>
+            <a:endParaRPr lang="en-US"/>
+          </a:p>
+        </c:txPr>
+        <c:crossAx val="2094734552"/>
+        <c:crosses val="autoZero"/>
+        <c:auto val="1"/>
+        <c:lblAlgn val="ctr"/>
+        <c:noMultiLvlLbl val="1"/>
+      </c:catAx>
+      <c:valAx>
+        <c:axId val="2094734552"/>
+        <c:scaling>
+          <c:orientation val="minMax"/>
+          <c:max val="0.52"/>
+        </c:scaling>
+        <c:delete val="1"/>
+        <c:axPos val="l"/>
+        <c:numFmt formatCode="General" sourceLinked="0"/>
+        <c:majorTickMark val="out"/>
+        <c:minorTickMark val="none"/>
+        <c:tickLblPos val="nextTo"/>
+        <c:spPr>
+          <a:ln w="12700" cap="flat">
+            <a:solidFill>
+              <a:srgbClr val="888888"/>
+            </a:solidFill>
+            <a:prstDash val="solid"/>
+            <a:round/>
+          </a:ln>
+        </c:spPr>
+        <c:txPr>
+          <a:bodyPr/>
+          <a:lstStyle/>
+          <a:p>
+            <a:pPr>
+              <a:defRPr sz="1000" b="0" i="0" u="none" strike="noStrike">
+                <a:solidFill>
+                  <a:srgbClr val="5F6B76"/>
+                </a:solidFill>
+                <a:latin typeface="+mn-lt"/>
+              </a:defRPr>
+            </a:pPr>
+            <a:endParaRPr lang="en-US"/>
+          </a:p>
+        </c:txPr>
+        <c:crossAx val="2094734554"/>
+        <c:crosses val="autoZero"/>
+        <c:crossBetween val="between"/>
+      </c:valAx>
+      <c:spPr>
+        <a:noFill/>
+        <a:ln>
+          <a:noFill/>
+        </a:ln>
+        <a:effectLst/>
+      </c:spPr>
+    </c:plotArea>
+    <c:legend>
+      <c:legendPos val="b"/>
+      <c:overlay val="0"/>
+      <c:txPr>
+        <a:bodyPr/>
+        <a:lstStyle/>
+        <a:p>
+          <a:pPr>
+            <a:defRPr sz="1000">
+              <a:solidFill>
+                <a:srgbClr val="5F6B76"/>
+              </a:solidFill>
+              <a:latin typeface="+mn-lt"/>
+              <a:cs typeface="+mn-lt"/>
+            </a:defRPr>
+          </a:pPr>
+          <a:endParaRPr lang="en-US"/>
+        </a:p>
+      </c:txPr>
+    </c:legend>
+    <c:plotVisOnly val="1"/>
+    <c:dispBlanksAs val="span"/>
+  </c:chart>
+  <c:spPr>
+    <a:noFill/>
+    <a:ln>
+      <a:noFill/>
+    </a:ln>
+    <a:effectLst/>
+  </c:spPr>
+  <c:externalData r:id="rId1">
+    <c:autoUpdate val="0"/>
+  </c:externalData>
+</c:chartSpace>
+</file>
+
+<file path=ppt/charts/chart5.xml><?xml version="1.0" encoding="utf-8"?>
+<c:chartSpace xmlns:c="http://schemas.openxmlformats.org/drawingml/2006/chart" xmlns:a="http://schemas.openxmlformats.org/drawingml/2006/main" xmlns:r="http://schemas.openxmlformats.org/officeDocument/2006/relationships">
+  <c:date1904 val="0"/>
+  <c:roundedCorners val="1"/>
+  <c:chart>
+    <c:title>
+      <c:tx>
+        <c:rich>
+          <a:bodyPr/>
+          <a:lstStyle/>
+          <a:p>
+            <a:pPr algn="l">
+              <a:defRPr sz="1300" b="1" i="0" u="none" strike="noStrike">
+                <a:solidFill>
+                  <a:srgbClr val="051C2C"/>
+                </a:solidFill>
+                <a:latin typeface="+mn-lt"/>
+              </a:defRPr>
+            </a:pPr>
+            <a:r>
+              <a:rPr sz="1300" b="1" i="0" u="none" strike="noStrike">
+                <a:solidFill>
+                  <a:srgbClr val="051C2C"/>
+                </a:solidFill>
+                <a:latin typeface="+mn-lt"/>
+              </a:rPr>
+              <a:t>Where customers sit, thousand</a:t>
+            </a:r>
+          </a:p>
+        </c:rich>
+      </c:tx>
+      <c:layout/>
+      <c:overlay val="0"/>
+    </c:title>
+    <c:autoTitleDeleted val="0"/>
+    <c:plotArea>
+      <c:layout/>
+      <c:barChart>
+        <c:barDir val="bar"/>
+        <c:grouping val="clustered"/>
+        <c:varyColors val="0"/>
+        <c:ser>
+          <c:idx val="0"/>
+          <c:order val="0"/>
+          <c:tx>
+            <c:strRef>
+              <c:f>Sheet1!$B$1</c:f>
+              <c:strCache>
+                <c:ptCount val="1"/>
+                <c:pt idx="0">
+                  <c:v>Customers, K</c:v>
+                </c:pt>
+              </c:strCache>
+            </c:strRef>
+          </c:tx>
+          <c:spPr>
+            <a:solidFill>
+              <a:srgbClr val="D9475C"/>
+            </a:solidFill>
+            <a:effectLst/>
+          </c:spPr>
+          <c:invertIfNegative val="0"/>
+          <c:dLbls>
+            <c:numFmt formatCode="#,##0" sourceLinked="0"/>
+            <c:txPr>
+              <a:bodyPr/>
+              <a:lstStyle/>
+              <a:p>
+                <a:pPr>
+                  <a:defRPr b="0" i="0" strike="noStrike" sz="1100" u="none">
+                    <a:solidFill>
+                      <a:srgbClr val="1A1A1A"/>
+                    </a:solidFill>
+                    <a:latin typeface="+mn-lt"/>
+                  </a:defRPr>
+                </a:pPr>
+              </a:p>
+            </c:txPr>
+            <c:showLegendKey val="0"/>
+            <c:showVal val="1"/>
+            <c:showCatName val="0"/>
+            <c:showSerName val="0"/>
+            <c:showPercent val="0"/>
+            <c:showBubbleSize val="0"/>
+            <c:showLeaderLines val="0"/>
+          </c:dLbls>
+          <c:dPt>
+            <c:idx val="0"/>
+            <c:invertIfNegative val="0"/>
+            <c:bubble3D val="0"/>
+            <c:spPr>
+              <a:solidFill>
+                <a:srgbClr val="D9475C"/>
+              </a:solidFill>
+              <a:effectLst/>
+            </c:spPr>
+          </c:dPt>
+          <c:dPt>
+            <c:idx val="1"/>
+            <c:invertIfNegative val="0"/>
+            <c:bubble3D val="0"/>
+            <c:spPr>
+              <a:solidFill>
+                <a:srgbClr val="A2AAAD"/>
+              </a:solidFill>
+              <a:effectLst/>
+            </c:spPr>
+          </c:dPt>
+          <c:dPt>
+            <c:idx val="2"/>
+            <c:invertIfNegative val="0"/>
+            <c:bubble3D val="0"/>
+            <c:spPr>
+              <a:solidFill>
+                <a:srgbClr val="2251FF"/>
+              </a:solidFill>
+              <a:effectLst/>
+            </c:spPr>
+          </c:dPt>
+          <c:dPt>
+            <c:idx val="3"/>
+            <c:invertIfNegative val="0"/>
+            <c:bubble3D val="0"/>
+            <c:spPr>
+              <a:solidFill>
+                <a:srgbClr val="051C2C"/>
+              </a:solidFill>
+              <a:effectLst/>
+            </c:spPr>
+          </c:dPt>
+          <c:cat>
+            <c:multiLvlStrRef>
+              <c:f>Sheet1!$A$2:$A$5</c:f>
+              <c:multiLvlStrCache>
+                <c:ptCount val="4"/>
+                <c:lvl>
+                  <c:pt idx="0">
+                    <c:v>Zero</c:v>
+                  </c:pt>
+                  <c:pt idx="1">
+                    <c:v>Under 1K</c:v>
+                  </c:pt>
+                  <c:pt idx="2">
+                    <c:v>1K–20K</c:v>
+                  </c:pt>
+                  <c:pt idx="3">
+                    <c:v>20K+</c:v>
+                  </c:pt>
+                </c:lvl>
+              </c:multiLvlStrCache>
+            </c:multiLvlStrRef>
+          </c:cat>
+          <c:val>
+            <c:numRef>
+              <c:f>Sheet1!$B$2:$B$5</c:f>
+              <c:numCache>
+                <c:formatCode>General</c:formatCode>
+                <c:ptCount val="4"/>
+                <c:pt idx="0">
+                  <c:v>1142</c:v>
+                </c:pt>
+                <c:pt idx="1">
+                  <c:v>288</c:v>
+                </c:pt>
+                <c:pt idx="2">
+                  <c:v>42</c:v>
+                </c:pt>
+                <c:pt idx="3">
+                  <c:v>29</c:v>
+                </c:pt>
+              </c:numCache>
+            </c:numRef>
+          </c:val>
+        </c:ser>
+        <c:dLbls>
+          <c:numFmt formatCode="#,##0" sourceLinked="0"/>
+          <c:txPr>
+            <a:bodyPr/>
+            <a:lstStyle/>
+            <a:p>
+              <a:pPr>
+                <a:defRPr b="0" i="0" strike="noStrike" sz="1100" u="none">
+                  <a:solidFill>
+                    <a:srgbClr val="1A1A1A"/>
+                  </a:solidFill>
+                  <a:latin typeface="+mn-lt"/>
+                </a:defRPr>
+              </a:pPr>
+            </a:p>
+          </c:txPr>
+          <c:showLegendKey val="0"/>
+          <c:showVal val="1"/>
+          <c:showCatName val="0"/>
+          <c:showSerName val="0"/>
+          <c:showPercent val="0"/>
+          <c:showBubbleSize val="0"/>
+          <c:showLeaderLines val="0"/>
+        </c:dLbls>
+        <c:gapWidth val="40"/>
+        <c:overlap val="0"/>
+        <c:axId val="2094734554"/>
+        <c:axId val="2094734552"/>
+        <c:axId val="2094734556"/>
+      </c:barChart>
+      <c:catAx>
+        <c:axId val="2094734554"/>
+        <c:scaling>
+          <c:orientation val="maxMin"/>
+        </c:scaling>
+        <c:delete val="0"/>
+        <c:axPos val="l"/>
+        <c:numFmt formatCode="General" sourceLinked="1"/>
+        <c:majorTickMark val="out"/>
+        <c:minorTickMark val="none"/>
+        <c:tickLblPos val="nextTo"/>
+        <c:spPr>
+          <a:ln w="12700" cap="flat">
+            <a:solidFill>
+              <a:srgbClr val="D5DADF"/>
+            </a:solidFill>
+            <a:prstDash val="solid"/>
+            <a:round/>
+          </a:ln>
+        </c:spPr>
+        <c:txPr>
+          <a:bodyPr/>
+          <a:lstStyle/>
+          <a:p>
+            <a:pPr>
+              <a:defRPr sz="1100" b="0" i="0" u="none" strike="noStrike">
+                <a:solidFill>
+                  <a:srgbClr val="5F6B76"/>
+                </a:solidFill>
+                <a:latin typeface="+mn-lt"/>
+              </a:defRPr>
+            </a:pPr>
+            <a:endParaRPr lang="en-US"/>
+          </a:p>
+        </c:txPr>
+        <c:crossAx val="2094734552"/>
+        <c:crosses val="autoZero"/>
+        <c:auto val="1"/>
+        <c:lblAlgn val="ctr"/>
+        <c:noMultiLvlLbl val="1"/>
+      </c:catAx>
+      <c:valAx>
+        <c:axId val="2094734552"/>
+        <c:scaling>
+          <c:orientation val="minMax"/>
+          <c:max val="1450"/>
+        </c:scaling>
+        <c:delete val="1"/>
+        <c:axPos val="b"/>
+        <c:numFmt formatCode="General" sourceLinked="0"/>
+        <c:majorTickMark val="out"/>
+        <c:minorTickMark val="none"/>
+        <c:tickLblPos val="low"/>
+        <c:spPr>
+          <a:ln w="12700" cap="flat">
+            <a:solidFill>
+              <a:srgbClr val="888888"/>
+            </a:solidFill>
+            <a:prstDash val="solid"/>
+            <a:round/>
+          </a:ln>
+        </c:spPr>
+        <c:txPr>
+          <a:bodyPr/>
+          <a:lstStyle/>
+          <a:p>
+            <a:pPr>
+              <a:defRPr sz="1000" b="0" i="0" u="none" strike="noStrike">
+                <a:solidFill>
+                  <a:srgbClr val="5F6B76"/>
+                </a:solidFill>
+                <a:latin typeface="+mn-lt"/>
+              </a:defRPr>
+            </a:pPr>
+            <a:endParaRPr lang="en-US"/>
+          </a:p>
+        </c:txPr>
+        <c:crossAx val="2094734554"/>
+        <c:crosses val="autoZero"/>
+        <c:crossBetween val="between"/>
+      </c:valAx>
+      <c:spPr>
+        <a:noFill/>
+        <a:ln>
+          <a:noFill/>
+        </a:ln>
+        <a:effectLst/>
+      </c:spPr>
+    </c:plotArea>
+    <c:plotVisOnly val="1"/>
+    <c:dispBlanksAs val="span"/>
+  </c:chart>
+  <c:spPr>
+    <a:noFill/>
+    <a:ln>
+      <a:noFill/>
+    </a:ln>
+    <a:effectLst/>
+  </c:spPr>
+  <c:externalData r:id="rId1">
+    <c:autoUpdate val="0"/>
+  </c:externalData>
+</c:chartSpace>
+</file>
+
 <file path=ppt/notesMasters/notesMaster1.xml><?xml version="1.0" encoding="utf-8"?>
 <p:notesMaster xmlns:a="http://schemas.openxmlformats.org/drawingml/2006/main" xmlns:r="http://schemas.openxmlformats.org/officeDocument/2006/relationships" xmlns:p="http://schemas.openxmlformats.org/presentationml/2006/main">
   <p:cSld>
@@ -1625,6 +2310,94 @@
             <a:fld id="{F7021451-1387-4CA6-816F-3879F97B5CBC}" type="slidenum">
               <a:rPr lang="en-US"/>
               <a:t>3</a:t>
+            </a:fld>
+            <a:endParaRPr lang="en-US"/>
+          </a:p>
+        </p:txBody>
+      </p:sp>
+    </p:spTree>
+    <p:extLst>
+      <p:ext uri="{BB962C8B-B14F-4D97-AF65-F5344CB8AC3E}">
+        <p14:creationId xmlns:p14="http://schemas.microsoft.com/office/powerpoint/2010/main" val="1024086991"/>
+      </p:ext>
+    </p:extLst>
+  </p:cSld>
+  <p:clrMapOvr>
+    <a:masterClrMapping/>
+  </p:clrMapOvr>
+</p:notes>
+</file>
+
+<file path=ppt/notesSlides/notesSlide4.xml><?xml version="1.0" encoding="utf-8"?>
+<p:notes xmlns:a="http://schemas.openxmlformats.org/drawingml/2006/main" xmlns:r="http://schemas.openxmlformats.org/officeDocument/2006/relationships" xmlns:p="http://schemas.openxmlformats.org/presentationml/2006/main">
+  <p:cSld>
+    <p:spTree>
+      <p:nvGrpSpPr>
+        <p:cNvPr id="1" name=""/>
+        <p:cNvGrpSpPr/>
+        <p:nvPr/>
+      </p:nvGrpSpPr>
+      <p:grpSpPr>
+        <a:xfrm>
+          <a:off x="0" y="0"/>
+          <a:ext cx="0" cy="0"/>
+          <a:chOff x="0" y="0"/>
+          <a:chExt cx="0" cy="0"/>
+        </a:xfrm>
+      </p:grpSpPr>
+      <p:sp>
+        <p:nvSpPr>
+          <p:cNvPr id="2" name="Slide Image Placeholder 1"/>
+          <p:cNvSpPr>
+            <a:spLocks noGrp="1" noRot="1" noChangeAspect="1"/>
+          </p:cNvSpPr>
+          <p:nvPr>
+            <p:ph type="sldImg"/>
+          </p:nvPr>
+        </p:nvSpPr>
+        <p:spPr/>
+      </p:sp>
+      <p:sp>
+        <p:nvSpPr>
+          <p:cNvPr id="3" name="Notes Placeholder 2"/>
+          <p:cNvSpPr>
+            <a:spLocks noGrp="1"/>
+          </p:cNvSpPr>
+          <p:nvPr>
+            <p:ph type="body" idx="1"/>
+          </p:nvPr>
+        </p:nvSpPr>
+        <p:spPr/>
+        <p:txBody>
+          <a:bodyPr/>
+          <a:lstStyle/>
+          <a:p>
+            <a:r>
+              <a:rPr lang="en-US" dirty="0"/>
+              <a:t/>
+            </a:r>
+            <a:endParaRPr lang="en-US" dirty="0"/>
+          </a:p>
+        </p:txBody>
+      </p:sp>
+      <p:sp>
+        <p:nvSpPr>
+          <p:cNvPr id="4" name="Slide Number Placeholder 3"/>
+          <p:cNvSpPr>
+            <a:spLocks noGrp="1"/>
+          </p:cNvSpPr>
+          <p:nvPr>
+            <p:ph type="sldNum" sz="quarter" idx="10"/>
+          </p:nvPr>
+        </p:nvSpPr>
+        <p:spPr/>
+        <p:txBody>
+          <a:bodyPr/>
+          <a:lstStyle/>
+          <a:p>
+            <a:fld id="{F7021451-1387-4CA6-816F-3879F97B5CBC}" type="slidenum">
+              <a:rPr lang="en-US"/>
+              <a:t>4</a:t>
             </a:fld>
             <a:endParaRPr lang="en-US"/>
           </a:p>
@@ -2515,7 +3288,7 @@
                   <a:schemeClr val="accent1"/>
                 </a:solidFill>
               </a:rPr>
-              <a:t>BOARD SUMMARY  (1/3)  |  WHAT EXISTING CUSTOMERS DO</a:t>
+              <a:t>BOARD SUMMARY  (1/4)  |  WHAT EXISTING CUSTOMERS DO</a:t>
             </a:r>
             <a:endParaRPr lang="en-US" sz="1100" dirty="0"/>
           </a:p>
@@ -3339,7 +4112,7 @@
                   <a:schemeClr val="accent1"/>
                 </a:solidFill>
               </a:rPr>
-              <a:t>BOARD SUMMARY  (2/3)  |  HOW PRODUCTS CONNECT</a:t>
+              <a:t>BOARD SUMMARY  (2/4)  |  HOW PRODUCTS CONNECT</a:t>
             </a:r>
             <a:endParaRPr lang="en-US" sz="1100" dirty="0"/>
           </a:p>
@@ -3453,7 +4226,7 @@
                   <a:srgbClr val="6E7C87"/>
                 </a:solidFill>
               </a:rPr>
-              <a:t>x = times more likely than the average customer. Ladder % = share of the step before. Source: CLICX product and payment segments, 1 Oct 2026 (1.50M accounts); registration funnel from CLICX 5-Year Business Plan</a:t>
+              <a:t>x = times as likely as the average customer. Balance rows use current balance; a 100-baht cut is not in the data yet. Ladder % = share of the step before; main bank = regular income in and payments out. Source: CLICX product and payment segments, 1 Oct 2026 (1.50M accounts); registration funnel from CLICX 5-Year Business Plan</a:t>
             </a:r>
             <a:endParaRPr lang="en-US" sz="1000" dirty="0"/>
           </a:p>
@@ -3523,7 +4296,7 @@
                 <a:gridCol w="960120"/>
                 <a:gridCol w="960120"/>
               </a:tblGrid>
-              <a:tr h="457200">
+              <a:tr h="420624">
                 <a:tc>
                   <a:txBody>
                     <a:bodyPr/>
@@ -3797,7 +4570,7 @@
                   </a:tcPr>
                 </a:tc>
               </a:tr>
-              <a:tr h="457200">
+              <a:tr h="384048">
                 <a:tc>
                   <a:txBody>
                     <a:bodyPr/>
@@ -4068,7 +4841,7 @@
                   </a:tcPr>
                 </a:tc>
               </a:tr>
-              <a:tr h="777240">
+              <a:tr h="548640">
                 <a:tc>
                   <a:txBody>
                     <a:bodyPr/>
@@ -4378,7 +5151,627 @@
                   </a:tcPr>
                 </a:tc>
               </a:tr>
-              <a:tr h="777240">
+              <a:tr h="502920">
+                <a:tc>
+                  <a:txBody>
+                    <a:bodyPr/>
+                    <a:lstStyle/>
+                    <a:p>
+                      <a:pPr lvl="1" indent="0" marL="0">
+                        <a:buNone/>
+                      </a:pPr>
+                      <a:r>
+                        <a:rPr lang="en-US" sz="1000" dirty="0">
+                          <a:solidFill>
+                            <a:srgbClr val="051C2C"/>
+                          </a:solidFill>
+                          <a:latin typeface="Arial" pitchFamily="34" charset="0"/>
+                          <a:ea typeface="Arial" pitchFamily="34" charset="-122"/>
+                          <a:cs typeface="Arial" pitchFamily="34" charset="-120"/>
+                        </a:rPr>
+                        <a:t>↳ Balance 1K+ today (71K)</a:t>
+                      </a:r>
+                      <a:endParaRPr lang="en-US" sz="1000" dirty="0">
+                        <a:latin typeface="Arial" charset="0"/>
+                        <a:ea typeface="Arial" charset="0"/>
+                        <a:cs typeface="Arial" charset="0"/>
+                      </a:endParaRPr>
+                    </a:p>
+                  </a:txBody>
+                  <a:tcPr marL="54864" marR="54864" marT="36576" marB="36576" anchor="ctr">
+                    <a:lnL w="19050" cap="flat" cmpd="sng" algn="ctr">
+                      <a:solidFill>
+                        <a:srgbClr val="FFFFFF"/>
+                      </a:solidFill>
+                      <a:prstDash val="solid"/>
+                      <a:round/>
+                      <a:headEnd type="none" w="med" len="med"/>
+                      <a:tailEnd type="none" w="med" len="med"/>
+                    </a:lnL>
+                    <a:lnR w="19050" cap="flat" cmpd="sng" algn="ctr">
+                      <a:solidFill>
+                        <a:srgbClr val="FFFFFF"/>
+                      </a:solidFill>
+                      <a:prstDash val="solid"/>
+                      <a:round/>
+                      <a:headEnd type="none" w="med" len="med"/>
+                      <a:tailEnd type="none" w="med" len="med"/>
+                    </a:lnR>
+                    <a:lnT w="19050" cap="flat" cmpd="sng" algn="ctr">
+                      <a:solidFill>
+                        <a:srgbClr val="FFFFFF"/>
+                      </a:solidFill>
+                      <a:prstDash val="solid"/>
+                      <a:round/>
+                      <a:headEnd type="none" w="med" len="med"/>
+                      <a:tailEnd type="none" w="med" len="med"/>
+                    </a:lnT>
+                    <a:lnB w="19050" cap="flat" cmpd="sng" algn="ctr">
+                      <a:solidFill>
+                        <a:srgbClr val="FFFFFF"/>
+                      </a:solidFill>
+                      <a:prstDash val="solid"/>
+                      <a:round/>
+                      <a:headEnd type="none" w="med" len="med"/>
+                      <a:tailEnd type="none" w="med" len="med"/>
+                    </a:lnB>
+                  </a:tcPr>
+                </a:tc>
+                <a:tc>
+                  <a:txBody>
+                    <a:bodyPr/>
+                    <a:lstStyle/>
+                    <a:p>
+                      <a:pPr algn="ctr" indent="0" marL="0">
+                        <a:buNone/>
+                      </a:pPr>
+                      <a:r>
+                        <a:rPr lang="en-US" sz="1000" dirty="0">
+                          <a:solidFill>
+                            <a:srgbClr val="5F6B76"/>
+                          </a:solidFill>
+                          <a:latin typeface="Arial" pitchFamily="34" charset="0"/>
+                          <a:ea typeface="Arial" pitchFamily="34" charset="-122"/>
+                          <a:cs typeface="Arial" pitchFamily="34" charset="-120"/>
+                        </a:rPr>
+                        <a:t>all</a:t>
+                      </a:r>
+                      <a:endParaRPr lang="en-US" sz="1000" dirty="0">
+                        <a:latin typeface="Arial" charset="0"/>
+                        <a:ea typeface="Arial" charset="0"/>
+                        <a:cs typeface="Arial" charset="0"/>
+                      </a:endParaRPr>
+                    </a:p>
+                  </a:txBody>
+                  <a:tcPr marL="54864" marR="54864" marT="36576" marB="36576" anchor="ctr">
+                    <a:lnL w="19050" cap="flat" cmpd="sng" algn="ctr">
+                      <a:solidFill>
+                        <a:srgbClr val="FFFFFF"/>
+                      </a:solidFill>
+                      <a:prstDash val="solid"/>
+                      <a:round/>
+                      <a:headEnd type="none" w="med" len="med"/>
+                      <a:tailEnd type="none" w="med" len="med"/>
+                    </a:lnL>
+                    <a:lnR w="19050" cap="flat" cmpd="sng" algn="ctr">
+                      <a:solidFill>
+                        <a:srgbClr val="FFFFFF"/>
+                      </a:solidFill>
+                      <a:prstDash val="solid"/>
+                      <a:round/>
+                      <a:headEnd type="none" w="med" len="med"/>
+                      <a:tailEnd type="none" w="med" len="med"/>
+                    </a:lnR>
+                    <a:lnT w="19050" cap="flat" cmpd="sng" algn="ctr">
+                      <a:solidFill>
+                        <a:srgbClr val="FFFFFF"/>
+                      </a:solidFill>
+                      <a:prstDash val="solid"/>
+                      <a:round/>
+                      <a:headEnd type="none" w="med" len="med"/>
+                      <a:tailEnd type="none" w="med" len="med"/>
+                    </a:lnT>
+                    <a:lnB w="19050" cap="flat" cmpd="sng" algn="ctr">
+                      <a:solidFill>
+                        <a:srgbClr val="FFFFFF"/>
+                      </a:solidFill>
+                      <a:prstDash val="solid"/>
+                      <a:round/>
+                      <a:headEnd type="none" w="med" len="med"/>
+                      <a:tailEnd type="none" w="med" len="med"/>
+                    </a:lnB>
+                  </a:tcPr>
+                </a:tc>
+                <a:tc>
+                  <a:txBody>
+                    <a:bodyPr/>
+                    <a:lstStyle/>
+                    <a:p>
+                      <a:pPr algn="ctr" indent="0" marL="0">
+                        <a:buNone/>
+                      </a:pPr>
+                      <a:r>
+                        <a:rPr lang="en-US" sz="1300" b="1" dirty="0">
+                          <a:solidFill>
+                            <a:srgbClr val="1A1A1A"/>
+                          </a:solidFill>
+                          <a:latin typeface="Arial" pitchFamily="34" charset="0"/>
+                          <a:ea typeface="Arial" pitchFamily="34" charset="-122"/>
+                          <a:cs typeface="Arial" pitchFamily="34" charset="-120"/>
+                        </a:rPr>
+                        <a:t>12%</a:t>
+                      </a:r>
+                      <a:endParaRPr lang="en-US" sz="1200" dirty="0">
+                        <a:latin typeface="Arial" charset="0"/>
+                        <a:ea typeface="Arial" charset="0"/>
+                        <a:cs typeface="Arial" charset="0"/>
+                      </a:endParaRPr>
+                    </a:p>
+                    <a:p>
+                      <a:pPr algn="ctr" indent="0" marL="0">
+                        <a:buNone/>
+                      </a:pPr>
+                      <a:r>
+                        <a:rPr lang="en-US" sz="950" dirty="0">
+                          <a:solidFill>
+                            <a:srgbClr val="1A1A1A"/>
+                          </a:solidFill>
+                          <a:latin typeface="Arial" pitchFamily="34" charset="0"/>
+                          <a:ea typeface="Arial" pitchFamily="34" charset="-122"/>
+                          <a:cs typeface="Arial" pitchFamily="34" charset="-120"/>
+                        </a:rPr>
+                        <a:t>about average</a:t>
+                      </a:r>
+                      <a:endParaRPr lang="en-US" sz="1200" dirty="0">
+                        <a:latin typeface="Arial" charset="0"/>
+                        <a:ea typeface="Arial" charset="0"/>
+                        <a:cs typeface="Arial" charset="0"/>
+                      </a:endParaRPr>
+                    </a:p>
+                  </a:txBody>
+                  <a:tcPr marL="54864" marR="54864" marT="36576" marB="36576" anchor="ctr">
+                    <a:lnL w="19050" cap="flat" cmpd="sng" algn="ctr">
+                      <a:solidFill>
+                        <a:srgbClr val="FFFFFF"/>
+                      </a:solidFill>
+                      <a:prstDash val="solid"/>
+                      <a:round/>
+                      <a:headEnd type="none" w="med" len="med"/>
+                      <a:tailEnd type="none" w="med" len="med"/>
+                    </a:lnL>
+                    <a:lnR w="19050" cap="flat" cmpd="sng" algn="ctr">
+                      <a:solidFill>
+                        <a:srgbClr val="FFFFFF"/>
+                      </a:solidFill>
+                      <a:prstDash val="solid"/>
+                      <a:round/>
+                      <a:headEnd type="none" w="med" len="med"/>
+                      <a:tailEnd type="none" w="med" len="med"/>
+                    </a:lnR>
+                    <a:lnT w="19050" cap="flat" cmpd="sng" algn="ctr">
+                      <a:solidFill>
+                        <a:srgbClr val="FFFFFF"/>
+                      </a:solidFill>
+                      <a:prstDash val="solid"/>
+                      <a:round/>
+                      <a:headEnd type="none" w="med" len="med"/>
+                      <a:tailEnd type="none" w="med" len="med"/>
+                    </a:lnT>
+                    <a:lnB w="19050" cap="flat" cmpd="sng" algn="ctr">
+                      <a:solidFill>
+                        <a:srgbClr val="FFFFFF"/>
+                      </a:solidFill>
+                      <a:prstDash val="solid"/>
+                      <a:round/>
+                      <a:headEnd type="none" w="med" len="med"/>
+                      <a:tailEnd type="none" w="med" len="med"/>
+                    </a:lnB>
+                    <a:solidFill>
+                      <a:srgbClr val="F2F4F7"/>
+                    </a:solidFill>
+                  </a:tcPr>
+                </a:tc>
+                <a:tc>
+                  <a:txBody>
+                    <a:bodyPr/>
+                    <a:lstStyle/>
+                    <a:p>
+                      <a:pPr algn="ctr" indent="0" marL="0">
+                        <a:buNone/>
+                      </a:pPr>
+                      <a:r>
+                        <a:rPr lang="en-US" sz="1300" b="1" dirty="0">
+                          <a:solidFill>
+                            <a:srgbClr val="FFFFFF"/>
+                          </a:solidFill>
+                          <a:latin typeface="Arial" pitchFamily="34" charset="0"/>
+                          <a:ea typeface="Arial" pitchFamily="34" charset="-122"/>
+                          <a:cs typeface="Arial" pitchFamily="34" charset="-120"/>
+                        </a:rPr>
+                        <a:t>35%</a:t>
+                      </a:r>
+                      <a:endParaRPr lang="en-US" sz="1200" dirty="0">
+                        <a:latin typeface="Arial" charset="0"/>
+                        <a:ea typeface="Arial" charset="0"/>
+                        <a:cs typeface="Arial" charset="0"/>
+                      </a:endParaRPr>
+                    </a:p>
+                    <a:p>
+                      <a:pPr algn="ctr" indent="0" marL="0">
+                        <a:buNone/>
+                      </a:pPr>
+                      <a:r>
+                        <a:rPr lang="en-US" sz="950" dirty="0">
+                          <a:solidFill>
+                            <a:srgbClr val="FFFFFF"/>
+                          </a:solidFill>
+                          <a:latin typeface="Arial" pitchFamily="34" charset="0"/>
+                          <a:ea typeface="Arial" pitchFamily="34" charset="-122"/>
+                          <a:cs typeface="Arial" pitchFamily="34" charset="-120"/>
+                        </a:rPr>
+                        <a:t>4.5x more likely</a:t>
+                      </a:r>
+                      <a:endParaRPr lang="en-US" sz="1200" dirty="0">
+                        <a:latin typeface="Arial" charset="0"/>
+                        <a:ea typeface="Arial" charset="0"/>
+                        <a:cs typeface="Arial" charset="0"/>
+                      </a:endParaRPr>
+                    </a:p>
+                  </a:txBody>
+                  <a:tcPr marL="54864" marR="54864" marT="36576" marB="36576" anchor="ctr">
+                    <a:lnL w="19050" cap="flat" cmpd="sng" algn="ctr">
+                      <a:solidFill>
+                        <a:srgbClr val="FFFFFF"/>
+                      </a:solidFill>
+                      <a:prstDash val="solid"/>
+                      <a:round/>
+                      <a:headEnd type="none" w="med" len="med"/>
+                      <a:tailEnd type="none" w="med" len="med"/>
+                    </a:lnL>
+                    <a:lnR w="19050" cap="flat" cmpd="sng" algn="ctr">
+                      <a:solidFill>
+                        <a:srgbClr val="FFFFFF"/>
+                      </a:solidFill>
+                      <a:prstDash val="solid"/>
+                      <a:round/>
+                      <a:headEnd type="none" w="med" len="med"/>
+                      <a:tailEnd type="none" w="med" len="med"/>
+                    </a:lnR>
+                    <a:lnT w="19050" cap="flat" cmpd="sng" algn="ctr">
+                      <a:solidFill>
+                        <a:srgbClr val="FFFFFF"/>
+                      </a:solidFill>
+                      <a:prstDash val="solid"/>
+                      <a:round/>
+                      <a:headEnd type="none" w="med" len="med"/>
+                      <a:tailEnd type="none" w="med" len="med"/>
+                    </a:lnT>
+                    <a:lnB w="19050" cap="flat" cmpd="sng" algn="ctr">
+                      <a:solidFill>
+                        <a:srgbClr val="FFFFFF"/>
+                      </a:solidFill>
+                      <a:prstDash val="solid"/>
+                      <a:round/>
+                      <a:headEnd type="none" w="med" len="med"/>
+                      <a:tailEnd type="none" w="med" len="med"/>
+                    </a:lnB>
+                    <a:solidFill>
+                      <a:srgbClr val="051C2C"/>
+                    </a:solidFill>
+                  </a:tcPr>
+                </a:tc>
+              </a:tr>
+              <a:tr h="502920">
+                <a:tc>
+                  <a:txBody>
+                    <a:bodyPr/>
+                    <a:lstStyle/>
+                    <a:p>
+                      <a:pPr lvl="1" indent="0" marL="0">
+                        <a:buNone/>
+                      </a:pPr>
+                      <a:r>
+                        <a:rPr lang="en-US" sz="1000" dirty="0">
+                          <a:solidFill>
+                            <a:srgbClr val="051C2C"/>
+                          </a:solidFill>
+                          <a:latin typeface="Arial" pitchFamily="34" charset="0"/>
+                          <a:ea typeface="Arial" pitchFamily="34" charset="-122"/>
+                          <a:cs typeface="Arial" pitchFamily="34" charset="-120"/>
+                        </a:rPr>
+                        <a:t>↳ Balance 20K+ today (29K)</a:t>
+                      </a:r>
+                      <a:endParaRPr lang="en-US" sz="1000" dirty="0">
+                        <a:latin typeface="Arial" charset="0"/>
+                        <a:ea typeface="Arial" charset="0"/>
+                        <a:cs typeface="Arial" charset="0"/>
+                      </a:endParaRPr>
+                    </a:p>
+                  </a:txBody>
+                  <a:tcPr marL="54864" marR="54864" marT="36576" marB="36576" anchor="ctr">
+                    <a:lnL w="19050" cap="flat" cmpd="sng" algn="ctr">
+                      <a:solidFill>
+                        <a:srgbClr val="FFFFFF"/>
+                      </a:solidFill>
+                      <a:prstDash val="solid"/>
+                      <a:round/>
+                      <a:headEnd type="none" w="med" len="med"/>
+                      <a:tailEnd type="none" w="med" len="med"/>
+                    </a:lnL>
+                    <a:lnR w="19050" cap="flat" cmpd="sng" algn="ctr">
+                      <a:solidFill>
+                        <a:srgbClr val="FFFFFF"/>
+                      </a:solidFill>
+                      <a:prstDash val="solid"/>
+                      <a:round/>
+                      <a:headEnd type="none" w="med" len="med"/>
+                      <a:tailEnd type="none" w="med" len="med"/>
+                    </a:lnR>
+                    <a:lnT w="19050" cap="flat" cmpd="sng" algn="ctr">
+                      <a:solidFill>
+                        <a:srgbClr val="FFFFFF"/>
+                      </a:solidFill>
+                      <a:prstDash val="solid"/>
+                      <a:round/>
+                      <a:headEnd type="none" w="med" len="med"/>
+                      <a:tailEnd type="none" w="med" len="med"/>
+                    </a:lnT>
+                    <a:lnB w="19050" cap="flat" cmpd="sng" algn="ctr">
+                      <a:solidFill>
+                        <a:srgbClr val="FFFFFF"/>
+                      </a:solidFill>
+                      <a:prstDash val="solid"/>
+                      <a:round/>
+                      <a:headEnd type="none" w="med" len="med"/>
+                      <a:tailEnd type="none" w="med" len="med"/>
+                    </a:lnB>
+                  </a:tcPr>
+                </a:tc>
+                <a:tc>
+                  <a:txBody>
+                    <a:bodyPr/>
+                    <a:lstStyle/>
+                    <a:p>
+                      <a:pPr algn="ctr" indent="0" marL="0">
+                        <a:buNone/>
+                      </a:pPr>
+                      <a:r>
+                        <a:rPr lang="en-US" sz="1000" dirty="0">
+                          <a:solidFill>
+                            <a:srgbClr val="5F6B76"/>
+                          </a:solidFill>
+                          <a:latin typeface="Arial" pitchFamily="34" charset="0"/>
+                          <a:ea typeface="Arial" pitchFamily="34" charset="-122"/>
+                          <a:cs typeface="Arial" pitchFamily="34" charset="-120"/>
+                        </a:rPr>
+                        <a:t>all</a:t>
+                      </a:r>
+                      <a:endParaRPr lang="en-US" sz="1000" dirty="0">
+                        <a:latin typeface="Arial" charset="0"/>
+                        <a:ea typeface="Arial" charset="0"/>
+                        <a:cs typeface="Arial" charset="0"/>
+                      </a:endParaRPr>
+                    </a:p>
+                  </a:txBody>
+                  <a:tcPr marL="54864" marR="54864" marT="36576" marB="36576" anchor="ctr">
+                    <a:lnL w="19050" cap="flat" cmpd="sng" algn="ctr">
+                      <a:solidFill>
+                        <a:srgbClr val="FFFFFF"/>
+                      </a:solidFill>
+                      <a:prstDash val="solid"/>
+                      <a:round/>
+                      <a:headEnd type="none" w="med" len="med"/>
+                      <a:tailEnd type="none" w="med" len="med"/>
+                    </a:lnL>
+                    <a:lnR w="19050" cap="flat" cmpd="sng" algn="ctr">
+                      <a:solidFill>
+                        <a:srgbClr val="FFFFFF"/>
+                      </a:solidFill>
+                      <a:prstDash val="solid"/>
+                      <a:round/>
+                      <a:headEnd type="none" w="med" len="med"/>
+                      <a:tailEnd type="none" w="med" len="med"/>
+                    </a:lnR>
+                    <a:lnT w="19050" cap="flat" cmpd="sng" algn="ctr">
+                      <a:solidFill>
+                        <a:srgbClr val="FFFFFF"/>
+                      </a:solidFill>
+                      <a:prstDash val="solid"/>
+                      <a:round/>
+                      <a:headEnd type="none" w="med" len="med"/>
+                      <a:tailEnd type="none" w="med" len="med"/>
+                    </a:lnT>
+                    <a:lnB w="19050" cap="flat" cmpd="sng" algn="ctr">
+                      <a:solidFill>
+                        <a:srgbClr val="FFFFFF"/>
+                      </a:solidFill>
+                      <a:prstDash val="solid"/>
+                      <a:round/>
+                      <a:headEnd type="none" w="med" len="med"/>
+                      <a:tailEnd type="none" w="med" len="med"/>
+                    </a:lnB>
+                  </a:tcPr>
+                </a:tc>
+                <a:tc>
+                  <a:txBody>
+                    <a:bodyPr/>
+                    <a:lstStyle/>
+                    <a:p>
+                      <a:pPr algn="ctr" indent="0" marL="0">
+                        <a:buNone/>
+                      </a:pPr>
+                      <a:r>
+                        <a:rPr lang="en-US" sz="1300" b="1" dirty="0">
+                          <a:solidFill>
+                            <a:srgbClr val="D9475C"/>
+                          </a:solidFill>
+                          <a:latin typeface="Arial" pitchFamily="34" charset="0"/>
+                          <a:ea typeface="Arial" pitchFamily="34" charset="-122"/>
+                          <a:cs typeface="Arial" pitchFamily="34" charset="-120"/>
+                        </a:rPr>
+                        <a:t>4%</a:t>
+                      </a:r>
+                      <a:endParaRPr lang="en-US" sz="1200" dirty="0">
+                        <a:latin typeface="Arial" charset="0"/>
+                        <a:ea typeface="Arial" charset="0"/>
+                        <a:cs typeface="Arial" charset="0"/>
+                      </a:endParaRPr>
+                    </a:p>
+                    <a:p>
+                      <a:pPr algn="ctr" indent="0" marL="0">
+                        <a:buNone/>
+                      </a:pPr>
+                      <a:r>
+                        <a:rPr lang="en-US" sz="950" dirty="0">
+                          <a:solidFill>
+                            <a:srgbClr val="D9475C"/>
+                          </a:solidFill>
+                          <a:latin typeface="Arial" pitchFamily="34" charset="0"/>
+                          <a:ea typeface="Arial" pitchFamily="34" charset="-122"/>
+                          <a:cs typeface="Arial" pitchFamily="34" charset="-120"/>
+                        </a:rPr>
+                        <a:t>0.4x as likely</a:t>
+                      </a:r>
+                      <a:endParaRPr lang="en-US" sz="1200" dirty="0">
+                        <a:latin typeface="Arial" charset="0"/>
+                        <a:ea typeface="Arial" charset="0"/>
+                        <a:cs typeface="Arial" charset="0"/>
+                      </a:endParaRPr>
+                    </a:p>
+                  </a:txBody>
+                  <a:tcPr marL="54864" marR="54864" marT="36576" marB="36576" anchor="ctr">
+                    <a:lnL w="19050" cap="flat" cmpd="sng" algn="ctr">
+                      <a:solidFill>
+                        <a:srgbClr val="FFFFFF"/>
+                      </a:solidFill>
+                      <a:prstDash val="solid"/>
+                      <a:round/>
+                      <a:headEnd type="none" w="med" len="med"/>
+                      <a:tailEnd type="none" w="med" len="med"/>
+                    </a:lnL>
+                    <a:lnR w="19050" cap="flat" cmpd="sng" algn="ctr">
+                      <a:solidFill>
+                        <a:srgbClr val="FFFFFF"/>
+                      </a:solidFill>
+                      <a:prstDash val="solid"/>
+                      <a:round/>
+                      <a:headEnd type="none" w="med" len="med"/>
+                      <a:tailEnd type="none" w="med" len="med"/>
+                    </a:lnR>
+                    <a:lnT w="19050" cap="flat" cmpd="sng" algn="ctr">
+                      <a:solidFill>
+                        <a:srgbClr val="FFFFFF"/>
+                      </a:solidFill>
+                      <a:prstDash val="solid"/>
+                      <a:round/>
+                      <a:headEnd type="none" w="med" len="med"/>
+                      <a:tailEnd type="none" w="med" len="med"/>
+                    </a:lnT>
+                    <a:lnB w="19050" cap="flat" cmpd="sng" algn="ctr">
+                      <a:solidFill>
+                        <a:srgbClr val="FFFFFF"/>
+                      </a:solidFill>
+                      <a:prstDash val="solid"/>
+                      <a:round/>
+                      <a:headEnd type="none" w="med" len="med"/>
+                      <a:tailEnd type="none" w="med" len="med"/>
+                    </a:lnB>
+                    <a:solidFill>
+                      <a:srgbClr val="F2F4F7"/>
+                    </a:solidFill>
+                  </a:tcPr>
+                </a:tc>
+                <a:tc>
+                  <a:txBody>
+                    <a:bodyPr/>
+                    <a:lstStyle/>
+                    <a:p>
+                      <a:pPr algn="ctr" indent="0" marL="0">
+                        <a:buNone/>
+                      </a:pPr>
+                      <a:r>
+                        <a:rPr lang="en-US" sz="1300" b="1" dirty="0">
+                          <a:solidFill>
+                            <a:srgbClr val="FFFFFF"/>
+                          </a:solidFill>
+                          <a:latin typeface="Arial" pitchFamily="34" charset="0"/>
+                          <a:ea typeface="Arial" pitchFamily="34" charset="-122"/>
+                          <a:cs typeface="Arial" pitchFamily="34" charset="-120"/>
+                        </a:rPr>
+                        <a:t>22%</a:t>
+                      </a:r>
+                      <a:endParaRPr lang="en-US" sz="1200" dirty="0">
+                        <a:latin typeface="Arial" charset="0"/>
+                        <a:ea typeface="Arial" charset="0"/>
+                        <a:cs typeface="Arial" charset="0"/>
+                      </a:endParaRPr>
+                    </a:p>
+                    <a:p>
+                      <a:pPr algn="ctr" indent="0" marL="0">
+                        <a:buNone/>
+                      </a:pPr>
+                      <a:r>
+                        <a:rPr lang="en-US" sz="950" dirty="0">
+                          <a:solidFill>
+                            <a:srgbClr val="FFFFFF"/>
+                          </a:solidFill>
+                          <a:latin typeface="Arial" pitchFamily="34" charset="0"/>
+                          <a:ea typeface="Arial" pitchFamily="34" charset="-122"/>
+                          <a:cs typeface="Arial" pitchFamily="34" charset="-120"/>
+                        </a:rPr>
+                        <a:t>2.8x more likely</a:t>
+                      </a:r>
+                      <a:endParaRPr lang="en-US" sz="1200" dirty="0">
+                        <a:latin typeface="Arial" charset="0"/>
+                        <a:ea typeface="Arial" charset="0"/>
+                        <a:cs typeface="Arial" charset="0"/>
+                      </a:endParaRPr>
+                    </a:p>
+                  </a:txBody>
+                  <a:tcPr marL="54864" marR="54864" marT="36576" marB="36576" anchor="ctr">
+                    <a:lnL w="19050" cap="flat" cmpd="sng" algn="ctr">
+                      <a:solidFill>
+                        <a:srgbClr val="FFFFFF"/>
+                      </a:solidFill>
+                      <a:prstDash val="solid"/>
+                      <a:round/>
+                      <a:headEnd type="none" w="med" len="med"/>
+                      <a:tailEnd type="none" w="med" len="med"/>
+                    </a:lnL>
+                    <a:lnR w="19050" cap="flat" cmpd="sng" algn="ctr">
+                      <a:solidFill>
+                        <a:srgbClr val="FFFFFF"/>
+                      </a:solidFill>
+                      <a:prstDash val="solid"/>
+                      <a:round/>
+                      <a:headEnd type="none" w="med" len="med"/>
+                      <a:tailEnd type="none" w="med" len="med"/>
+                    </a:lnR>
+                    <a:lnT w="19050" cap="flat" cmpd="sng" algn="ctr">
+                      <a:solidFill>
+                        <a:srgbClr val="FFFFFF"/>
+                      </a:solidFill>
+                      <a:prstDash val="solid"/>
+                      <a:round/>
+                      <a:headEnd type="none" w="med" len="med"/>
+                      <a:tailEnd type="none" w="med" len="med"/>
+                    </a:lnT>
+                    <a:lnB w="19050" cap="flat" cmpd="sng" algn="ctr">
+                      <a:solidFill>
+                        <a:srgbClr val="FFFFFF"/>
+                      </a:solidFill>
+                      <a:prstDash val="solid"/>
+                      <a:round/>
+                      <a:headEnd type="none" w="med" len="med"/>
+                      <a:tailEnd type="none" w="med" len="med"/>
+                    </a:lnB>
+                    <a:solidFill>
+                      <a:srgbClr val="2251FF"/>
+                    </a:solidFill>
+                  </a:tcPr>
+                </a:tc>
+              </a:tr>
+              <a:tr h="548640">
                 <a:tc>
                   <a:txBody>
                     <a:bodyPr/>
@@ -4683,12 +6076,12 @@
                       <a:tailEnd type="none" w="med" len="med"/>
                     </a:lnB>
                     <a:solidFill>
-                      <a:srgbClr val="2251FF"/>
+                      <a:srgbClr val="051C2C"/>
                     </a:solidFill>
                   </a:tcPr>
                 </a:tc>
               </a:tr>
-              <a:tr h="777240">
+              <a:tr h="548640">
                 <a:tc>
                   <a:txBody>
                     <a:bodyPr/>
@@ -4928,7 +6321,7 @@
                       <a:tailEnd type="none" w="med" len="med"/>
                     </a:lnB>
                     <a:solidFill>
-                      <a:srgbClr val="2251FF"/>
+                      <a:srgbClr val="051C2C"/>
                     </a:solidFill>
                   </a:tcPr>
                 </a:tc>
@@ -5896,7 +7289,7 @@
                   <a:schemeClr val="tx2"/>
                 </a:solidFill>
               </a:rPr>
-              <a:t>The chain breaks at step one</a:t>
+              <a:t>Savers pay, but rarely borrow</a:t>
             </a:r>
             <a:endParaRPr lang="en-US" sz="1400" dirty="0"/>
           </a:p>
@@ -5913,7 +7306,7 @@
                   <a:schemeClr val="tx1"/>
                 </a:solidFill>
               </a:rPr>
-              <a:t>Only 35% of accounts ever get money in, yet 99% of payers have. Money in comes first</a:t>
+              <a:t>35% of customers with 1K+ pay with CLICX (4.5x), but only 4% with 20K+ have a loan. They need a different offer</a:t>
             </a:r>
             <a:endParaRPr lang="en-US" sz="1400" dirty="0"/>
           </a:p>
@@ -6008,7 +7401,7 @@
                   <a:schemeClr val="tx2"/>
                 </a:solidFill>
               </a:rPr>
-              <a:t>Main-bank status isn't tracked</a:t>
+              <a:t>The chain breaks at step one</a:t>
             </a:r>
             <a:endParaRPr lang="en-US" sz="1400" dirty="0"/>
           </a:p>
@@ -6025,7 +7418,7 @@
                   <a:schemeClr val="tx1"/>
                 </a:solidFill>
               </a:rPr>
-              <a:t>Main bank = regular income in and regular payments out. Add an income flag to track it</a:t>
+              <a:t>Only 35% of accounts ever get money in, yet 99% of payers have. Money in comes first</a:t>
             </a:r>
             <a:endParaRPr lang="en-US" sz="1400" dirty="0"/>
           </a:p>
@@ -6133,7 +7526,7 @@
                   <a:schemeClr val="accent1"/>
                 </a:solidFill>
               </a:rPr>
-              <a:t>BOARD SUMMARY  (3/3)  |  WHAT WE WILL DO</a:t>
+              <a:t>BOARD SUMMARY  (3/4)  |  BALANCE AND USE</a:t>
             </a:r>
             <a:endParaRPr lang="en-US" sz="1100" dirty="0"/>
           </a:p>
@@ -6171,7 +7564,7 @@
                   <a:schemeClr val="tx2"/>
                 </a:solidFill>
               </a:rPr>
-              <a:t>What can we do in the next 90 days, and what do we need from the board?</a:t>
+              <a:t>Does how much money customers keep with us change what else they do?</a:t>
             </a:r>
             <a:endParaRPr lang="en-US" sz="2400" dirty="0"/>
           </a:p>
@@ -6209,7 +7602,7 @@
                   <a:schemeClr val="tx1"/>
                 </a:solidFill>
               </a:rPr>
-              <a:t>Six actions aimed at customers we already have: get money in, bring loan payments into the app, and keep payers from dropping off</a:t>
+              <a:t>Yes. Payments peak among customers keeping 1K–20K (44% pay), while big savers (20K+) pay less and rarely borrow. The 1.14M with a zero balance barely use anything</a:t>
             </a:r>
             <a:endParaRPr lang="en-US" sz="1600" dirty="0"/>
           </a:p>
@@ -6247,6 +7640,652 @@
                   <a:srgbClr val="6E7C87"/>
                 </a:solidFill>
               </a:rPr>
+              <a:t>Balance = current total balance, 1 Oct 2026. Zero and under-1K figures are estimates from rounded shares in the source; 1K+ figures are exact. A 100-baht cut is not in the data yet. Source: CLICX product and payment segments</a:t>
+            </a:r>
+            <a:endParaRPr lang="en-US" sz="1000" dirty="0"/>
+          </a:p>
+        </p:txBody>
+      </p:sp>
+      <p:graphicFrame>
+        <p:nvGraphicFramePr>
+          <p:cNvPr id="6" name="Use by balance band" descr=""/>
+          <p:cNvGraphicFramePr/>
+          <p:nvPr/>
+        </p:nvGraphicFramePr>
+        <p:xfrm>
+          <a:off x="457200" y="2148840"/>
+          <a:ext cx="4846320" cy="3977640"/>
+        </p:xfrm>
+        <a:graphic xmlns:a="http://schemas.openxmlformats.org/drawingml/2006/main">
+          <a:graphicData uri="http://schemas.openxmlformats.org/drawingml/2006/chart">
+            <c:chart xmlns:c="http://schemas.openxmlformats.org/drawingml/2006/chart" r:id="rId1"/>
+          </a:graphicData>
+        </a:graphic>
+      </p:graphicFrame>
+      <p:graphicFrame>
+        <p:nvGraphicFramePr>
+          <p:cNvPr id="7" name="Customers by balance band" descr=""/>
+          <p:cNvGraphicFramePr/>
+          <p:nvPr/>
+        </p:nvGraphicFramePr>
+        <p:xfrm>
+          <a:off x="5394960" y="2148840"/>
+          <a:ext cx="2743200" cy="3977640"/>
+        </p:xfrm>
+        <a:graphic xmlns:a="http://schemas.openxmlformats.org/drawingml/2006/main">
+          <a:graphicData uri="http://schemas.openxmlformats.org/drawingml/2006/chart">
+            <c:chart xmlns:c="http://schemas.openxmlformats.org/drawingml/2006/chart" r:id="rId2"/>
+          </a:graphicData>
+        </a:graphic>
+      </p:graphicFrame>
+      <p:sp>
+        <p:nvSpPr>
+          <p:cNvPr id="8" name="Insight panel"/>
+          <p:cNvSpPr/>
+          <p:nvPr/>
+        </p:nvSpPr>
+        <p:spPr>
+          <a:xfrm>
+            <a:off x="8275320" y="2148840"/>
+            <a:ext cx="3456432" cy="3977640"/>
+          </a:xfrm>
+          <a:prstGeom prst="rect">
+            <a:avLst/>
+          </a:prstGeom>
+          <a:solidFill>
+            <a:schemeClr val="bg2"/>
+          </a:solidFill>
+          <a:ln/>
+        </p:spPr>
+      </p:sp>
+      <p:sp>
+        <p:nvSpPr>
+          <p:cNvPr id="9" name="Insight header"/>
+          <p:cNvSpPr txBox="1"/>
+          <p:nvPr/>
+        </p:nvSpPr>
+        <p:spPr>
+          <a:xfrm>
+            <a:off x="8503920" y="2313432"/>
+            <a:ext cx="2999232" cy="274320"/>
+          </a:xfrm>
+          <a:prstGeom prst="rect">
+            <a:avLst/>
+          </a:prstGeom>
+          <a:noFill/>
+          <a:ln/>
+        </p:spPr>
+        <p:txBody>
+          <a:bodyPr wrap="square" lIns="0" tIns="0" rIns="0" bIns="0" rtlCol="0" anchor="ctr"/>
+          <a:lstStyle/>
+          <a:p>
+            <a:pPr indent="0" marL="0">
+              <a:buNone/>
+            </a:pPr>
+            <a:r>
+              <a:rPr lang="en-US" sz="1100" b="1" spc="100" kern="0" dirty="0">
+                <a:solidFill>
+                  <a:schemeClr val="accent1"/>
+                </a:solidFill>
+              </a:rPr>
+              <a:t>WHAT IT MEANS</a:t>
+            </a:r>
+            <a:endParaRPr lang="en-US" sz="1100" dirty="0"/>
+          </a:p>
+        </p:txBody>
+      </p:sp>
+      <p:sp>
+        <p:nvSpPr>
+          <p:cNvPr id="10" name="Badge 1"/>
+          <p:cNvSpPr/>
+          <p:nvPr/>
+        </p:nvSpPr>
+        <p:spPr>
+          <a:xfrm>
+            <a:off x="8503920" y="2715768"/>
+            <a:ext cx="292608" cy="292608"/>
+          </a:xfrm>
+          <a:prstGeom prst="ellipse">
+            <a:avLst/>
+          </a:prstGeom>
+          <a:solidFill>
+            <a:schemeClr val="tx2"/>
+          </a:solidFill>
+          <a:ln/>
+        </p:spPr>
+      </p:sp>
+      <p:sp>
+        <p:nvSpPr>
+          <p:cNvPr id="11" name="Badge num 1"/>
+          <p:cNvSpPr txBox="1"/>
+          <p:nvPr/>
+        </p:nvSpPr>
+        <p:spPr>
+          <a:xfrm>
+            <a:off x="8503920" y="2715768"/>
+            <a:ext cx="292608" cy="292608"/>
+          </a:xfrm>
+          <a:prstGeom prst="rect">
+            <a:avLst/>
+          </a:prstGeom>
+          <a:noFill/>
+          <a:ln/>
+        </p:spPr>
+        <p:txBody>
+          <a:bodyPr wrap="square" lIns="0" tIns="0" rIns="0" bIns="0" rtlCol="0" anchor="ctr"/>
+          <a:lstStyle/>
+          <a:p>
+            <a:pPr algn="ctr" indent="0" marL="0">
+              <a:buNone/>
+            </a:pPr>
+            <a:r>
+              <a:rPr lang="en-US" sz="1100" b="1" dirty="0">
+                <a:solidFill>
+                  <a:schemeClr val="bg1"/>
+                </a:solidFill>
+              </a:rPr>
+              <a:t>1</a:t>
+            </a:r>
+            <a:endParaRPr lang="en-US" sz="1100" dirty="0"/>
+          </a:p>
+        </p:txBody>
+      </p:sp>
+      <p:sp>
+        <p:nvSpPr>
+          <p:cNvPr id="12" name="Insight 1"/>
+          <p:cNvSpPr txBox="1"/>
+          <p:nvPr/>
+        </p:nvSpPr>
+        <p:spPr>
+          <a:xfrm>
+            <a:off x="8915400" y="2670048"/>
+            <a:ext cx="2633472" cy="1054608"/>
+          </a:xfrm>
+          <a:prstGeom prst="rect">
+            <a:avLst/>
+          </a:prstGeom>
+          <a:noFill/>
+          <a:ln/>
+        </p:spPr>
+        <p:txBody>
+          <a:bodyPr wrap="square" lIns="0" tIns="0" rIns="0" bIns="0" rtlCol="0" anchor="t"/>
+          <a:lstStyle/>
+          <a:p>
+            <a:pPr indent="0" marL="0">
+              <a:spcAft>
+                <a:spcPts val="300"/>
+              </a:spcAft>
+              <a:buNone/>
+            </a:pPr>
+            <a:r>
+              <a:rPr lang="en-US" sz="1400" b="1" dirty="0">
+                <a:solidFill>
+                  <a:schemeClr val="tx2"/>
+                </a:solidFill>
+              </a:rPr>
+              <a:t>Small balances follow loans</a:t>
+            </a:r>
+            <a:endParaRPr lang="en-US" sz="1400" dirty="0"/>
+          </a:p>
+          <a:p>
+            <a:pPr indent="0" marL="0">
+              <a:spcAft>
+                <a:spcPts val="300"/>
+              </a:spcAft>
+              <a:buNone/>
+            </a:pPr>
+            <a:r>
+              <a:rPr lang="en-US" sz="1200" dirty="0">
+                <a:solidFill>
+                  <a:schemeClr val="tx1"/>
+                </a:solidFill>
+              </a:rPr>
+              <a:t>28% of customers holding under 1K have a loan, the highest of any group</a:t>
+            </a:r>
+            <a:endParaRPr lang="en-US" sz="1400" dirty="0"/>
+          </a:p>
+        </p:txBody>
+      </p:sp>
+      <p:sp>
+        <p:nvSpPr>
+          <p:cNvPr id="13" name="Badge 2"/>
+          <p:cNvSpPr/>
+          <p:nvPr/>
+        </p:nvSpPr>
+        <p:spPr>
+          <a:xfrm>
+            <a:off x="8503920" y="3843528"/>
+            <a:ext cx="292608" cy="292608"/>
+          </a:xfrm>
+          <a:prstGeom prst="ellipse">
+            <a:avLst/>
+          </a:prstGeom>
+          <a:solidFill>
+            <a:schemeClr val="tx2"/>
+          </a:solidFill>
+          <a:ln/>
+        </p:spPr>
+      </p:sp>
+      <p:sp>
+        <p:nvSpPr>
+          <p:cNvPr id="14" name="Badge num 2"/>
+          <p:cNvSpPr txBox="1"/>
+          <p:nvPr/>
+        </p:nvSpPr>
+        <p:spPr>
+          <a:xfrm>
+            <a:off x="8503920" y="3843528"/>
+            <a:ext cx="292608" cy="292608"/>
+          </a:xfrm>
+          <a:prstGeom prst="rect">
+            <a:avLst/>
+          </a:prstGeom>
+          <a:noFill/>
+          <a:ln/>
+        </p:spPr>
+        <p:txBody>
+          <a:bodyPr wrap="square" lIns="0" tIns="0" rIns="0" bIns="0" rtlCol="0" anchor="ctr"/>
+          <a:lstStyle/>
+          <a:p>
+            <a:pPr algn="ctr" indent="0" marL="0">
+              <a:buNone/>
+            </a:pPr>
+            <a:r>
+              <a:rPr lang="en-US" sz="1100" b="1" dirty="0">
+                <a:solidFill>
+                  <a:schemeClr val="bg1"/>
+                </a:solidFill>
+              </a:rPr>
+              <a:t>2</a:t>
+            </a:r>
+            <a:endParaRPr lang="en-US" sz="1100" dirty="0"/>
+          </a:p>
+        </p:txBody>
+      </p:sp>
+      <p:sp>
+        <p:nvSpPr>
+          <p:cNvPr id="15" name="Insight 2"/>
+          <p:cNvSpPr txBox="1"/>
+          <p:nvPr/>
+        </p:nvSpPr>
+        <p:spPr>
+          <a:xfrm>
+            <a:off x="8915400" y="3797808"/>
+            <a:ext cx="2633472" cy="1054608"/>
+          </a:xfrm>
+          <a:prstGeom prst="rect">
+            <a:avLst/>
+          </a:prstGeom>
+          <a:noFill/>
+          <a:ln/>
+        </p:spPr>
+        <p:txBody>
+          <a:bodyPr wrap="square" lIns="0" tIns="0" rIns="0" bIns="0" rtlCol="0" anchor="t"/>
+          <a:lstStyle/>
+          <a:p>
+            <a:pPr indent="0" marL="0">
+              <a:spcAft>
+                <a:spcPts val="300"/>
+              </a:spcAft>
+              <a:buNone/>
+            </a:pPr>
+            <a:r>
+              <a:rPr lang="en-US" sz="1400" b="1" dirty="0">
+                <a:solidFill>
+                  <a:schemeClr val="tx2"/>
+                </a:solidFill>
+              </a:rPr>
+              <a:t>1K–20K is the everyday sweet spot</a:t>
+            </a:r>
+            <a:endParaRPr lang="en-US" sz="1400" dirty="0"/>
+          </a:p>
+          <a:p>
+            <a:pPr indent="0" marL="0">
+              <a:spcAft>
+                <a:spcPts val="300"/>
+              </a:spcAft>
+              <a:buNone/>
+            </a:pPr>
+            <a:r>
+              <a:rPr lang="en-US" sz="1200" dirty="0">
+                <a:solidFill>
+                  <a:schemeClr val="tx1"/>
+                </a:solidFill>
+              </a:rPr>
+              <a:t>44% pay with CLICX, 6x the average. Grow this group from the 288K holding under 1K</a:t>
+            </a:r>
+            <a:endParaRPr lang="en-US" sz="1400" dirty="0"/>
+          </a:p>
+        </p:txBody>
+      </p:sp>
+      <p:sp>
+        <p:nvSpPr>
+          <p:cNvPr id="16" name="Badge 3"/>
+          <p:cNvSpPr/>
+          <p:nvPr/>
+        </p:nvSpPr>
+        <p:spPr>
+          <a:xfrm>
+            <a:off x="8503920" y="4971288"/>
+            <a:ext cx="292608" cy="292608"/>
+          </a:xfrm>
+          <a:prstGeom prst="ellipse">
+            <a:avLst/>
+          </a:prstGeom>
+          <a:solidFill>
+            <a:schemeClr val="tx2"/>
+          </a:solidFill>
+          <a:ln/>
+        </p:spPr>
+      </p:sp>
+      <p:sp>
+        <p:nvSpPr>
+          <p:cNvPr id="17" name="Badge num 3"/>
+          <p:cNvSpPr txBox="1"/>
+          <p:nvPr/>
+        </p:nvSpPr>
+        <p:spPr>
+          <a:xfrm>
+            <a:off x="8503920" y="4971288"/>
+            <a:ext cx="292608" cy="292608"/>
+          </a:xfrm>
+          <a:prstGeom prst="rect">
+            <a:avLst/>
+          </a:prstGeom>
+          <a:noFill/>
+          <a:ln/>
+        </p:spPr>
+        <p:txBody>
+          <a:bodyPr wrap="square" lIns="0" tIns="0" rIns="0" bIns="0" rtlCol="0" anchor="ctr"/>
+          <a:lstStyle/>
+          <a:p>
+            <a:pPr algn="ctr" indent="0" marL="0">
+              <a:buNone/>
+            </a:pPr>
+            <a:r>
+              <a:rPr lang="en-US" sz="1100" b="1" dirty="0">
+                <a:solidFill>
+                  <a:schemeClr val="bg1"/>
+                </a:solidFill>
+              </a:rPr>
+              <a:t>3</a:t>
+            </a:r>
+            <a:endParaRPr lang="en-US" sz="1100" dirty="0"/>
+          </a:p>
+        </p:txBody>
+      </p:sp>
+      <p:sp>
+        <p:nvSpPr>
+          <p:cNvPr id="18" name="Insight 3"/>
+          <p:cNvSpPr txBox="1"/>
+          <p:nvPr/>
+        </p:nvSpPr>
+        <p:spPr>
+          <a:xfrm>
+            <a:off x="8915400" y="4925568"/>
+            <a:ext cx="2633472" cy="1054608"/>
+          </a:xfrm>
+          <a:prstGeom prst="rect">
+            <a:avLst/>
+          </a:prstGeom>
+          <a:noFill/>
+          <a:ln/>
+        </p:spPr>
+        <p:txBody>
+          <a:bodyPr wrap="square" lIns="0" tIns="0" rIns="0" bIns="0" rtlCol="0" anchor="t"/>
+          <a:lstStyle/>
+          <a:p>
+            <a:pPr indent="0" marL="0">
+              <a:spcAft>
+                <a:spcPts val="300"/>
+              </a:spcAft>
+              <a:buNone/>
+            </a:pPr>
+            <a:r>
+              <a:rPr lang="en-US" sz="1400" b="1" dirty="0">
+                <a:solidFill>
+                  <a:schemeClr val="tx2"/>
+                </a:solidFill>
+              </a:rPr>
+              <a:t>Big savers want a savings home</a:t>
+            </a:r>
+            <a:endParaRPr lang="en-US" sz="1400" dirty="0"/>
+          </a:p>
+          <a:p>
+            <a:pPr indent="0" marL="0">
+              <a:spcAft>
+                <a:spcPts val="300"/>
+              </a:spcAft>
+              <a:buNone/>
+            </a:pPr>
+            <a:r>
+              <a:rPr lang="en-US" sz="1200" dirty="0">
+                <a:solidFill>
+                  <a:schemeClr val="tx1"/>
+                </a:solidFill>
+              </a:rPr>
+              <a:t>20K+ customers rarely borrow (4%). Offer savings and rewards, not loans</a:t>
+            </a:r>
+            <a:endParaRPr lang="en-US" sz="1400" dirty="0"/>
+          </a:p>
+        </p:txBody>
+      </p:sp>
+      <p:sp>
+        <p:nvSpPr>
+          <p:cNvPr id="25" name="Slide Number Placeholder 0"/>
+          <p:cNvSpPr>
+            <a:spLocks noGrp="1"/>
+          </p:cNvSpPr>
+          <p:nvPr>
+            <p:ph type="sldNum" sz="quarter" idx="4294967295"/>
+          </p:nvPr>
+        </p:nvSpPr>
+        <p:spPr>
+          <a:xfrm>
+            <a:off x="11274552" y="6355080"/>
+            <a:ext cx="457200" cy="274320"/>
+          </a:xfrm>
+          <a:prstGeom prst="rect">
+            <a:avLst/>
+          </a:prstGeom>
+          <a:extLst>
+            <a:ext uri="{C572A759-6A51-4108-AA02-DFA0A04FC94B}">
+              <ma14:wrappingTextBoxFlag xmlns:ma14="http://schemas.microsoft.com/office/mac/drawingml/2011/main" val="0"/>
+            </a:ext>
+          </a:extLst>
+        </p:spPr>
+        <p:txBody>
+          <a:bodyPr/>
+          <a:lstStyle>
+            <a:lvl1pPr>
+              <a:defRPr sz="1000">
+                <a:solidFill>
+                  <a:srgbClr val="6E7C87"/>
+                </a:solidFill>
+              </a:defRPr>
+            </a:lvl1pPr>
+          </a:lstStyle>
+          <a:p>
+            <a:pPr algn="r"/>
+            <a:fld id="{F7021451-1387-4CA6-816F-3879F97B5CBC}" type="slidenum">
+              <a:rPr b="0" lang="en-US"/>
+              <a:t>3</a:t>
+            </a:fld>
+            <a:endParaRPr lang="en-US"/>
+          </a:p>
+        </p:txBody>
+      </p:sp>
+    </p:spTree>
+  </p:cSld>
+  <p:clrMapOvr>
+    <a:masterClrMapping/>
+  </p:clrMapOvr>
+</p:sld>
+</file>
+
+<file path=ppt/slides/slide4.xml><?xml version="1.0" encoding="utf-8"?>
+<p:sld xmlns:a="http://schemas.openxmlformats.org/drawingml/2006/main" xmlns:r="http://schemas.openxmlformats.org/officeDocument/2006/relationships" xmlns:p="http://schemas.openxmlformats.org/presentationml/2006/main">
+  <p:cSld name="Slide 4">
+    <p:spTree>
+      <p:nvGrpSpPr>
+        <p:cNvPr id="1" name=""/>
+        <p:cNvGrpSpPr/>
+        <p:nvPr/>
+      </p:nvGrpSpPr>
+      <p:grpSpPr>
+        <a:xfrm>
+          <a:off x="0" y="0"/>
+          <a:ext cx="0" cy="0"/>
+          <a:chOff x="0" y="0"/>
+          <a:chExt cx="0" cy="0"/>
+        </a:xfrm>
+      </p:grpSpPr>
+      <p:sp>
+        <p:nvSpPr>
+          <p:cNvPr id="2" name="Text 0"/>
+          <p:cNvSpPr/>
+          <p:nvPr>
+            <p:ph idx="100" type="body" hasCustomPrompt="1"/>
+          </p:nvPr>
+        </p:nvSpPr>
+        <p:spPr>
+          <a:xfrm>
+            <a:off x="457200" y="274320"/>
+            <a:ext cx="8229600" cy="274320"/>
+          </a:xfrm>
+          <a:prstGeom prst="rect">
+            <a:avLst/>
+          </a:prstGeom>
+          <a:noFill/>
+          <a:ln/>
+        </p:spPr>
+        <p:txBody>
+          <a:bodyPr wrap="square" lIns="0" tIns="0" rIns="0" bIns="0" rtlCol="0"/>
+          <a:lstStyle/>
+          <a:p>
+            <a:pPr indent="0" marL="0">
+              <a:buNone/>
+            </a:pPr>
+            <a:r>
+              <a:rPr lang="en-US" sz="1100" b="1" spc="100" kern="0" dirty="0">
+                <a:solidFill>
+                  <a:schemeClr val="accent1"/>
+                </a:solidFill>
+              </a:rPr>
+              <a:t>BOARD SUMMARY  (4/4)  |  WHAT WE WILL DO</a:t>
+            </a:r>
+            <a:endParaRPr lang="en-US" sz="1100" dirty="0"/>
+          </a:p>
+        </p:txBody>
+      </p:sp>
+      <p:sp>
+        <p:nvSpPr>
+          <p:cNvPr id="3" name="Text 0"/>
+          <p:cNvSpPr/>
+          <p:nvPr>
+            <p:ph idx="101" type="title" hasCustomPrompt="1"/>
+          </p:nvPr>
+        </p:nvSpPr>
+        <p:spPr>
+          <a:xfrm>
+            <a:off x="457200" y="566928"/>
+            <a:ext cx="11274552" cy="822960"/>
+          </a:xfrm>
+          <a:prstGeom prst="rect">
+            <a:avLst/>
+          </a:prstGeom>
+          <a:noFill/>
+          <a:ln/>
+        </p:spPr>
+        <p:txBody>
+          <a:bodyPr wrap="square" lIns="0" tIns="0" rIns="0" bIns="0" rtlCol="0" anchor="t"/>
+          <a:lstStyle/>
+          <a:p>
+            <a:pPr algn="l" indent="0" marL="0">
+              <a:buNone/>
+            </a:pPr>
+            <a:r>
+              <a:rPr lang="en-US" sz="2400" b="1" dirty="0">
+                <a:solidFill>
+                  <a:schemeClr val="tx2"/>
+                </a:solidFill>
+              </a:rPr>
+              <a:t>What can we do in the next 90 days, and what do we need from the board?</a:t>
+            </a:r>
+            <a:endParaRPr lang="en-US" sz="2400" dirty="0"/>
+          </a:p>
+        </p:txBody>
+      </p:sp>
+      <p:sp>
+        <p:nvSpPr>
+          <p:cNvPr id="4" name="Text 0"/>
+          <p:cNvSpPr/>
+          <p:nvPr>
+            <p:ph idx="102" type="body" hasCustomPrompt="1"/>
+          </p:nvPr>
+        </p:nvSpPr>
+        <p:spPr>
+          <a:xfrm>
+            <a:off x="457200" y="1481328"/>
+            <a:ext cx="11274552" cy="594360"/>
+          </a:xfrm>
+          <a:prstGeom prst="rect">
+            <a:avLst/>
+          </a:prstGeom>
+          <a:noFill/>
+          <a:ln/>
+        </p:spPr>
+        <p:txBody>
+          <a:bodyPr wrap="square" lIns="0" tIns="0" rIns="0" bIns="0" rtlCol="0" anchor="t"/>
+          <a:lstStyle/>
+          <a:p>
+            <a:pPr indent="0" marL="0">
+              <a:buNone/>
+            </a:pPr>
+            <a:r>
+              <a:rPr lang="en-US" sz="1600" dirty="0">
+                <a:solidFill>
+                  <a:schemeClr val="tx1"/>
+                </a:solidFill>
+              </a:rPr>
+              <a:t>Six actions aimed at customers we already have: get money in, bring loan payments into the app, and keep payers from dropping off</a:t>
+            </a:r>
+            <a:endParaRPr lang="en-US" sz="1600" dirty="0"/>
+          </a:p>
+        </p:txBody>
+      </p:sp>
+      <p:sp>
+        <p:nvSpPr>
+          <p:cNvPr id="5" name="Text 0"/>
+          <p:cNvSpPr/>
+          <p:nvPr>
+            <p:ph idx="103" type="body" hasCustomPrompt="1"/>
+          </p:nvPr>
+        </p:nvSpPr>
+        <p:spPr>
+          <a:xfrm>
+            <a:off x="457200" y="6327648"/>
+            <a:ext cx="10241280" cy="274320"/>
+          </a:xfrm>
+          <a:prstGeom prst="rect">
+            <a:avLst/>
+          </a:prstGeom>
+          <a:noFill/>
+          <a:ln/>
+        </p:spPr>
+        <p:txBody>
+          <a:bodyPr wrap="square" lIns="0" tIns="0" rIns="0" bIns="0" rtlCol="0" anchor="t"/>
+          <a:lstStyle/>
+          <a:p>
+            <a:pPr indent="0" marL="0">
+              <a:buNone/>
+            </a:pPr>
+            <a:r>
+              <a:rPr lang="en-US" sz="1000" dirty="0">
+                <a:solidFill>
+                  <a:srgbClr val="6E7C87"/>
+                </a:solidFill>
+              </a:rPr>
               <a:t>Source: CLICX product and payment segments, 1 Oct 2026 (1.50M customers with an account)</a:t>
             </a:r>
             <a:endParaRPr lang="en-US" sz="1000" dirty="0"/>
@@ -6255,7 +8294,7 @@
       </p:sp>
       <p:graphicFrame>
         <p:nvGraphicFramePr>
-          <p:cNvPr id="4" name="Action table"/>
+          <p:cNvPr id="5" name="Action table"/>
           <p:cNvGraphicFramePr>
             <a:graphicFrameLocks noGrp="1"/>
           </p:cNvGraphicFramePr>
@@ -8609,7 +10648,7 @@
             <a:pPr algn="r"/>
             <a:fld id="{F7021451-1387-4CA6-816F-3879F97B5CBC}" type="slidenum">
               <a:rPr b="0" lang="en-US"/>
-              <a:t>3</a:t>
+              <a:t>4</a:t>
             </a:fld>
             <a:endParaRPr lang="en-US"/>
           </a:p>

</xml_diff>